<commit_message>
some changes to final presentation
</commit_message>
<xml_diff>
--- a/report/Präsentation_final.pptx
+++ b/report/Präsentation_final.pptx
@@ -2369,10 +2369,18 @@
         <a:lstStyle/>
         <a:p>
           <a:r>
-            <a:rPr lang="en-GB" sz="1600" dirty="0"/>
+            <a:rPr lang="en-GB" sz="1600" b="1" i="1" dirty="0">
+              <a:solidFill>
+                <a:srgbClr val="FF0000"/>
+              </a:solidFill>
+            </a:rPr>
             <a:t>Creating a function to read the velocity of thrown punches/calculate it using the IMU-Data</a:t>
           </a:r>
-          <a:endParaRPr lang="en-US" sz="1600" dirty="0"/>
+          <a:endParaRPr lang="en-US" sz="1600" b="1" i="1" dirty="0">
+            <a:solidFill>
+              <a:srgbClr val="FF0000"/>
+            </a:solidFill>
+          </a:endParaRPr>
         </a:p>
       </dgm:t>
     </dgm:pt>
@@ -3998,10 +4006,18 @@
             <a:buNone/>
           </a:pPr>
           <a:r>
-            <a:rPr lang="en-GB" sz="1600" kern="1200" dirty="0"/>
+            <a:rPr lang="en-GB" sz="1600" b="1" i="1" kern="1200" dirty="0">
+              <a:solidFill>
+                <a:srgbClr val="FF0000"/>
+              </a:solidFill>
+            </a:rPr>
             <a:t>Creating a function to read the velocity of thrown punches/calculate it using the IMU-Data</a:t>
           </a:r>
-          <a:endParaRPr lang="en-US" sz="1600" kern="1200" dirty="0"/>
+          <a:endParaRPr lang="en-US" sz="1600" b="1" i="1" kern="1200" dirty="0">
+            <a:solidFill>
+              <a:srgbClr val="FF0000"/>
+            </a:solidFill>
+          </a:endParaRPr>
         </a:p>
       </dsp:txBody>
       <dsp:txXfrm>
@@ -6908,7 +6924,7 @@
           <a:p>
             <a:fld id="{34FDB5A7-DA16-4448-8282-3E19F6C995A7}" type="datetimeFigureOut">
               <a:rPr lang="de-AT" smtClean="0"/>
-              <a:t>21.02.2026</a:t>
+              <a:t>22.02.2026</a:t>
             </a:fld>
             <a:endParaRPr lang="de-AT"/>
           </a:p>
@@ -7393,8 +7409,1631 @@
           <a:lstStyle/>
           <a:p>
             <a:r>
-              <a:rPr lang="de-AT" dirty="0"/>
-              <a:t>Holz</a:t>
+              <a:rPr lang="de-AT" dirty="0" err="1"/>
+              <a:t>We</a:t>
+            </a:r>
+            <a:r>
+              <a:rPr lang="de-AT" dirty="0"/>
+              <a:t> ran </a:t>
+            </a:r>
+            <a:r>
+              <a:rPr lang="de-AT" dirty="0" err="1"/>
+              <a:t>into</a:t>
+            </a:r>
+            <a:r>
+              <a:rPr lang="de-AT" dirty="0"/>
+              <a:t> </a:t>
+            </a:r>
+            <a:r>
+              <a:rPr lang="de-AT" dirty="0" err="1"/>
+              <a:t>some</a:t>
+            </a:r>
+            <a:r>
+              <a:rPr lang="de-AT" dirty="0"/>
+              <a:t> </a:t>
+            </a:r>
+            <a:r>
+              <a:rPr lang="de-AT" dirty="0" err="1"/>
+              <a:t>problems</a:t>
+            </a:r>
+            <a:r>
+              <a:rPr lang="de-AT" dirty="0"/>
+              <a:t> </a:t>
+            </a:r>
+            <a:r>
+              <a:rPr lang="de-AT" dirty="0" err="1"/>
+              <a:t>along</a:t>
+            </a:r>
+            <a:r>
+              <a:rPr lang="de-AT" dirty="0"/>
+              <a:t> </a:t>
+            </a:r>
+            <a:r>
+              <a:rPr lang="de-AT" dirty="0" err="1"/>
+              <a:t>our</a:t>
+            </a:r>
+            <a:r>
+              <a:rPr lang="de-AT" dirty="0"/>
+              <a:t> </a:t>
+            </a:r>
+            <a:r>
+              <a:rPr lang="de-AT" dirty="0" err="1"/>
+              <a:t>jorney</a:t>
+            </a:r>
+            <a:r>
+              <a:rPr lang="de-AT" dirty="0"/>
+              <a:t>, </a:t>
+            </a:r>
+            <a:r>
+              <a:rPr lang="de-AT" dirty="0" err="1"/>
+              <a:t>some</a:t>
+            </a:r>
+            <a:r>
+              <a:rPr lang="de-AT" dirty="0"/>
+              <a:t> </a:t>
+            </a:r>
+            <a:r>
+              <a:rPr lang="de-AT" dirty="0" err="1"/>
+              <a:t>of</a:t>
+            </a:r>
+            <a:r>
+              <a:rPr lang="de-AT" dirty="0"/>
+              <a:t> </a:t>
+            </a:r>
+            <a:r>
+              <a:rPr lang="de-AT" dirty="0" err="1"/>
+              <a:t>which</a:t>
+            </a:r>
+            <a:r>
+              <a:rPr lang="de-AT" dirty="0"/>
+              <a:t> i </a:t>
+            </a:r>
+            <a:r>
+              <a:rPr lang="de-AT" dirty="0" err="1"/>
+              <a:t>would</a:t>
+            </a:r>
+            <a:r>
+              <a:rPr lang="de-AT" dirty="0"/>
+              <a:t> like </a:t>
+            </a:r>
+            <a:r>
+              <a:rPr lang="de-AT" dirty="0" err="1"/>
+              <a:t>to</a:t>
+            </a:r>
+            <a:r>
+              <a:rPr lang="de-AT" dirty="0"/>
+              <a:t> </a:t>
+            </a:r>
+            <a:r>
+              <a:rPr lang="de-AT" dirty="0" err="1"/>
+              <a:t>talk</a:t>
+            </a:r>
+            <a:r>
+              <a:rPr lang="de-AT" dirty="0"/>
+              <a:t> </a:t>
+            </a:r>
+            <a:r>
+              <a:rPr lang="de-AT" dirty="0" err="1"/>
+              <a:t>about</a:t>
+            </a:r>
+            <a:r>
+              <a:rPr lang="de-AT" dirty="0"/>
+              <a:t>.</a:t>
+            </a:r>
+          </a:p>
+          <a:p>
+            <a:endParaRPr lang="de-AT" dirty="0"/>
+          </a:p>
+          <a:p>
+            <a:r>
+              <a:rPr lang="de-AT" dirty="0" err="1"/>
+              <a:t>One</a:t>
+            </a:r>
+            <a:r>
+              <a:rPr lang="de-AT" dirty="0"/>
+              <a:t> </a:t>
+            </a:r>
+            <a:r>
+              <a:rPr lang="de-AT" dirty="0" err="1"/>
+              <a:t>problem</a:t>
+            </a:r>
+            <a:r>
+              <a:rPr lang="de-AT" dirty="0"/>
+              <a:t> </a:t>
+            </a:r>
+            <a:r>
+              <a:rPr lang="de-AT" dirty="0" err="1"/>
+              <a:t>we</a:t>
+            </a:r>
+            <a:r>
+              <a:rPr lang="de-AT" dirty="0"/>
+              <a:t> </a:t>
+            </a:r>
+            <a:r>
+              <a:rPr lang="de-AT" dirty="0" err="1"/>
+              <a:t>faced</a:t>
+            </a:r>
+            <a:r>
+              <a:rPr lang="de-AT" dirty="0"/>
+              <a:t> </a:t>
+            </a:r>
+            <a:r>
+              <a:rPr lang="de-AT" dirty="0" err="1"/>
+              <a:t>were</a:t>
+            </a:r>
+            <a:r>
+              <a:rPr lang="de-AT" dirty="0"/>
+              <a:t> </a:t>
+            </a:r>
+            <a:r>
+              <a:rPr lang="de-AT" dirty="0" err="1"/>
+              <a:t>overlapping</a:t>
+            </a:r>
+            <a:r>
+              <a:rPr lang="de-AT" dirty="0"/>
+              <a:t> </a:t>
+            </a:r>
+            <a:r>
+              <a:rPr lang="de-AT" dirty="0" err="1"/>
+              <a:t>labels</a:t>
+            </a:r>
+            <a:r>
+              <a:rPr lang="de-AT" dirty="0"/>
+              <a:t>, </a:t>
+            </a:r>
+            <a:r>
+              <a:rPr lang="de-AT" dirty="0" err="1"/>
+              <a:t>which</a:t>
+            </a:r>
+            <a:r>
+              <a:rPr lang="de-AT" dirty="0"/>
+              <a:t> </a:t>
+            </a:r>
+            <a:r>
+              <a:rPr lang="de-AT" dirty="0" err="1"/>
+              <a:t>were</a:t>
+            </a:r>
+            <a:r>
+              <a:rPr lang="de-AT" dirty="0"/>
+              <a:t> </a:t>
+            </a:r>
+            <a:r>
+              <a:rPr lang="de-AT" dirty="0" err="1"/>
+              <a:t>sometimes</a:t>
+            </a:r>
+            <a:r>
+              <a:rPr lang="de-AT" dirty="0"/>
+              <a:t> </a:t>
+            </a:r>
+            <a:r>
+              <a:rPr lang="de-AT" dirty="0" err="1"/>
+              <a:t>generated</a:t>
+            </a:r>
+            <a:r>
+              <a:rPr lang="de-AT" dirty="0"/>
+              <a:t> </a:t>
+            </a:r>
+            <a:r>
+              <a:rPr lang="de-AT" dirty="0" err="1"/>
+              <a:t>by</a:t>
+            </a:r>
+            <a:r>
+              <a:rPr lang="de-AT" dirty="0"/>
+              <a:t> </a:t>
+            </a:r>
+            <a:r>
+              <a:rPr lang="de-AT" dirty="0" err="1"/>
+              <a:t>Deepcraft</a:t>
+            </a:r>
+            <a:r>
+              <a:rPr lang="de-AT" dirty="0"/>
+              <a:t> Studio </a:t>
+            </a:r>
+            <a:r>
+              <a:rPr lang="de-AT" dirty="0" err="1"/>
+              <a:t>while</a:t>
+            </a:r>
+            <a:r>
+              <a:rPr lang="de-AT" dirty="0"/>
+              <a:t> </a:t>
+            </a:r>
+            <a:r>
+              <a:rPr lang="de-AT" dirty="0" err="1"/>
+              <a:t>setting</a:t>
+            </a:r>
+            <a:r>
+              <a:rPr lang="de-AT" dirty="0"/>
+              <a:t> a </a:t>
+            </a:r>
+            <a:r>
+              <a:rPr lang="de-AT" dirty="0" err="1"/>
+              <a:t>label</a:t>
+            </a:r>
+            <a:r>
+              <a:rPr lang="de-AT" dirty="0"/>
+              <a:t> in </a:t>
+            </a:r>
+            <a:r>
+              <a:rPr lang="de-AT" dirty="0" err="1"/>
+              <a:t>the</a:t>
+            </a:r>
+            <a:r>
+              <a:rPr lang="de-AT" dirty="0"/>
+              <a:t> </a:t>
+            </a:r>
+            <a:r>
+              <a:rPr lang="de-AT" dirty="0" err="1"/>
+              <a:t>session</a:t>
+            </a:r>
+            <a:r>
+              <a:rPr lang="de-AT" dirty="0"/>
+              <a:t>. These </a:t>
+            </a:r>
+            <a:r>
+              <a:rPr lang="de-AT" dirty="0" err="1"/>
+              <a:t>had</a:t>
+            </a:r>
+            <a:r>
+              <a:rPr lang="de-AT" dirty="0"/>
+              <a:t> </a:t>
+            </a:r>
+            <a:r>
+              <a:rPr lang="de-AT" dirty="0" err="1"/>
+              <a:t>to</a:t>
+            </a:r>
+            <a:r>
+              <a:rPr lang="de-AT" dirty="0"/>
+              <a:t> </a:t>
+            </a:r>
+            <a:r>
+              <a:rPr lang="de-AT" dirty="0" err="1"/>
+              <a:t>be</a:t>
+            </a:r>
+            <a:r>
+              <a:rPr lang="de-AT" dirty="0"/>
+              <a:t> </a:t>
+            </a:r>
+            <a:r>
+              <a:rPr lang="de-AT" dirty="0" err="1"/>
+              <a:t>found</a:t>
+            </a:r>
+            <a:r>
+              <a:rPr lang="de-AT" dirty="0"/>
+              <a:t> and </a:t>
+            </a:r>
+            <a:r>
+              <a:rPr lang="de-AT" dirty="0" err="1"/>
+              <a:t>deleted</a:t>
+            </a:r>
+            <a:r>
+              <a:rPr lang="de-AT" dirty="0"/>
+              <a:t> in </a:t>
+            </a:r>
+            <a:r>
+              <a:rPr lang="de-AT" dirty="0" err="1"/>
+              <a:t>the</a:t>
+            </a:r>
+            <a:r>
+              <a:rPr lang="de-AT" dirty="0"/>
+              <a:t> </a:t>
+            </a:r>
+            <a:r>
+              <a:rPr lang="de-AT" dirty="0" err="1"/>
+              <a:t>classification</a:t>
+            </a:r>
+            <a:endParaRPr lang="de-AT" dirty="0"/>
+          </a:p>
+          <a:p>
+            <a:endParaRPr lang="de-AT" dirty="0"/>
+          </a:p>
+          <a:p>
+            <a:r>
+              <a:rPr lang="de-AT" dirty="0" err="1"/>
+              <a:t>Furthermore</a:t>
+            </a:r>
+            <a:r>
+              <a:rPr lang="de-AT" dirty="0"/>
+              <a:t> </a:t>
+            </a:r>
+            <a:r>
+              <a:rPr lang="de-AT" dirty="0" err="1"/>
+              <a:t>while</a:t>
+            </a:r>
+            <a:r>
+              <a:rPr lang="de-AT" dirty="0"/>
+              <a:t> </a:t>
+            </a:r>
+            <a:r>
+              <a:rPr lang="de-AT" dirty="0" err="1"/>
+              <a:t>playing</a:t>
+            </a:r>
+            <a:r>
+              <a:rPr lang="de-AT" dirty="0"/>
+              <a:t> </a:t>
+            </a:r>
+            <a:r>
+              <a:rPr lang="de-AT" dirty="0" err="1"/>
+              <a:t>around</a:t>
+            </a:r>
+            <a:r>
+              <a:rPr lang="de-AT" dirty="0"/>
+              <a:t> </a:t>
+            </a:r>
+            <a:r>
+              <a:rPr lang="de-AT" dirty="0" err="1"/>
+              <a:t>with</a:t>
+            </a:r>
+            <a:r>
+              <a:rPr lang="de-AT" dirty="0"/>
+              <a:t> </a:t>
+            </a:r>
+            <a:r>
+              <a:rPr lang="de-AT" dirty="0" err="1"/>
+              <a:t>model</a:t>
+            </a:r>
+            <a:r>
+              <a:rPr lang="de-AT" dirty="0"/>
+              <a:t> </a:t>
+            </a:r>
+            <a:r>
+              <a:rPr lang="de-AT" dirty="0" err="1"/>
+              <a:t>paramteres</a:t>
+            </a:r>
+            <a:r>
+              <a:rPr lang="de-AT" dirty="0"/>
+              <a:t> </a:t>
+            </a:r>
+            <a:r>
+              <a:rPr lang="de-AT" dirty="0" err="1"/>
+              <a:t>we</a:t>
+            </a:r>
+            <a:r>
+              <a:rPr lang="de-AT" dirty="0"/>
+              <a:t> </a:t>
+            </a:r>
+            <a:r>
+              <a:rPr lang="de-AT" dirty="0" err="1"/>
+              <a:t>found</a:t>
+            </a:r>
+            <a:r>
+              <a:rPr lang="de-AT" dirty="0"/>
+              <a:t> </a:t>
+            </a:r>
+            <a:r>
+              <a:rPr lang="de-AT" dirty="0" err="1"/>
+              <a:t>ourselves</a:t>
+            </a:r>
+            <a:r>
+              <a:rPr lang="de-AT" dirty="0"/>
+              <a:t> not </a:t>
+            </a:r>
+            <a:r>
+              <a:rPr lang="de-AT" dirty="0" err="1"/>
+              <a:t>really</a:t>
+            </a:r>
+            <a:r>
+              <a:rPr lang="de-AT" dirty="0"/>
+              <a:t> </a:t>
+            </a:r>
+            <a:r>
+              <a:rPr lang="de-AT" dirty="0" err="1"/>
+              <a:t>knowing</a:t>
+            </a:r>
+            <a:r>
+              <a:rPr lang="de-AT" dirty="0"/>
+              <a:t> </a:t>
+            </a:r>
+            <a:r>
+              <a:rPr lang="de-AT" dirty="0" err="1"/>
+              <a:t>which</a:t>
+            </a:r>
+            <a:r>
+              <a:rPr lang="de-AT" dirty="0"/>
+              <a:t> </a:t>
+            </a:r>
+            <a:r>
+              <a:rPr lang="de-AT" dirty="0" err="1"/>
+              <a:t>paramters</a:t>
+            </a:r>
+            <a:r>
+              <a:rPr lang="de-AT" dirty="0"/>
+              <a:t> </a:t>
+            </a:r>
+            <a:r>
+              <a:rPr lang="de-AT" dirty="0" err="1"/>
+              <a:t>lead</a:t>
+            </a:r>
+            <a:r>
+              <a:rPr lang="de-AT" dirty="0"/>
+              <a:t> </a:t>
+            </a:r>
+            <a:r>
+              <a:rPr lang="de-AT" dirty="0" err="1"/>
+              <a:t>to</a:t>
+            </a:r>
+            <a:r>
+              <a:rPr lang="de-AT" dirty="0"/>
+              <a:t> </a:t>
+            </a:r>
+            <a:r>
+              <a:rPr lang="de-AT" dirty="0" err="1"/>
+              <a:t>better</a:t>
+            </a:r>
+            <a:r>
+              <a:rPr lang="de-AT" dirty="0"/>
+              <a:t> </a:t>
+            </a:r>
+            <a:r>
+              <a:rPr lang="de-AT" dirty="0" err="1"/>
+              <a:t>results</a:t>
+            </a:r>
+            <a:r>
+              <a:rPr lang="de-AT" dirty="0"/>
+              <a:t>, </a:t>
+            </a:r>
+            <a:r>
+              <a:rPr lang="de-AT" dirty="0" err="1"/>
+              <a:t>besides</a:t>
+            </a:r>
+            <a:r>
+              <a:rPr lang="de-AT" dirty="0"/>
+              <a:t> </a:t>
+            </a:r>
+            <a:r>
+              <a:rPr lang="de-AT" dirty="0" err="1"/>
+              <a:t>gathering</a:t>
+            </a:r>
+            <a:r>
+              <a:rPr lang="de-AT" dirty="0"/>
+              <a:t> </a:t>
+            </a:r>
+            <a:r>
+              <a:rPr lang="de-AT" dirty="0" err="1"/>
+              <a:t>more</a:t>
+            </a:r>
+            <a:r>
+              <a:rPr lang="de-AT" dirty="0"/>
+              <a:t> </a:t>
+            </a:r>
+            <a:r>
+              <a:rPr lang="de-AT" dirty="0" err="1"/>
+              <a:t>data</a:t>
+            </a:r>
+            <a:endParaRPr lang="de-AT" dirty="0"/>
+          </a:p>
+          <a:p>
+            <a:endParaRPr lang="de-AT" dirty="0"/>
+          </a:p>
+          <a:p>
+            <a:r>
+              <a:rPr lang="de-AT" dirty="0" err="1"/>
+              <a:t>When</a:t>
+            </a:r>
+            <a:r>
+              <a:rPr lang="de-AT" dirty="0"/>
+              <a:t> </a:t>
+            </a:r>
+            <a:r>
+              <a:rPr lang="de-AT" dirty="0" err="1"/>
+              <a:t>we</a:t>
+            </a:r>
+            <a:r>
+              <a:rPr lang="de-AT" dirty="0"/>
+              <a:t> </a:t>
+            </a:r>
+            <a:r>
+              <a:rPr lang="de-AT" dirty="0" err="1"/>
+              <a:t>implemented</a:t>
+            </a:r>
+            <a:r>
+              <a:rPr lang="de-AT" dirty="0"/>
+              <a:t> </a:t>
+            </a:r>
+            <a:r>
+              <a:rPr lang="de-AT" dirty="0" err="1"/>
+              <a:t>the</a:t>
+            </a:r>
+            <a:r>
+              <a:rPr lang="de-AT" dirty="0"/>
+              <a:t> Model in </a:t>
+            </a:r>
+            <a:r>
+              <a:rPr lang="de-AT" dirty="0" err="1"/>
+              <a:t>Micropython</a:t>
+            </a:r>
+            <a:r>
+              <a:rPr lang="de-AT" dirty="0"/>
+              <a:t> </a:t>
+            </a:r>
+            <a:r>
+              <a:rPr lang="de-AT" dirty="0" err="1"/>
+              <a:t>we</a:t>
+            </a:r>
+            <a:r>
+              <a:rPr lang="de-AT" dirty="0"/>
+              <a:t> </a:t>
+            </a:r>
+            <a:r>
+              <a:rPr lang="de-AT" dirty="0" err="1"/>
+              <a:t>had</a:t>
+            </a:r>
+            <a:r>
+              <a:rPr lang="de-AT" dirty="0"/>
+              <a:t> a </a:t>
+            </a:r>
+            <a:r>
+              <a:rPr lang="de-AT" dirty="0" err="1"/>
+              <a:t>model</a:t>
+            </a:r>
+            <a:r>
+              <a:rPr lang="de-AT" dirty="0"/>
+              <a:t> </a:t>
+            </a:r>
+            <a:r>
+              <a:rPr lang="de-AT" dirty="0" err="1"/>
+              <a:t>which</a:t>
+            </a:r>
+            <a:r>
+              <a:rPr lang="de-AT" dirty="0"/>
+              <a:t> </a:t>
+            </a:r>
+            <a:r>
+              <a:rPr lang="de-AT" dirty="0" err="1"/>
+              <a:t>used</a:t>
+            </a:r>
+            <a:r>
+              <a:rPr lang="de-AT" dirty="0"/>
+              <a:t> 400Hz IMU </a:t>
+            </a:r>
+            <a:r>
+              <a:rPr lang="de-AT" dirty="0" err="1"/>
+              <a:t>data</a:t>
+            </a:r>
+            <a:r>
+              <a:rPr lang="de-AT" dirty="0"/>
+              <a:t>, </a:t>
+            </a:r>
+            <a:r>
+              <a:rPr lang="de-AT" dirty="0" err="1"/>
+              <a:t>which</a:t>
+            </a:r>
+            <a:r>
+              <a:rPr lang="de-AT" dirty="0"/>
+              <a:t> </a:t>
+            </a:r>
+            <a:r>
+              <a:rPr lang="de-AT" dirty="0" err="1"/>
+              <a:t>we</a:t>
+            </a:r>
+            <a:r>
+              <a:rPr lang="de-AT" dirty="0"/>
+              <a:t> </a:t>
+            </a:r>
+            <a:r>
+              <a:rPr lang="de-AT" dirty="0" err="1"/>
+              <a:t>found</a:t>
+            </a:r>
+            <a:r>
+              <a:rPr lang="de-AT" dirty="0"/>
+              <a:t> out was </a:t>
+            </a:r>
+            <a:r>
+              <a:rPr lang="de-AT" dirty="0" err="1"/>
+              <a:t>very</a:t>
+            </a:r>
+            <a:r>
+              <a:rPr lang="de-AT" dirty="0"/>
+              <a:t> </a:t>
+            </a:r>
+            <a:r>
+              <a:rPr lang="de-AT" dirty="0" err="1"/>
+              <a:t>problematic</a:t>
+            </a:r>
+            <a:r>
+              <a:rPr lang="de-AT" dirty="0"/>
+              <a:t> </a:t>
+            </a:r>
+            <a:r>
+              <a:rPr lang="de-AT" dirty="0" err="1"/>
+              <a:t>because</a:t>
+            </a:r>
+            <a:r>
+              <a:rPr lang="de-AT" dirty="0"/>
+              <a:t> </a:t>
+            </a:r>
+            <a:r>
+              <a:rPr lang="de-AT" dirty="0" err="1"/>
+              <a:t>we</a:t>
+            </a:r>
+            <a:r>
+              <a:rPr lang="de-AT" dirty="0"/>
+              <a:t> </a:t>
+            </a:r>
+            <a:r>
+              <a:rPr lang="de-AT" dirty="0" err="1"/>
+              <a:t>werent</a:t>
+            </a:r>
+            <a:r>
+              <a:rPr lang="de-AT" dirty="0"/>
+              <a:t> </a:t>
+            </a:r>
+            <a:r>
+              <a:rPr lang="de-AT" dirty="0" err="1"/>
+              <a:t>able</a:t>
+            </a:r>
+            <a:r>
+              <a:rPr lang="de-AT" dirty="0"/>
+              <a:t> </a:t>
+            </a:r>
+            <a:r>
+              <a:rPr lang="de-AT" dirty="0" err="1"/>
+              <a:t>to</a:t>
+            </a:r>
+            <a:r>
+              <a:rPr lang="de-AT" dirty="0"/>
+              <a:t> </a:t>
+            </a:r>
+            <a:r>
+              <a:rPr lang="de-AT" dirty="0" err="1"/>
+              <a:t>enqueue</a:t>
+            </a:r>
+            <a:r>
+              <a:rPr lang="de-AT" dirty="0"/>
+              <a:t> </a:t>
+            </a:r>
+            <a:r>
+              <a:rPr lang="de-AT" dirty="0" err="1"/>
+              <a:t>the</a:t>
+            </a:r>
+            <a:r>
+              <a:rPr lang="de-AT" dirty="0"/>
+              <a:t> </a:t>
+            </a:r>
+            <a:r>
+              <a:rPr lang="de-AT" dirty="0" err="1"/>
+              <a:t>data</a:t>
+            </a:r>
+            <a:r>
+              <a:rPr lang="de-AT" dirty="0"/>
+              <a:t> fast </a:t>
+            </a:r>
+            <a:r>
+              <a:rPr lang="de-AT" dirty="0" err="1"/>
+              <a:t>enough</a:t>
+            </a:r>
+            <a:r>
+              <a:rPr lang="de-AT" dirty="0"/>
+              <a:t>. The fastest loop time </a:t>
+            </a:r>
+            <a:r>
+              <a:rPr lang="de-AT" dirty="0" err="1"/>
+              <a:t>we</a:t>
+            </a:r>
+            <a:r>
+              <a:rPr lang="de-AT" dirty="0"/>
+              <a:t> </a:t>
+            </a:r>
+            <a:r>
+              <a:rPr lang="de-AT" dirty="0" err="1"/>
+              <a:t>achieved</a:t>
+            </a:r>
+            <a:r>
+              <a:rPr lang="de-AT" dirty="0"/>
+              <a:t> </a:t>
+            </a:r>
+            <a:r>
+              <a:rPr lang="de-AT" dirty="0" err="1"/>
+              <a:t>were</a:t>
+            </a:r>
+            <a:r>
+              <a:rPr lang="de-AT" dirty="0"/>
+              <a:t> 3ms, </a:t>
+            </a:r>
+            <a:r>
+              <a:rPr lang="de-AT" dirty="0" err="1"/>
+              <a:t>which</a:t>
+            </a:r>
+            <a:r>
+              <a:rPr lang="de-AT" dirty="0"/>
+              <a:t> </a:t>
+            </a:r>
+            <a:r>
+              <a:rPr lang="de-AT" dirty="0" err="1"/>
+              <a:t>is</a:t>
+            </a:r>
+            <a:r>
+              <a:rPr lang="de-AT" dirty="0"/>
+              <a:t> half a </a:t>
+            </a:r>
+            <a:r>
+              <a:rPr lang="de-AT" dirty="0" err="1"/>
+              <a:t>ms</a:t>
+            </a:r>
+            <a:r>
+              <a:rPr lang="de-AT" dirty="0"/>
+              <a:t> off </a:t>
+            </a:r>
+            <a:r>
+              <a:rPr lang="de-AT" dirty="0" err="1"/>
+              <a:t>the</a:t>
+            </a:r>
+            <a:r>
+              <a:rPr lang="de-AT" dirty="0"/>
+              <a:t> </a:t>
+            </a:r>
+            <a:r>
+              <a:rPr lang="de-AT" dirty="0" err="1"/>
+              <a:t>desired</a:t>
+            </a:r>
+            <a:r>
+              <a:rPr lang="de-AT" dirty="0"/>
+              <a:t> 2,5ms/400Hz. </a:t>
+            </a:r>
+            <a:r>
+              <a:rPr lang="de-AT" dirty="0" err="1"/>
+              <a:t>Thats</a:t>
+            </a:r>
+            <a:r>
+              <a:rPr lang="de-AT" dirty="0"/>
+              <a:t> </a:t>
+            </a:r>
+            <a:r>
+              <a:rPr lang="de-AT" dirty="0" err="1"/>
+              <a:t>why</a:t>
+            </a:r>
+            <a:r>
+              <a:rPr lang="de-AT" dirty="0"/>
+              <a:t> </a:t>
+            </a:r>
+            <a:r>
+              <a:rPr lang="de-AT" dirty="0" err="1"/>
+              <a:t>we</a:t>
+            </a:r>
+            <a:r>
+              <a:rPr lang="de-AT" dirty="0"/>
+              <a:t> </a:t>
+            </a:r>
+            <a:r>
+              <a:rPr lang="de-AT" dirty="0" err="1"/>
+              <a:t>created</a:t>
+            </a:r>
+            <a:r>
+              <a:rPr lang="de-AT" dirty="0"/>
+              <a:t> an extra </a:t>
+            </a:r>
+            <a:r>
+              <a:rPr lang="de-AT" dirty="0" err="1"/>
+              <a:t>pythonscript</a:t>
+            </a:r>
+            <a:r>
+              <a:rPr lang="de-AT" dirty="0"/>
+              <a:t> </a:t>
+            </a:r>
+            <a:r>
+              <a:rPr lang="de-AT" dirty="0" err="1"/>
+              <a:t>to</a:t>
+            </a:r>
+            <a:r>
+              <a:rPr lang="de-AT" dirty="0"/>
+              <a:t> </a:t>
+            </a:r>
+            <a:r>
+              <a:rPr lang="de-AT" dirty="0" err="1"/>
+              <a:t>manually</a:t>
+            </a:r>
+            <a:r>
+              <a:rPr lang="de-AT" dirty="0"/>
+              <a:t> </a:t>
+            </a:r>
+            <a:r>
+              <a:rPr lang="de-AT" dirty="0" err="1"/>
+              <a:t>downsample</a:t>
+            </a:r>
+            <a:r>
+              <a:rPr lang="de-AT" dirty="0"/>
+              <a:t> </a:t>
+            </a:r>
+            <a:r>
+              <a:rPr lang="de-AT" dirty="0" err="1"/>
+              <a:t>the</a:t>
+            </a:r>
+            <a:r>
+              <a:rPr lang="de-AT" dirty="0"/>
+              <a:t> </a:t>
+            </a:r>
+            <a:r>
+              <a:rPr lang="de-AT" dirty="0" err="1"/>
+              <a:t>data</a:t>
+            </a:r>
+            <a:r>
+              <a:rPr lang="de-AT" dirty="0"/>
+              <a:t> </a:t>
+            </a:r>
+            <a:r>
+              <a:rPr lang="de-AT" dirty="0" err="1"/>
+              <a:t>files</a:t>
+            </a:r>
+            <a:r>
+              <a:rPr lang="de-AT" dirty="0"/>
+              <a:t> </a:t>
+            </a:r>
+            <a:r>
+              <a:rPr lang="de-AT" dirty="0" err="1"/>
+              <a:t>to</a:t>
+            </a:r>
+            <a:r>
+              <a:rPr lang="de-AT" dirty="0"/>
+              <a:t> 100Hz</a:t>
+            </a:r>
+          </a:p>
+          <a:p>
+            <a:endParaRPr lang="de-AT" dirty="0"/>
+          </a:p>
+          <a:p>
+            <a:r>
+              <a:rPr lang="de-AT" dirty="0" err="1"/>
+              <a:t>Furthermore</a:t>
+            </a:r>
+            <a:r>
+              <a:rPr lang="de-AT" dirty="0"/>
+              <a:t> in </a:t>
+            </a:r>
+            <a:r>
+              <a:rPr lang="de-AT" dirty="0" err="1"/>
+              <a:t>the</a:t>
+            </a:r>
+            <a:r>
+              <a:rPr lang="de-AT" dirty="0"/>
+              <a:t> </a:t>
+            </a:r>
+            <a:r>
+              <a:rPr lang="de-AT" dirty="0" err="1"/>
+              <a:t>main</a:t>
+            </a:r>
+            <a:r>
+              <a:rPr lang="de-AT" dirty="0"/>
+              <a:t> loop </a:t>
+            </a:r>
+            <a:r>
+              <a:rPr lang="de-AT" dirty="0" err="1"/>
+              <a:t>we</a:t>
+            </a:r>
+            <a:r>
+              <a:rPr lang="de-AT" dirty="0"/>
+              <a:t> </a:t>
+            </a:r>
+            <a:r>
+              <a:rPr lang="de-AT" dirty="0" err="1"/>
+              <a:t>encountered</a:t>
+            </a:r>
+            <a:r>
+              <a:rPr lang="de-AT" dirty="0"/>
+              <a:t> </a:t>
+            </a:r>
+            <a:r>
+              <a:rPr lang="de-AT" dirty="0" err="1"/>
+              <a:t>problems</a:t>
+            </a:r>
+            <a:r>
+              <a:rPr lang="de-AT" dirty="0"/>
+              <a:t> </a:t>
+            </a:r>
+            <a:r>
+              <a:rPr lang="de-AT" dirty="0" err="1"/>
+              <a:t>while</a:t>
+            </a:r>
+            <a:r>
+              <a:rPr lang="de-AT" dirty="0"/>
+              <a:t> </a:t>
+            </a:r>
+            <a:r>
+              <a:rPr lang="de-AT" dirty="0" err="1"/>
+              <a:t>timing</a:t>
+            </a:r>
+            <a:r>
+              <a:rPr lang="de-AT" dirty="0"/>
+              <a:t> </a:t>
+            </a:r>
+            <a:r>
+              <a:rPr lang="de-AT" dirty="0" err="1"/>
+              <a:t>the</a:t>
+            </a:r>
+            <a:r>
+              <a:rPr lang="de-AT" dirty="0"/>
+              <a:t> </a:t>
+            </a:r>
+            <a:r>
+              <a:rPr lang="de-AT" dirty="0" err="1"/>
+              <a:t>enqueueing</a:t>
+            </a:r>
+            <a:r>
+              <a:rPr lang="de-AT" dirty="0"/>
+              <a:t>/IMU </a:t>
+            </a:r>
+            <a:r>
+              <a:rPr lang="de-AT" dirty="0" err="1"/>
+              <a:t>data</a:t>
+            </a:r>
+            <a:r>
+              <a:rPr lang="de-AT" dirty="0"/>
+              <a:t> </a:t>
+            </a:r>
+            <a:r>
+              <a:rPr lang="de-AT" dirty="0" err="1"/>
+              <a:t>sampling</a:t>
+            </a:r>
+            <a:r>
+              <a:rPr lang="de-AT" dirty="0"/>
+              <a:t>. </a:t>
+            </a:r>
+            <a:r>
+              <a:rPr lang="de-AT" dirty="0" err="1"/>
+              <a:t>Using</a:t>
+            </a:r>
+            <a:r>
+              <a:rPr lang="de-AT" dirty="0"/>
+              <a:t> an </a:t>
+            </a:r>
+            <a:r>
+              <a:rPr lang="de-AT" dirty="0" err="1"/>
+              <a:t>if-selection</a:t>
+            </a:r>
+            <a:r>
+              <a:rPr lang="de-AT" dirty="0"/>
+              <a:t> and </a:t>
+            </a:r>
+            <a:r>
+              <a:rPr lang="de-AT" dirty="0" err="1"/>
+              <a:t>timing</a:t>
+            </a:r>
+            <a:r>
+              <a:rPr lang="de-AT" dirty="0"/>
+              <a:t> </a:t>
+            </a:r>
+            <a:r>
+              <a:rPr lang="de-AT" dirty="0" err="1"/>
+              <a:t>the</a:t>
+            </a:r>
+            <a:r>
+              <a:rPr lang="de-AT" dirty="0"/>
+              <a:t> </a:t>
+            </a:r>
+            <a:r>
+              <a:rPr lang="de-AT" dirty="0" err="1"/>
+              <a:t>delay</a:t>
+            </a:r>
+            <a:r>
+              <a:rPr lang="de-AT" dirty="0"/>
+              <a:t> </a:t>
+            </a:r>
+            <a:r>
+              <a:rPr lang="de-AT" dirty="0" err="1"/>
+              <a:t>lead</a:t>
+            </a:r>
+            <a:r>
+              <a:rPr lang="de-AT" dirty="0"/>
+              <a:t> </a:t>
+            </a:r>
+            <a:r>
+              <a:rPr lang="de-AT" dirty="0" err="1"/>
+              <a:t>to</a:t>
+            </a:r>
+            <a:r>
+              <a:rPr lang="de-AT" dirty="0"/>
+              <a:t> </a:t>
+            </a:r>
+            <a:r>
+              <a:rPr lang="de-AT" dirty="0" err="1"/>
+              <a:t>the</a:t>
+            </a:r>
+            <a:r>
+              <a:rPr lang="de-AT" dirty="0"/>
+              <a:t> PSOC6 </a:t>
+            </a:r>
+            <a:r>
+              <a:rPr lang="de-AT" dirty="0" err="1"/>
+              <a:t>stalling</a:t>
+            </a:r>
+            <a:r>
+              <a:rPr lang="de-AT" dirty="0"/>
+              <a:t> after a </a:t>
+            </a:r>
+            <a:r>
+              <a:rPr lang="de-AT" dirty="0" err="1"/>
+              <a:t>few</a:t>
+            </a:r>
+            <a:r>
+              <a:rPr lang="de-AT" dirty="0"/>
+              <a:t> </a:t>
+            </a:r>
+            <a:r>
+              <a:rPr lang="de-AT" dirty="0" err="1"/>
+              <a:t>seconds</a:t>
+            </a:r>
+            <a:r>
+              <a:rPr lang="de-AT" dirty="0"/>
+              <a:t>, different </a:t>
+            </a:r>
+            <a:r>
+              <a:rPr lang="de-AT" dirty="0" err="1"/>
+              <a:t>tries</a:t>
+            </a:r>
+            <a:r>
+              <a:rPr lang="de-AT" dirty="0"/>
+              <a:t> </a:t>
+            </a:r>
+            <a:r>
+              <a:rPr lang="de-AT" dirty="0" err="1"/>
+              <a:t>to</a:t>
+            </a:r>
+            <a:r>
+              <a:rPr lang="de-AT" dirty="0"/>
+              <a:t> </a:t>
+            </a:r>
+            <a:r>
+              <a:rPr lang="de-AT" dirty="0" err="1"/>
+              <a:t>solve</a:t>
+            </a:r>
+            <a:r>
+              <a:rPr lang="de-AT" dirty="0"/>
+              <a:t> </a:t>
+            </a:r>
+            <a:r>
+              <a:rPr lang="de-AT" dirty="0" err="1"/>
+              <a:t>the</a:t>
+            </a:r>
+            <a:r>
+              <a:rPr lang="de-AT" dirty="0"/>
+              <a:t> </a:t>
+            </a:r>
+            <a:r>
+              <a:rPr lang="de-AT" dirty="0" err="1"/>
+              <a:t>problem</a:t>
+            </a:r>
+            <a:r>
+              <a:rPr lang="de-AT" dirty="0"/>
+              <a:t> like </a:t>
+            </a:r>
+            <a:r>
+              <a:rPr lang="de-AT" dirty="0" err="1"/>
+              <a:t>manually</a:t>
+            </a:r>
+            <a:r>
+              <a:rPr lang="de-AT" dirty="0"/>
+              <a:t> </a:t>
+            </a:r>
+            <a:r>
+              <a:rPr lang="de-AT" dirty="0" err="1"/>
+              <a:t>triggering</a:t>
+            </a:r>
+            <a:r>
+              <a:rPr lang="de-AT" dirty="0"/>
+              <a:t> </a:t>
+            </a:r>
+            <a:r>
+              <a:rPr lang="de-AT" dirty="0" err="1"/>
+              <a:t>the</a:t>
+            </a:r>
+            <a:r>
+              <a:rPr lang="de-AT" dirty="0"/>
+              <a:t> </a:t>
+            </a:r>
+            <a:r>
+              <a:rPr lang="de-AT" dirty="0" err="1"/>
+              <a:t>garbage</a:t>
+            </a:r>
+            <a:r>
+              <a:rPr lang="de-AT" dirty="0"/>
+              <a:t> </a:t>
+            </a:r>
+            <a:r>
+              <a:rPr lang="de-AT" dirty="0" err="1"/>
+              <a:t>collector</a:t>
+            </a:r>
+            <a:r>
+              <a:rPr lang="de-AT" dirty="0"/>
+              <a:t> </a:t>
+            </a:r>
+            <a:r>
+              <a:rPr lang="de-AT" dirty="0" err="1"/>
+              <a:t>did</a:t>
+            </a:r>
+            <a:r>
+              <a:rPr lang="de-AT" dirty="0"/>
+              <a:t> not </a:t>
+            </a:r>
+            <a:r>
+              <a:rPr lang="de-AT" dirty="0" err="1"/>
+              <a:t>work</a:t>
+            </a:r>
+            <a:r>
+              <a:rPr lang="de-AT" dirty="0"/>
+              <a:t>. </a:t>
+            </a:r>
+            <a:r>
+              <a:rPr lang="de-AT" dirty="0" err="1"/>
+              <a:t>Using</a:t>
+            </a:r>
+            <a:r>
+              <a:rPr lang="de-AT" dirty="0"/>
+              <a:t> </a:t>
+            </a:r>
+            <a:r>
+              <a:rPr lang="de-AT" dirty="0" err="1"/>
+              <a:t>time.wait_ms</a:t>
+            </a:r>
+            <a:r>
+              <a:rPr lang="de-AT" dirty="0"/>
+              <a:t>() </a:t>
+            </a:r>
+            <a:r>
+              <a:rPr lang="de-AT" dirty="0" err="1"/>
+              <a:t>to</a:t>
+            </a:r>
+            <a:r>
+              <a:rPr lang="de-AT" dirty="0"/>
+              <a:t> </a:t>
+            </a:r>
+            <a:r>
+              <a:rPr lang="de-AT" dirty="0" err="1"/>
+              <a:t>achieve</a:t>
+            </a:r>
+            <a:r>
+              <a:rPr lang="de-AT" dirty="0"/>
+              <a:t> </a:t>
+            </a:r>
+            <a:r>
+              <a:rPr lang="de-AT" dirty="0" err="1"/>
+              <a:t>the</a:t>
+            </a:r>
+            <a:r>
+              <a:rPr lang="de-AT" dirty="0"/>
+              <a:t> 10ms loop </a:t>
+            </a:r>
+            <a:r>
+              <a:rPr lang="de-AT" dirty="0" err="1"/>
+              <a:t>runtime</a:t>
+            </a:r>
+            <a:r>
+              <a:rPr lang="de-AT" dirty="0"/>
+              <a:t> </a:t>
+            </a:r>
+            <a:r>
+              <a:rPr lang="de-AT" dirty="0" err="1"/>
+              <a:t>worked</a:t>
+            </a:r>
+            <a:r>
+              <a:rPr lang="de-AT" dirty="0"/>
+              <a:t> out </a:t>
+            </a:r>
+            <a:r>
+              <a:rPr lang="de-AT" dirty="0" err="1"/>
+              <a:t>perfectly</a:t>
+            </a:r>
+            <a:r>
+              <a:rPr lang="de-AT" dirty="0"/>
+              <a:t> (</a:t>
+            </a:r>
+            <a:r>
+              <a:rPr lang="de-AT" dirty="0" err="1"/>
+              <a:t>bad</a:t>
+            </a:r>
+            <a:r>
+              <a:rPr lang="de-AT" dirty="0"/>
+              <a:t> </a:t>
+            </a:r>
+            <a:r>
+              <a:rPr lang="de-AT" dirty="0" err="1"/>
+              <a:t>practice</a:t>
+            </a:r>
+            <a:r>
+              <a:rPr lang="de-AT" dirty="0"/>
+              <a:t> </a:t>
+            </a:r>
+            <a:r>
+              <a:rPr lang="de-AT" dirty="0" err="1"/>
+              <a:t>nonetheless</a:t>
+            </a:r>
+            <a:r>
+              <a:rPr lang="de-AT" dirty="0"/>
+              <a:t>).</a:t>
+            </a:r>
+          </a:p>
+          <a:p>
+            <a:endParaRPr lang="de-AT" dirty="0"/>
+          </a:p>
+          <a:p>
+            <a:r>
+              <a:rPr lang="de-AT" dirty="0" err="1"/>
+              <a:t>Another</a:t>
+            </a:r>
+            <a:r>
+              <a:rPr lang="de-AT" dirty="0"/>
+              <a:t> </a:t>
+            </a:r>
+            <a:r>
+              <a:rPr lang="de-AT" dirty="0" err="1"/>
+              <a:t>problem</a:t>
+            </a:r>
+            <a:r>
+              <a:rPr lang="de-AT" dirty="0"/>
+              <a:t> </a:t>
+            </a:r>
+            <a:r>
+              <a:rPr lang="de-AT" dirty="0" err="1"/>
+              <a:t>has</a:t>
+            </a:r>
+            <a:r>
+              <a:rPr lang="de-AT" dirty="0"/>
+              <a:t> </a:t>
+            </a:r>
+            <a:r>
+              <a:rPr lang="de-AT" dirty="0" err="1"/>
+              <a:t>to</a:t>
+            </a:r>
+            <a:r>
+              <a:rPr lang="de-AT" dirty="0"/>
+              <a:t> do </a:t>
+            </a:r>
+            <a:r>
+              <a:rPr lang="de-AT" dirty="0" err="1"/>
+              <a:t>with</a:t>
+            </a:r>
+            <a:r>
+              <a:rPr lang="de-AT" dirty="0"/>
+              <a:t> </a:t>
+            </a:r>
+            <a:r>
+              <a:rPr lang="de-AT" dirty="0" err="1"/>
+              <a:t>the</a:t>
+            </a:r>
+            <a:r>
+              <a:rPr lang="de-AT" dirty="0"/>
+              <a:t> </a:t>
+            </a:r>
+            <a:r>
+              <a:rPr lang="de-AT" dirty="0" err="1"/>
+              <a:t>sliding</a:t>
+            </a:r>
+            <a:r>
+              <a:rPr lang="de-AT" dirty="0"/>
+              <a:t> </a:t>
+            </a:r>
+            <a:r>
+              <a:rPr lang="de-AT" dirty="0" err="1"/>
+              <a:t>window</a:t>
+            </a:r>
+            <a:r>
+              <a:rPr lang="de-AT" dirty="0"/>
+              <a:t> and </a:t>
+            </a:r>
+            <a:r>
+              <a:rPr lang="de-AT" dirty="0" err="1"/>
+              <a:t>its</a:t>
+            </a:r>
+            <a:r>
+              <a:rPr lang="de-AT" dirty="0"/>
+              <a:t> </a:t>
+            </a:r>
+            <a:r>
+              <a:rPr lang="de-AT" dirty="0" err="1"/>
+              <a:t>length</a:t>
+            </a:r>
+            <a:r>
+              <a:rPr lang="de-AT" dirty="0"/>
+              <a:t>, </a:t>
+            </a:r>
+            <a:r>
+              <a:rPr lang="de-AT" dirty="0" err="1"/>
+              <a:t>sometimes</a:t>
+            </a:r>
+            <a:r>
+              <a:rPr lang="de-AT" dirty="0"/>
+              <a:t> </a:t>
+            </a:r>
+            <a:r>
+              <a:rPr lang="de-AT" dirty="0" err="1"/>
+              <a:t>when</a:t>
+            </a:r>
+            <a:r>
+              <a:rPr lang="de-AT" dirty="0"/>
+              <a:t> a </a:t>
+            </a:r>
+            <a:r>
+              <a:rPr lang="de-AT" dirty="0" err="1"/>
+              <a:t>punch</a:t>
+            </a:r>
+            <a:r>
+              <a:rPr lang="de-AT" dirty="0"/>
+              <a:t> </a:t>
+            </a:r>
+            <a:r>
+              <a:rPr lang="de-AT" dirty="0" err="1"/>
+              <a:t>reaches</a:t>
+            </a:r>
+            <a:r>
+              <a:rPr lang="de-AT" dirty="0"/>
+              <a:t> </a:t>
+            </a:r>
+            <a:r>
+              <a:rPr lang="de-AT" dirty="0" err="1"/>
+              <a:t>across</a:t>
+            </a:r>
+            <a:r>
+              <a:rPr lang="de-AT" dirty="0"/>
+              <a:t> </a:t>
+            </a:r>
+            <a:r>
+              <a:rPr lang="de-AT" dirty="0" err="1"/>
+              <a:t>two</a:t>
+            </a:r>
+            <a:r>
+              <a:rPr lang="de-AT" dirty="0"/>
+              <a:t> </a:t>
+            </a:r>
+            <a:r>
+              <a:rPr lang="de-AT" dirty="0" err="1"/>
+              <a:t>sliding</a:t>
+            </a:r>
+            <a:r>
+              <a:rPr lang="de-AT" dirty="0"/>
+              <a:t> </a:t>
+            </a:r>
+            <a:r>
+              <a:rPr lang="de-AT" dirty="0" err="1"/>
+              <a:t>windows</a:t>
+            </a:r>
+            <a:r>
+              <a:rPr lang="de-AT" dirty="0"/>
+              <a:t>/</a:t>
+            </a:r>
+            <a:r>
+              <a:rPr lang="de-AT" dirty="0" err="1"/>
+              <a:t>predicition</a:t>
+            </a:r>
+            <a:r>
+              <a:rPr lang="de-AT" dirty="0"/>
+              <a:t> </a:t>
+            </a:r>
+            <a:r>
+              <a:rPr lang="de-AT" dirty="0" err="1"/>
+              <a:t>periods</a:t>
+            </a:r>
+            <a:r>
+              <a:rPr lang="de-AT" dirty="0"/>
+              <a:t> </a:t>
+            </a:r>
+            <a:r>
+              <a:rPr lang="de-AT" dirty="0" err="1"/>
+              <a:t>it</a:t>
+            </a:r>
+            <a:r>
+              <a:rPr lang="de-AT" dirty="0"/>
+              <a:t> </a:t>
+            </a:r>
+            <a:r>
+              <a:rPr lang="de-AT" dirty="0" err="1"/>
+              <a:t>leads</a:t>
+            </a:r>
+            <a:r>
+              <a:rPr lang="de-AT" dirty="0"/>
+              <a:t> </a:t>
+            </a:r>
+            <a:r>
+              <a:rPr lang="de-AT" dirty="0" err="1"/>
+              <a:t>to</a:t>
+            </a:r>
+            <a:r>
+              <a:rPr lang="de-AT" dirty="0"/>
+              <a:t> </a:t>
+            </a:r>
+            <a:r>
+              <a:rPr lang="de-AT" dirty="0" err="1"/>
+              <a:t>the</a:t>
+            </a:r>
+            <a:r>
+              <a:rPr lang="de-AT" dirty="0"/>
+              <a:t> </a:t>
+            </a:r>
+            <a:r>
+              <a:rPr lang="de-AT" dirty="0" err="1"/>
+              <a:t>predicition</a:t>
+            </a:r>
+            <a:r>
+              <a:rPr lang="de-AT" dirty="0"/>
+              <a:t> </a:t>
+            </a:r>
+            <a:r>
+              <a:rPr lang="de-AT" dirty="0" err="1"/>
+              <a:t>value</a:t>
+            </a:r>
+            <a:r>
+              <a:rPr lang="de-AT" dirty="0"/>
+              <a:t> </a:t>
+            </a:r>
+            <a:r>
+              <a:rPr lang="de-AT" dirty="0" err="1"/>
+              <a:t>being</a:t>
+            </a:r>
+            <a:r>
+              <a:rPr lang="de-AT" dirty="0"/>
+              <a:t> </a:t>
+            </a:r>
+            <a:r>
+              <a:rPr lang="de-AT" dirty="0" err="1"/>
+              <a:t>higher</a:t>
+            </a:r>
+            <a:r>
+              <a:rPr lang="de-AT" dirty="0"/>
+              <a:t> </a:t>
+            </a:r>
+            <a:r>
+              <a:rPr lang="de-AT" dirty="0" err="1"/>
+              <a:t>than</a:t>
+            </a:r>
+            <a:r>
+              <a:rPr lang="de-AT" dirty="0"/>
+              <a:t> 0.6 </a:t>
+            </a:r>
+            <a:r>
+              <a:rPr lang="de-AT" dirty="0" err="1"/>
+              <a:t>which</a:t>
+            </a:r>
+            <a:r>
+              <a:rPr lang="de-AT" dirty="0"/>
+              <a:t> </a:t>
+            </a:r>
+            <a:r>
+              <a:rPr lang="de-AT" dirty="0" err="1"/>
+              <a:t>counts</a:t>
+            </a:r>
+            <a:r>
+              <a:rPr lang="de-AT" dirty="0"/>
+              <a:t> </a:t>
+            </a:r>
+            <a:r>
+              <a:rPr lang="de-AT" dirty="0" err="1"/>
+              <a:t>one</a:t>
+            </a:r>
+            <a:r>
+              <a:rPr lang="de-AT" dirty="0"/>
+              <a:t> </a:t>
+            </a:r>
+            <a:r>
+              <a:rPr lang="de-AT" dirty="0" err="1"/>
+              <a:t>punch</a:t>
+            </a:r>
+            <a:r>
+              <a:rPr lang="de-AT" dirty="0"/>
+              <a:t> </a:t>
+            </a:r>
+            <a:r>
+              <a:rPr lang="de-AT" dirty="0" err="1"/>
+              <a:t>as</a:t>
+            </a:r>
+            <a:r>
+              <a:rPr lang="de-AT" dirty="0"/>
+              <a:t> </a:t>
+            </a:r>
+            <a:r>
+              <a:rPr lang="de-AT" dirty="0" err="1"/>
+              <a:t>two</a:t>
+            </a:r>
+            <a:r>
+              <a:rPr lang="de-AT" dirty="0"/>
+              <a:t>. This </a:t>
+            </a:r>
+            <a:r>
+              <a:rPr lang="de-AT" dirty="0" err="1"/>
+              <a:t>could</a:t>
+            </a:r>
+            <a:r>
+              <a:rPr lang="de-AT" dirty="0"/>
+              <a:t> </a:t>
+            </a:r>
+            <a:r>
+              <a:rPr lang="de-AT" dirty="0" err="1"/>
+              <a:t>be</a:t>
+            </a:r>
+            <a:r>
+              <a:rPr lang="de-AT" dirty="0"/>
+              <a:t> </a:t>
+            </a:r>
+            <a:r>
+              <a:rPr lang="de-AT" dirty="0" err="1"/>
+              <a:t>fixed</a:t>
+            </a:r>
+            <a:r>
+              <a:rPr lang="de-AT" dirty="0"/>
+              <a:t> </a:t>
+            </a:r>
+            <a:r>
+              <a:rPr lang="de-AT" dirty="0" err="1"/>
+              <a:t>by</a:t>
+            </a:r>
+            <a:r>
+              <a:rPr lang="de-AT" dirty="0"/>
+              <a:t> </a:t>
+            </a:r>
+            <a:r>
+              <a:rPr lang="de-AT" dirty="0" err="1"/>
+              <a:t>trying</a:t>
+            </a:r>
+            <a:r>
+              <a:rPr lang="de-AT" dirty="0"/>
+              <a:t> out </a:t>
+            </a:r>
+            <a:r>
+              <a:rPr lang="de-AT" dirty="0" err="1"/>
+              <a:t>other</a:t>
+            </a:r>
+            <a:r>
+              <a:rPr lang="de-AT" dirty="0"/>
+              <a:t> </a:t>
+            </a:r>
+            <a:r>
+              <a:rPr lang="de-AT" dirty="0" err="1"/>
+              <a:t>sliding</a:t>
+            </a:r>
+            <a:r>
+              <a:rPr lang="de-AT" dirty="0"/>
+              <a:t> </a:t>
+            </a:r>
+            <a:r>
+              <a:rPr lang="de-AT" dirty="0" err="1"/>
+              <a:t>window</a:t>
+            </a:r>
+            <a:r>
+              <a:rPr lang="de-AT" dirty="0"/>
+              <a:t> </a:t>
+            </a:r>
+            <a:r>
+              <a:rPr lang="de-AT" dirty="0" err="1"/>
+              <a:t>values</a:t>
+            </a:r>
+            <a:r>
+              <a:rPr lang="de-AT" dirty="0"/>
+              <a:t> </a:t>
+            </a:r>
+            <a:r>
+              <a:rPr lang="de-AT" dirty="0" err="1"/>
+              <a:t>or</a:t>
+            </a:r>
+            <a:r>
+              <a:rPr lang="de-AT" dirty="0"/>
+              <a:t> </a:t>
+            </a:r>
+            <a:r>
+              <a:rPr lang="de-AT" dirty="0" err="1"/>
+              <a:t>peak</a:t>
+            </a:r>
+            <a:r>
+              <a:rPr lang="de-AT" dirty="0"/>
+              <a:t> </a:t>
+            </a:r>
+            <a:r>
+              <a:rPr lang="de-AT" dirty="0" err="1"/>
+              <a:t>detection</a:t>
+            </a:r>
+            <a:r>
+              <a:rPr lang="de-AT" dirty="0"/>
+              <a:t> in </a:t>
+            </a:r>
+            <a:r>
+              <a:rPr lang="de-AT" dirty="0" err="1"/>
+              <a:t>our</a:t>
+            </a:r>
+            <a:r>
+              <a:rPr lang="de-AT" dirty="0"/>
+              <a:t> </a:t>
+            </a:r>
+            <a:r>
+              <a:rPr lang="de-AT" dirty="0" err="1"/>
+              <a:t>Micropython</a:t>
+            </a:r>
+            <a:r>
+              <a:rPr lang="de-AT"/>
+              <a:t> code</a:t>
             </a:r>
           </a:p>
         </p:txBody>
@@ -7827,6 +9466,492 @@
           <a:bodyPr/>
           <a:lstStyle/>
           <a:p>
+            <a:r>
+              <a:rPr lang="de-AT" dirty="0"/>
+              <a:t>Data </a:t>
+            </a:r>
+            <a:r>
+              <a:rPr lang="de-AT" dirty="0" err="1"/>
+              <a:t>of</a:t>
+            </a:r>
+            <a:r>
+              <a:rPr lang="de-AT" dirty="0"/>
+              <a:t> </a:t>
+            </a:r>
+            <a:r>
+              <a:rPr lang="de-AT" dirty="0" err="1"/>
+              <a:t>one</a:t>
+            </a:r>
+            <a:r>
+              <a:rPr lang="de-AT" dirty="0"/>
+              <a:t> </a:t>
+            </a:r>
+            <a:r>
+              <a:rPr lang="de-AT" dirty="0" err="1"/>
+              <a:t>person</a:t>
+            </a:r>
+            <a:r>
+              <a:rPr lang="de-AT" dirty="0"/>
+              <a:t> </a:t>
+            </a:r>
+            <a:r>
+              <a:rPr lang="de-AT" dirty="0" err="1"/>
+              <a:t>for</a:t>
+            </a:r>
+            <a:r>
+              <a:rPr lang="de-AT" dirty="0"/>
+              <a:t> </a:t>
+            </a:r>
+            <a:r>
+              <a:rPr lang="de-AT" dirty="0" err="1"/>
+              <a:t>greater</a:t>
+            </a:r>
+            <a:r>
+              <a:rPr lang="de-AT" dirty="0"/>
+              <a:t> </a:t>
+            </a:r>
+            <a:r>
+              <a:rPr lang="de-AT" dirty="0" err="1"/>
+              <a:t>accuracy</a:t>
+            </a:r>
+            <a:r>
+              <a:rPr lang="de-AT" dirty="0"/>
+              <a:t>. </a:t>
+            </a:r>
+            <a:r>
+              <a:rPr lang="de-AT" dirty="0" err="1"/>
+              <a:t>Gathered</a:t>
+            </a:r>
+            <a:r>
+              <a:rPr lang="de-AT" dirty="0"/>
+              <a:t> a total </a:t>
+            </a:r>
+            <a:r>
+              <a:rPr lang="de-AT" dirty="0" err="1"/>
+              <a:t>of</a:t>
+            </a:r>
+            <a:r>
+              <a:rPr lang="de-AT" dirty="0"/>
+              <a:t> 45 </a:t>
+            </a:r>
+            <a:r>
+              <a:rPr lang="de-AT" dirty="0" err="1"/>
+              <a:t>minutes</a:t>
+            </a:r>
+            <a:r>
+              <a:rPr lang="de-AT" dirty="0"/>
+              <a:t> </a:t>
+            </a:r>
+            <a:r>
+              <a:rPr lang="de-AT" dirty="0" err="1"/>
+              <a:t>of</a:t>
+            </a:r>
+            <a:r>
+              <a:rPr lang="de-AT" dirty="0"/>
+              <a:t> </a:t>
+            </a:r>
+            <a:r>
+              <a:rPr lang="de-AT" dirty="0" err="1"/>
+              <a:t>data</a:t>
+            </a:r>
+            <a:r>
+              <a:rPr lang="de-AT" dirty="0"/>
+              <a:t>, 18,5 </a:t>
+            </a:r>
+            <a:r>
+              <a:rPr lang="de-AT" dirty="0" err="1"/>
+              <a:t>labeled</a:t>
+            </a:r>
+            <a:r>
+              <a:rPr lang="de-AT" dirty="0"/>
+              <a:t>. </a:t>
+            </a:r>
+          </a:p>
+          <a:p>
+            <a:endParaRPr lang="de-AT" dirty="0"/>
+          </a:p>
+          <a:p>
+            <a:r>
+              <a:rPr lang="de-AT" dirty="0" err="1"/>
+              <a:t>We</a:t>
+            </a:r>
+            <a:r>
+              <a:rPr lang="de-AT" dirty="0"/>
+              <a:t> </a:t>
+            </a:r>
+            <a:r>
+              <a:rPr lang="de-AT" dirty="0" err="1"/>
+              <a:t>chose</a:t>
+            </a:r>
+            <a:r>
+              <a:rPr lang="de-AT" dirty="0"/>
+              <a:t> a 60/20/20 </a:t>
+            </a:r>
+            <a:r>
+              <a:rPr lang="de-AT" dirty="0" err="1"/>
+              <a:t>split</a:t>
+            </a:r>
+            <a:r>
+              <a:rPr lang="de-AT" dirty="0"/>
+              <a:t> </a:t>
+            </a:r>
+            <a:r>
+              <a:rPr lang="de-AT" dirty="0" err="1"/>
+              <a:t>as</a:t>
+            </a:r>
+            <a:r>
+              <a:rPr lang="de-AT" dirty="0"/>
+              <a:t> </a:t>
+            </a:r>
+            <a:r>
+              <a:rPr lang="de-AT" dirty="0" err="1"/>
+              <a:t>suggested</a:t>
+            </a:r>
+            <a:r>
+              <a:rPr lang="de-AT" dirty="0"/>
+              <a:t> in </a:t>
+            </a:r>
+            <a:r>
+              <a:rPr lang="de-AT" dirty="0" err="1"/>
+              <a:t>the</a:t>
+            </a:r>
+            <a:r>
+              <a:rPr lang="de-AT" dirty="0"/>
+              <a:t> </a:t>
+            </a:r>
+            <a:r>
+              <a:rPr lang="de-AT" dirty="0" err="1"/>
+              <a:t>lecture</a:t>
+            </a:r>
+            <a:r>
+              <a:rPr lang="de-AT" dirty="0"/>
+              <a:t> </a:t>
+            </a:r>
+            <a:r>
+              <a:rPr lang="de-AT" dirty="0" err="1"/>
+              <a:t>part</a:t>
+            </a:r>
+            <a:r>
+              <a:rPr lang="de-AT" dirty="0"/>
+              <a:t> </a:t>
+            </a:r>
+            <a:r>
+              <a:rPr lang="de-AT" dirty="0" err="1"/>
+              <a:t>of</a:t>
+            </a:r>
+            <a:r>
+              <a:rPr lang="de-AT" dirty="0"/>
+              <a:t> </a:t>
+            </a:r>
+            <a:r>
+              <a:rPr lang="de-AT" dirty="0" err="1"/>
+              <a:t>the</a:t>
+            </a:r>
+            <a:r>
+              <a:rPr lang="de-AT" dirty="0"/>
+              <a:t> </a:t>
+            </a:r>
+            <a:r>
+              <a:rPr lang="de-AT" dirty="0" err="1"/>
+              <a:t>project</a:t>
+            </a:r>
+            <a:r>
+              <a:rPr lang="de-AT" dirty="0"/>
+              <a:t>. </a:t>
+            </a:r>
+          </a:p>
+          <a:p>
+            <a:endParaRPr lang="de-AT" dirty="0"/>
+          </a:p>
+          <a:p>
+            <a:r>
+              <a:rPr lang="de-AT" dirty="0" err="1"/>
+              <a:t>Implemented</a:t>
+            </a:r>
+            <a:r>
+              <a:rPr lang="de-AT" dirty="0"/>
+              <a:t> negative </a:t>
+            </a:r>
+            <a:r>
+              <a:rPr lang="de-AT" dirty="0" err="1"/>
+              <a:t>data</a:t>
+            </a:r>
+            <a:r>
+              <a:rPr lang="de-AT" dirty="0"/>
+              <a:t> </a:t>
+            </a:r>
+            <a:r>
+              <a:rPr lang="de-AT" dirty="0" err="1"/>
+              <a:t>which</a:t>
+            </a:r>
+            <a:r>
+              <a:rPr lang="de-AT" dirty="0"/>
+              <a:t> </a:t>
+            </a:r>
+            <a:r>
+              <a:rPr lang="de-AT" dirty="0" err="1"/>
+              <a:t>consists</a:t>
+            </a:r>
+            <a:r>
+              <a:rPr lang="de-AT" dirty="0"/>
+              <a:t> </a:t>
+            </a:r>
+            <a:r>
+              <a:rPr lang="de-AT" dirty="0" err="1"/>
+              <a:t>of</a:t>
+            </a:r>
+            <a:r>
+              <a:rPr lang="de-AT" dirty="0"/>
+              <a:t> </a:t>
+            </a:r>
+            <a:r>
+              <a:rPr lang="de-AT" dirty="0" err="1"/>
+              <a:t>warming</a:t>
+            </a:r>
+            <a:r>
+              <a:rPr lang="de-AT" dirty="0"/>
+              <a:t> </a:t>
+            </a:r>
+            <a:r>
+              <a:rPr lang="de-AT" dirty="0" err="1"/>
+              <a:t>up</a:t>
+            </a:r>
+            <a:r>
+              <a:rPr lang="de-AT" dirty="0"/>
+              <a:t>, </a:t>
+            </a:r>
+            <a:r>
+              <a:rPr lang="de-AT" dirty="0" err="1"/>
+              <a:t>walking</a:t>
+            </a:r>
+            <a:r>
+              <a:rPr lang="de-AT" dirty="0"/>
+              <a:t> </a:t>
+            </a:r>
+            <a:r>
+              <a:rPr lang="de-AT" dirty="0" err="1"/>
+              <a:t>around</a:t>
+            </a:r>
+            <a:r>
+              <a:rPr lang="de-AT" dirty="0"/>
+              <a:t> and </a:t>
+            </a:r>
+            <a:r>
+              <a:rPr lang="de-AT" dirty="0" err="1"/>
+              <a:t>data</a:t>
+            </a:r>
+            <a:r>
+              <a:rPr lang="de-AT" dirty="0"/>
+              <a:t> </a:t>
+            </a:r>
+            <a:r>
+              <a:rPr lang="de-AT" dirty="0" err="1"/>
+              <a:t>which</a:t>
+            </a:r>
+            <a:r>
+              <a:rPr lang="de-AT" dirty="0"/>
+              <a:t> </a:t>
+            </a:r>
+            <a:r>
+              <a:rPr lang="de-AT" dirty="0" err="1"/>
+              <a:t>shows</a:t>
+            </a:r>
+            <a:r>
+              <a:rPr lang="de-AT" dirty="0"/>
+              <a:t> </a:t>
+            </a:r>
+            <a:r>
+              <a:rPr lang="de-AT" dirty="0" err="1"/>
+              <a:t>neither</a:t>
+            </a:r>
+            <a:r>
+              <a:rPr lang="de-AT" dirty="0"/>
+              <a:t> </a:t>
+            </a:r>
+            <a:r>
+              <a:rPr lang="de-AT" dirty="0" err="1"/>
+              <a:t>distinc</a:t>
+            </a:r>
+            <a:r>
+              <a:rPr lang="de-AT" dirty="0"/>
+              <a:t> </a:t>
+            </a:r>
+            <a:r>
+              <a:rPr lang="de-AT" dirty="0" err="1"/>
+              <a:t>punches</a:t>
+            </a:r>
+            <a:r>
+              <a:rPr lang="de-AT" dirty="0"/>
+              <a:t> </a:t>
+            </a:r>
+            <a:r>
+              <a:rPr lang="de-AT" dirty="0" err="1"/>
+              <a:t>thrown</a:t>
+            </a:r>
+            <a:r>
+              <a:rPr lang="de-AT" dirty="0"/>
+              <a:t> </a:t>
+            </a:r>
+            <a:r>
+              <a:rPr lang="de-AT" dirty="0" err="1"/>
+              <a:t>nor</a:t>
+            </a:r>
+            <a:r>
+              <a:rPr lang="de-AT" dirty="0"/>
+              <a:t> </a:t>
+            </a:r>
+            <a:r>
+              <a:rPr lang="de-AT" dirty="0" err="1"/>
+              <a:t>completly</a:t>
+            </a:r>
+            <a:r>
+              <a:rPr lang="de-AT" dirty="0"/>
+              <a:t> </a:t>
+            </a:r>
+            <a:r>
+              <a:rPr lang="de-AT" dirty="0" err="1"/>
+              <a:t>standing</a:t>
+            </a:r>
+            <a:r>
+              <a:rPr lang="de-AT" dirty="0"/>
+              <a:t> still.</a:t>
+            </a:r>
+          </a:p>
+          <a:p>
+            <a:r>
+              <a:rPr lang="de-AT" dirty="0"/>
+              <a:t> </a:t>
+            </a:r>
+          </a:p>
+          <a:p>
+            <a:r>
+              <a:rPr lang="de-AT" dirty="0"/>
+              <a:t>On </a:t>
+            </a:r>
+            <a:r>
+              <a:rPr lang="de-AT" dirty="0" err="1"/>
+              <a:t>the</a:t>
+            </a:r>
+            <a:r>
+              <a:rPr lang="de-AT" dirty="0"/>
+              <a:t> </a:t>
+            </a:r>
+            <a:r>
+              <a:rPr lang="de-AT" dirty="0" err="1"/>
+              <a:t>picture</a:t>
+            </a:r>
+            <a:r>
+              <a:rPr lang="de-AT" dirty="0"/>
+              <a:t> </a:t>
+            </a:r>
+            <a:r>
+              <a:rPr lang="de-AT" dirty="0" err="1"/>
+              <a:t>you</a:t>
+            </a:r>
+            <a:r>
+              <a:rPr lang="de-AT" dirty="0"/>
+              <a:t> </a:t>
+            </a:r>
+            <a:r>
+              <a:rPr lang="de-AT" dirty="0" err="1"/>
+              <a:t>can</a:t>
+            </a:r>
+            <a:r>
+              <a:rPr lang="de-AT" dirty="0"/>
+              <a:t> </a:t>
+            </a:r>
+            <a:r>
+              <a:rPr lang="de-AT" dirty="0" err="1"/>
+              <a:t>see</a:t>
+            </a:r>
+            <a:r>
+              <a:rPr lang="de-AT" dirty="0"/>
+              <a:t> </a:t>
+            </a:r>
+            <a:r>
+              <a:rPr lang="de-AT" dirty="0" err="1"/>
+              <a:t>the</a:t>
+            </a:r>
+            <a:r>
+              <a:rPr lang="de-AT" dirty="0"/>
+              <a:t> </a:t>
+            </a:r>
+            <a:r>
+              <a:rPr lang="de-AT" dirty="0" err="1"/>
+              <a:t>specific</a:t>
+            </a:r>
+            <a:r>
+              <a:rPr lang="de-AT" dirty="0"/>
+              <a:t> </a:t>
+            </a:r>
+            <a:r>
+              <a:rPr lang="de-AT" dirty="0" err="1"/>
+              <a:t>splits</a:t>
+            </a:r>
+            <a:r>
+              <a:rPr lang="de-AT" dirty="0"/>
+              <a:t> </a:t>
+            </a:r>
+            <a:r>
+              <a:rPr lang="de-AT" dirty="0" err="1"/>
+              <a:t>for</a:t>
+            </a:r>
+            <a:r>
+              <a:rPr lang="de-AT" dirty="0"/>
+              <a:t> </a:t>
+            </a:r>
+            <a:r>
+              <a:rPr lang="de-AT" dirty="0" err="1"/>
+              <a:t>train</a:t>
+            </a:r>
+            <a:r>
+              <a:rPr lang="de-AT" dirty="0"/>
+              <a:t>/</a:t>
+            </a:r>
+            <a:r>
+              <a:rPr lang="de-AT" dirty="0" err="1"/>
+              <a:t>validation</a:t>
+            </a:r>
+            <a:r>
+              <a:rPr lang="de-AT" dirty="0"/>
+              <a:t> and </a:t>
+            </a:r>
+            <a:r>
+              <a:rPr lang="de-AT" dirty="0" err="1"/>
+              <a:t>test</a:t>
+            </a:r>
+            <a:r>
+              <a:rPr lang="de-AT" dirty="0"/>
+              <a:t> </a:t>
+            </a:r>
+            <a:r>
+              <a:rPr lang="de-AT" dirty="0" err="1"/>
+              <a:t>we</a:t>
+            </a:r>
+            <a:r>
+              <a:rPr lang="de-AT" dirty="0"/>
+              <a:t> </a:t>
+            </a:r>
+            <a:r>
+              <a:rPr lang="de-AT" dirty="0" err="1"/>
+              <a:t>achieved</a:t>
+            </a:r>
+            <a:r>
+              <a:rPr lang="de-AT" dirty="0"/>
+              <a:t> in </a:t>
+            </a:r>
+            <a:r>
+              <a:rPr lang="de-AT" dirty="0" err="1"/>
+              <a:t>our</a:t>
+            </a:r>
+            <a:r>
+              <a:rPr lang="de-AT" dirty="0"/>
+              <a:t> </a:t>
+            </a:r>
+            <a:r>
+              <a:rPr lang="de-AT" dirty="0" err="1"/>
+              <a:t>classification</a:t>
+            </a:r>
             <a:endParaRPr lang="de-AT" dirty="0"/>
           </a:p>
         </p:txBody>
@@ -7911,6 +10036,506 @@
           <a:bodyPr/>
           <a:lstStyle/>
           <a:p>
+            <a:r>
+              <a:rPr lang="de-AT" dirty="0" err="1"/>
+              <a:t>Differene</a:t>
+            </a:r>
+            <a:r>
+              <a:rPr lang="de-AT" dirty="0"/>
+              <a:t> </a:t>
+            </a:r>
+            <a:r>
+              <a:rPr lang="de-AT" dirty="0" err="1"/>
+              <a:t>between</a:t>
+            </a:r>
+            <a:r>
+              <a:rPr lang="de-AT" dirty="0"/>
+              <a:t> </a:t>
+            </a:r>
+            <a:r>
+              <a:rPr lang="de-AT" dirty="0" err="1"/>
+              <a:t>tobi</a:t>
+            </a:r>
+            <a:r>
+              <a:rPr lang="de-AT" dirty="0"/>
+              <a:t> on </a:t>
+            </a:r>
+            <a:r>
+              <a:rPr lang="de-AT" dirty="0" err="1"/>
+              <a:t>the</a:t>
+            </a:r>
+            <a:r>
+              <a:rPr lang="de-AT" dirty="0"/>
+              <a:t> </a:t>
+            </a:r>
+            <a:r>
+              <a:rPr lang="de-AT" dirty="0" err="1"/>
+              <a:t>left</a:t>
+            </a:r>
+            <a:r>
+              <a:rPr lang="de-AT" dirty="0"/>
+              <a:t> and </a:t>
+            </a:r>
+            <a:r>
+              <a:rPr lang="de-AT" dirty="0" err="1"/>
+              <a:t>my</a:t>
+            </a:r>
+            <a:r>
+              <a:rPr lang="de-AT" dirty="0"/>
+              <a:t> </a:t>
+            </a:r>
+            <a:r>
+              <a:rPr lang="de-AT" dirty="0" err="1"/>
+              <a:t>data</a:t>
+            </a:r>
+            <a:r>
+              <a:rPr lang="de-AT" dirty="0"/>
+              <a:t> on </a:t>
+            </a:r>
+            <a:r>
+              <a:rPr lang="de-AT" dirty="0" err="1"/>
+              <a:t>the</a:t>
+            </a:r>
+            <a:r>
+              <a:rPr lang="de-AT" dirty="0"/>
+              <a:t> </a:t>
+            </a:r>
+            <a:r>
+              <a:rPr lang="de-AT" dirty="0" err="1"/>
+              <a:t>right</a:t>
+            </a:r>
+            <a:r>
+              <a:rPr lang="de-AT" dirty="0"/>
+              <a:t> </a:t>
+            </a:r>
+            <a:r>
+              <a:rPr lang="de-AT" dirty="0" err="1"/>
+              <a:t>is</a:t>
+            </a:r>
+            <a:r>
+              <a:rPr lang="de-AT" dirty="0"/>
+              <a:t> not </a:t>
+            </a:r>
+            <a:r>
+              <a:rPr lang="de-AT" dirty="0" err="1"/>
+              <a:t>as</a:t>
+            </a:r>
+            <a:r>
+              <a:rPr lang="de-AT" dirty="0"/>
+              <a:t> </a:t>
+            </a:r>
+            <a:r>
+              <a:rPr lang="de-AT" dirty="0" err="1"/>
+              <a:t>big</a:t>
+            </a:r>
+            <a:r>
+              <a:rPr lang="de-AT" dirty="0"/>
+              <a:t> </a:t>
+            </a:r>
+            <a:r>
+              <a:rPr lang="de-AT" dirty="0" err="1"/>
+              <a:t>as</a:t>
+            </a:r>
+            <a:r>
+              <a:rPr lang="de-AT" dirty="0"/>
+              <a:t> </a:t>
+            </a:r>
+            <a:r>
+              <a:rPr lang="de-AT" dirty="0" err="1"/>
+              <a:t>the</a:t>
+            </a:r>
+            <a:r>
+              <a:rPr lang="de-AT" dirty="0"/>
+              <a:t> </a:t>
+            </a:r>
+            <a:r>
+              <a:rPr lang="de-AT" dirty="0" err="1"/>
+              <a:t>difference</a:t>
+            </a:r>
+            <a:r>
+              <a:rPr lang="de-AT" dirty="0"/>
+              <a:t> </a:t>
+            </a:r>
+            <a:r>
+              <a:rPr lang="de-AT" dirty="0" err="1"/>
+              <a:t>to</a:t>
+            </a:r>
+            <a:r>
+              <a:rPr lang="de-AT" dirty="0"/>
+              <a:t> </a:t>
+            </a:r>
+            <a:r>
+              <a:rPr lang="de-AT" dirty="0" err="1"/>
+              <a:t>theos</a:t>
+            </a:r>
+            <a:r>
+              <a:rPr lang="de-AT" dirty="0"/>
+              <a:t> </a:t>
+            </a:r>
+            <a:r>
+              <a:rPr lang="de-AT" dirty="0" err="1"/>
+              <a:t>data</a:t>
+            </a:r>
+            <a:r>
+              <a:rPr lang="de-AT" dirty="0"/>
+              <a:t> in </a:t>
+            </a:r>
+            <a:r>
+              <a:rPr lang="de-AT" dirty="0" err="1"/>
+              <a:t>the</a:t>
+            </a:r>
+            <a:r>
+              <a:rPr lang="de-AT" dirty="0"/>
+              <a:t> </a:t>
+            </a:r>
+            <a:r>
+              <a:rPr lang="de-AT" dirty="0" err="1"/>
+              <a:t>middle</a:t>
+            </a:r>
+            <a:r>
+              <a:rPr lang="de-AT" dirty="0"/>
+              <a:t>. </a:t>
+            </a:r>
+            <a:r>
+              <a:rPr lang="de-AT" dirty="0" err="1"/>
+              <a:t>Its</a:t>
+            </a:r>
+            <a:r>
+              <a:rPr lang="de-AT" dirty="0"/>
+              <a:t> </a:t>
+            </a:r>
+            <a:r>
+              <a:rPr lang="de-AT" dirty="0" err="1"/>
+              <a:t>necessary</a:t>
+            </a:r>
+            <a:r>
+              <a:rPr lang="de-AT" dirty="0"/>
+              <a:t> </a:t>
+            </a:r>
+            <a:r>
+              <a:rPr lang="de-AT" dirty="0" err="1"/>
+              <a:t>to</a:t>
+            </a:r>
+            <a:r>
+              <a:rPr lang="de-AT" dirty="0"/>
+              <a:t> </a:t>
+            </a:r>
+            <a:r>
+              <a:rPr lang="de-AT" dirty="0" err="1"/>
+              <a:t>state</a:t>
+            </a:r>
+            <a:r>
+              <a:rPr lang="de-AT" dirty="0"/>
+              <a:t> </a:t>
+            </a:r>
+            <a:r>
+              <a:rPr lang="de-AT" dirty="0" err="1"/>
+              <a:t>that</a:t>
+            </a:r>
+            <a:r>
+              <a:rPr lang="de-AT" dirty="0"/>
+              <a:t> </a:t>
+            </a:r>
+            <a:r>
+              <a:rPr lang="de-AT" dirty="0" err="1"/>
+              <a:t>tobi</a:t>
+            </a:r>
+            <a:r>
+              <a:rPr lang="de-AT" dirty="0"/>
+              <a:t> and i </a:t>
+            </a:r>
+            <a:r>
+              <a:rPr lang="de-AT" dirty="0" err="1"/>
+              <a:t>have</a:t>
+            </a:r>
+            <a:r>
+              <a:rPr lang="de-AT" dirty="0"/>
+              <a:t> </a:t>
+            </a:r>
+            <a:r>
+              <a:rPr lang="de-AT" dirty="0" err="1"/>
+              <a:t>boxed</a:t>
+            </a:r>
+            <a:r>
+              <a:rPr lang="de-AT" dirty="0"/>
+              <a:t> multiple </a:t>
+            </a:r>
+            <a:r>
+              <a:rPr lang="de-AT" dirty="0" err="1"/>
+              <a:t>times</a:t>
+            </a:r>
+            <a:r>
+              <a:rPr lang="de-AT" dirty="0"/>
+              <a:t> </a:t>
+            </a:r>
+            <a:r>
+              <a:rPr lang="de-AT" dirty="0" err="1"/>
+              <a:t>before</a:t>
+            </a:r>
+            <a:r>
+              <a:rPr lang="de-AT" dirty="0"/>
+              <a:t> and </a:t>
+            </a:r>
+            <a:r>
+              <a:rPr lang="de-AT" dirty="0" err="1"/>
+              <a:t>theo</a:t>
+            </a:r>
+            <a:r>
+              <a:rPr lang="de-AT" dirty="0"/>
+              <a:t> </a:t>
+            </a:r>
+            <a:r>
+              <a:rPr lang="de-AT" dirty="0" err="1"/>
+              <a:t>took</a:t>
+            </a:r>
+            <a:r>
+              <a:rPr lang="de-AT" dirty="0"/>
+              <a:t> </a:t>
+            </a:r>
+            <a:r>
+              <a:rPr lang="de-AT" dirty="0" err="1"/>
+              <a:t>his</a:t>
+            </a:r>
+            <a:r>
+              <a:rPr lang="de-AT" dirty="0"/>
+              <a:t> </a:t>
+            </a:r>
+            <a:r>
+              <a:rPr lang="de-AT" dirty="0" err="1"/>
+              <a:t>first</a:t>
+            </a:r>
+            <a:r>
+              <a:rPr lang="de-AT" dirty="0"/>
+              <a:t> </a:t>
+            </a:r>
+            <a:r>
+              <a:rPr lang="de-AT" dirty="0" err="1"/>
+              <a:t>punches</a:t>
+            </a:r>
+            <a:r>
+              <a:rPr lang="de-AT" dirty="0"/>
+              <a:t> </a:t>
+            </a:r>
+            <a:r>
+              <a:rPr lang="de-AT" dirty="0" err="1"/>
+              <a:t>during</a:t>
+            </a:r>
+            <a:r>
+              <a:rPr lang="de-AT" dirty="0"/>
+              <a:t> </a:t>
+            </a:r>
+            <a:r>
+              <a:rPr lang="de-AT" dirty="0" err="1"/>
+              <a:t>our</a:t>
+            </a:r>
+            <a:r>
+              <a:rPr lang="de-AT" dirty="0"/>
+              <a:t> </a:t>
+            </a:r>
+            <a:r>
+              <a:rPr lang="de-AT" dirty="0" err="1"/>
+              <a:t>project</a:t>
+            </a:r>
+            <a:r>
+              <a:rPr lang="de-AT" dirty="0"/>
+              <a:t> (and </a:t>
+            </a:r>
+            <a:r>
+              <a:rPr lang="de-AT" dirty="0" err="1"/>
+              <a:t>with</a:t>
+            </a:r>
+            <a:r>
+              <a:rPr lang="de-AT" dirty="0"/>
+              <a:t> </a:t>
+            </a:r>
+            <a:r>
+              <a:rPr lang="de-AT" dirty="0" err="1"/>
+              <a:t>us</a:t>
+            </a:r>
+            <a:r>
+              <a:rPr lang="de-AT" dirty="0"/>
+              <a:t> </a:t>
+            </a:r>
+            <a:r>
+              <a:rPr lang="de-AT" dirty="0" err="1"/>
+              <a:t>as</a:t>
+            </a:r>
+            <a:r>
+              <a:rPr lang="de-AT" dirty="0"/>
+              <a:t> </a:t>
+            </a:r>
+            <a:r>
+              <a:rPr lang="de-AT" dirty="0" err="1"/>
+              <a:t>his</a:t>
+            </a:r>
+            <a:r>
+              <a:rPr lang="de-AT" dirty="0"/>
+              <a:t> </a:t>
+            </a:r>
+            <a:r>
+              <a:rPr lang="de-AT" dirty="0" err="1"/>
+              <a:t>coaches</a:t>
+            </a:r>
+            <a:r>
+              <a:rPr lang="de-AT" dirty="0"/>
+              <a:t> ;) ) </a:t>
+            </a:r>
+            <a:r>
+              <a:rPr lang="de-AT" dirty="0" err="1"/>
+              <a:t>That</a:t>
+            </a:r>
+            <a:r>
+              <a:rPr lang="de-AT" dirty="0"/>
+              <a:t> </a:t>
+            </a:r>
+            <a:r>
+              <a:rPr lang="de-AT" dirty="0" err="1"/>
+              <a:t>visualizes</a:t>
+            </a:r>
+            <a:r>
+              <a:rPr lang="de-AT" dirty="0"/>
+              <a:t> </a:t>
+            </a:r>
+            <a:r>
+              <a:rPr lang="de-AT" dirty="0" err="1"/>
+              <a:t>perfectly</a:t>
+            </a:r>
+            <a:r>
+              <a:rPr lang="de-AT" dirty="0"/>
+              <a:t> </a:t>
+            </a:r>
+            <a:r>
+              <a:rPr lang="de-AT" dirty="0" err="1"/>
+              <a:t>how</a:t>
+            </a:r>
+            <a:r>
+              <a:rPr lang="de-AT" dirty="0"/>
+              <a:t> </a:t>
+            </a:r>
+            <a:r>
+              <a:rPr lang="de-AT" dirty="0" err="1"/>
+              <a:t>significant</a:t>
+            </a:r>
+            <a:r>
+              <a:rPr lang="de-AT" dirty="0"/>
+              <a:t> </a:t>
+            </a:r>
+            <a:r>
+              <a:rPr lang="de-AT" dirty="0" err="1"/>
+              <a:t>the</a:t>
+            </a:r>
+            <a:r>
+              <a:rPr lang="de-AT" dirty="0"/>
+              <a:t> </a:t>
+            </a:r>
+            <a:r>
+              <a:rPr lang="de-AT" dirty="0" err="1"/>
+              <a:t>differences</a:t>
+            </a:r>
+            <a:r>
+              <a:rPr lang="de-AT" dirty="0"/>
+              <a:t> </a:t>
+            </a:r>
+            <a:r>
+              <a:rPr lang="de-AT" dirty="0" err="1"/>
+              <a:t>can</a:t>
+            </a:r>
+            <a:r>
+              <a:rPr lang="de-AT" dirty="0"/>
+              <a:t> </a:t>
+            </a:r>
+            <a:r>
+              <a:rPr lang="de-AT" dirty="0" err="1"/>
+              <a:t>be</a:t>
+            </a:r>
+            <a:r>
+              <a:rPr lang="de-AT" dirty="0"/>
+              <a:t>, </a:t>
+            </a:r>
+            <a:r>
+              <a:rPr lang="de-AT" dirty="0" err="1"/>
+              <a:t>therefore</a:t>
+            </a:r>
+            <a:r>
+              <a:rPr lang="de-AT" dirty="0"/>
+              <a:t> </a:t>
+            </a:r>
+            <a:r>
+              <a:rPr lang="de-AT" dirty="0" err="1"/>
+              <a:t>we</a:t>
+            </a:r>
+            <a:r>
+              <a:rPr lang="de-AT" dirty="0"/>
+              <a:t> </a:t>
+            </a:r>
+            <a:r>
+              <a:rPr lang="de-AT" dirty="0" err="1"/>
+              <a:t>decided</a:t>
+            </a:r>
+            <a:r>
+              <a:rPr lang="de-AT" dirty="0"/>
+              <a:t> </a:t>
+            </a:r>
+            <a:r>
+              <a:rPr lang="de-AT" dirty="0" err="1"/>
+              <a:t>to</a:t>
+            </a:r>
+            <a:r>
+              <a:rPr lang="de-AT" dirty="0"/>
+              <a:t> </a:t>
+            </a:r>
+            <a:r>
+              <a:rPr lang="de-AT" dirty="0" err="1"/>
+              <a:t>only</a:t>
+            </a:r>
+            <a:r>
+              <a:rPr lang="de-AT" dirty="0"/>
+              <a:t> </a:t>
+            </a:r>
+            <a:r>
+              <a:rPr lang="de-AT" dirty="0" err="1"/>
+              <a:t>use</a:t>
+            </a:r>
+            <a:r>
+              <a:rPr lang="de-AT" dirty="0"/>
+              <a:t> </a:t>
+            </a:r>
+            <a:r>
+              <a:rPr lang="de-AT" dirty="0" err="1"/>
+              <a:t>the</a:t>
+            </a:r>
+            <a:r>
+              <a:rPr lang="de-AT" dirty="0"/>
+              <a:t> </a:t>
+            </a:r>
+            <a:r>
+              <a:rPr lang="de-AT" dirty="0" err="1"/>
+              <a:t>data</a:t>
+            </a:r>
+            <a:r>
+              <a:rPr lang="de-AT" dirty="0"/>
+              <a:t> </a:t>
+            </a:r>
+            <a:r>
+              <a:rPr lang="de-AT" dirty="0" err="1"/>
+              <a:t>of</a:t>
+            </a:r>
+            <a:r>
+              <a:rPr lang="de-AT" dirty="0"/>
+              <a:t> </a:t>
+            </a:r>
+            <a:r>
+              <a:rPr lang="de-AT" dirty="0" err="1"/>
+              <a:t>one</a:t>
+            </a:r>
+            <a:r>
+              <a:rPr lang="de-AT" dirty="0"/>
+              <a:t> </a:t>
+            </a:r>
+            <a:r>
+              <a:rPr lang="de-AT" dirty="0" err="1"/>
+              <a:t>person</a:t>
+            </a:r>
             <a:endParaRPr lang="de-AT" dirty="0"/>
           </a:p>
         </p:txBody>
@@ -7995,7 +10620,853 @@
           <a:bodyPr/>
           <a:lstStyle/>
           <a:p>
+            <a:r>
+              <a:rPr lang="de-AT" dirty="0" err="1"/>
+              <a:t>We</a:t>
+            </a:r>
+            <a:r>
+              <a:rPr lang="de-AT" dirty="0"/>
+              <a:t> </a:t>
+            </a:r>
+            <a:r>
+              <a:rPr lang="de-AT" dirty="0" err="1"/>
+              <a:t>used</a:t>
+            </a:r>
+            <a:r>
+              <a:rPr lang="de-AT" dirty="0"/>
+              <a:t> </a:t>
+            </a:r>
+            <a:r>
+              <a:rPr lang="de-AT" dirty="0" err="1"/>
+              <a:t>the</a:t>
+            </a:r>
+            <a:r>
+              <a:rPr lang="de-AT" dirty="0"/>
+              <a:t> </a:t>
+            </a:r>
+            <a:r>
+              <a:rPr lang="de-AT" dirty="0" err="1"/>
+              <a:t>contextual</a:t>
+            </a:r>
+            <a:r>
+              <a:rPr lang="de-AT" dirty="0"/>
+              <a:t> </a:t>
+            </a:r>
+            <a:r>
+              <a:rPr lang="de-AT" dirty="0" err="1"/>
+              <a:t>window</a:t>
+            </a:r>
+            <a:r>
+              <a:rPr lang="de-AT" dirty="0"/>
+              <a:t>/</a:t>
+            </a:r>
+            <a:r>
+              <a:rPr lang="de-AT" dirty="0" err="1"/>
+              <a:t>sliding</a:t>
+            </a:r>
+            <a:r>
+              <a:rPr lang="de-AT" dirty="0"/>
+              <a:t> </a:t>
+            </a:r>
+            <a:r>
+              <a:rPr lang="de-AT" dirty="0" err="1"/>
+              <a:t>window</a:t>
+            </a:r>
+            <a:r>
+              <a:rPr lang="de-AT" dirty="0"/>
+              <a:t> </a:t>
+            </a:r>
+            <a:r>
+              <a:rPr lang="de-AT" dirty="0" err="1"/>
+              <a:t>as</a:t>
+            </a:r>
+            <a:r>
+              <a:rPr lang="de-AT" dirty="0"/>
+              <a:t> </a:t>
+            </a:r>
+            <a:r>
+              <a:rPr lang="de-AT" dirty="0" err="1"/>
+              <a:t>preprocessor</a:t>
+            </a:r>
+            <a:r>
+              <a:rPr lang="de-AT" dirty="0"/>
+              <a:t> </a:t>
+            </a:r>
+            <a:r>
+              <a:rPr lang="de-AT" dirty="0" err="1"/>
+              <a:t>layer</a:t>
+            </a:r>
+            <a:r>
+              <a:rPr lang="de-AT" dirty="0"/>
+              <a:t> </a:t>
+            </a:r>
+            <a:r>
+              <a:rPr lang="de-AT" dirty="0" err="1"/>
+              <a:t>for</a:t>
+            </a:r>
+            <a:r>
+              <a:rPr lang="de-AT" dirty="0"/>
+              <a:t> </a:t>
+            </a:r>
+            <a:r>
+              <a:rPr lang="de-AT" dirty="0" err="1"/>
+              <a:t>our</a:t>
+            </a:r>
+            <a:r>
+              <a:rPr lang="de-AT" dirty="0"/>
+              <a:t> </a:t>
+            </a:r>
+            <a:r>
+              <a:rPr lang="de-AT" dirty="0" err="1"/>
+              <a:t>classification</a:t>
+            </a:r>
+            <a:r>
+              <a:rPr lang="de-AT" dirty="0"/>
+              <a:t> </a:t>
+            </a:r>
+            <a:r>
+              <a:rPr lang="de-AT" dirty="0" err="1"/>
+              <a:t>with</a:t>
+            </a:r>
+            <a:r>
+              <a:rPr lang="de-AT" dirty="0"/>
+              <a:t> a </a:t>
+            </a:r>
+            <a:r>
+              <a:rPr lang="de-AT" dirty="0" err="1"/>
+              <a:t>window</a:t>
+            </a:r>
+            <a:r>
+              <a:rPr lang="de-AT" dirty="0"/>
+              <a:t> </a:t>
+            </a:r>
+            <a:r>
+              <a:rPr lang="de-AT" dirty="0" err="1"/>
+              <a:t>length</a:t>
+            </a:r>
+            <a:r>
+              <a:rPr lang="de-AT" dirty="0"/>
+              <a:t> </a:t>
+            </a:r>
+            <a:r>
+              <a:rPr lang="de-AT" dirty="0" err="1"/>
+              <a:t>of</a:t>
+            </a:r>
+            <a:r>
+              <a:rPr lang="de-AT" dirty="0"/>
+              <a:t> 0.5s and 2Hz </a:t>
+            </a:r>
+            <a:r>
+              <a:rPr lang="de-AT" dirty="0" err="1"/>
+              <a:t>prediciton</a:t>
+            </a:r>
+            <a:r>
+              <a:rPr lang="de-AT" dirty="0"/>
+              <a:t> </a:t>
+            </a:r>
+            <a:r>
+              <a:rPr lang="de-AT" dirty="0" err="1"/>
+              <a:t>frequency</a:t>
+            </a:r>
             <a:endParaRPr lang="de-AT" dirty="0"/>
+          </a:p>
+          <a:p>
+            <a:endParaRPr lang="de-AT" dirty="0"/>
+          </a:p>
+          <a:p>
+            <a:r>
+              <a:rPr lang="de-AT" dirty="0" err="1"/>
+              <a:t>For</a:t>
+            </a:r>
+            <a:r>
+              <a:rPr lang="de-AT" dirty="0"/>
+              <a:t> </a:t>
+            </a:r>
+            <a:r>
+              <a:rPr lang="de-AT" dirty="0" err="1"/>
+              <a:t>the</a:t>
+            </a:r>
+            <a:r>
+              <a:rPr lang="de-AT" dirty="0"/>
+              <a:t> </a:t>
+            </a:r>
+            <a:r>
+              <a:rPr lang="de-AT" dirty="0" err="1"/>
+              <a:t>model</a:t>
+            </a:r>
+            <a:r>
+              <a:rPr lang="de-AT" dirty="0"/>
+              <a:t> </a:t>
+            </a:r>
+            <a:r>
+              <a:rPr lang="de-AT" dirty="0" err="1"/>
+              <a:t>creation</a:t>
+            </a:r>
+            <a:r>
+              <a:rPr lang="de-AT" dirty="0"/>
+              <a:t> </a:t>
+            </a:r>
+            <a:r>
+              <a:rPr lang="de-AT" dirty="0" err="1"/>
+              <a:t>we</a:t>
+            </a:r>
+            <a:r>
+              <a:rPr lang="de-AT" dirty="0"/>
+              <a:t> </a:t>
+            </a:r>
+            <a:r>
+              <a:rPr lang="de-AT" dirty="0" err="1"/>
+              <a:t>used</a:t>
+            </a:r>
+            <a:r>
+              <a:rPr lang="de-AT" dirty="0"/>
+              <a:t> </a:t>
+            </a:r>
+            <a:r>
+              <a:rPr lang="de-AT" dirty="0" err="1"/>
+              <a:t>the</a:t>
+            </a:r>
+            <a:r>
+              <a:rPr lang="de-AT" dirty="0"/>
+              <a:t> </a:t>
+            </a:r>
+            <a:r>
+              <a:rPr lang="de-AT" dirty="0" err="1"/>
+              <a:t>model</a:t>
+            </a:r>
+            <a:r>
+              <a:rPr lang="de-AT" dirty="0"/>
+              <a:t> </a:t>
+            </a:r>
+            <a:r>
+              <a:rPr lang="de-AT" dirty="0" err="1"/>
+              <a:t>wizard</a:t>
+            </a:r>
+            <a:r>
+              <a:rPr lang="de-AT" dirty="0"/>
+              <a:t> and </a:t>
+            </a:r>
+            <a:r>
+              <a:rPr lang="de-AT" dirty="0" err="1"/>
+              <a:t>decided</a:t>
+            </a:r>
+            <a:r>
+              <a:rPr lang="de-AT" dirty="0"/>
+              <a:t> </a:t>
+            </a:r>
+            <a:r>
+              <a:rPr lang="de-AT" dirty="0" err="1"/>
+              <a:t>to</a:t>
+            </a:r>
+            <a:r>
+              <a:rPr lang="de-AT" dirty="0"/>
+              <a:t> </a:t>
+            </a:r>
+            <a:r>
+              <a:rPr lang="de-AT" dirty="0" err="1"/>
+              <a:t>go</a:t>
+            </a:r>
+            <a:r>
+              <a:rPr lang="de-AT" dirty="0"/>
+              <a:t> </a:t>
+            </a:r>
+            <a:r>
+              <a:rPr lang="de-AT" dirty="0" err="1"/>
+              <a:t>with</a:t>
+            </a:r>
+            <a:r>
+              <a:rPr lang="de-AT" dirty="0"/>
+              <a:t> </a:t>
+            </a:r>
+            <a:r>
+              <a:rPr lang="de-AT" dirty="0" err="1"/>
+              <a:t>the</a:t>
+            </a:r>
+            <a:r>
+              <a:rPr lang="de-AT" dirty="0"/>
+              <a:t> conv1d </a:t>
+            </a:r>
+            <a:r>
+              <a:rPr lang="de-AT" dirty="0" err="1"/>
+              <a:t>model</a:t>
+            </a:r>
+            <a:r>
+              <a:rPr lang="de-AT" dirty="0"/>
+              <a:t> </a:t>
+            </a:r>
+            <a:r>
+              <a:rPr lang="de-AT" dirty="0" err="1"/>
+              <a:t>family</a:t>
+            </a:r>
+            <a:r>
+              <a:rPr lang="de-AT" dirty="0"/>
+              <a:t>, medium </a:t>
+            </a:r>
+            <a:r>
+              <a:rPr lang="de-AT" dirty="0" err="1"/>
+              <a:t>model</a:t>
+            </a:r>
+            <a:r>
+              <a:rPr lang="de-AT" dirty="0"/>
+              <a:t> </a:t>
+            </a:r>
+            <a:r>
+              <a:rPr lang="de-AT" dirty="0" err="1"/>
+              <a:t>size</a:t>
+            </a:r>
+            <a:r>
+              <a:rPr lang="de-AT" dirty="0"/>
+              <a:t>. </a:t>
+            </a:r>
+            <a:r>
+              <a:rPr lang="de-AT" dirty="0" err="1"/>
+              <a:t>Balanced</a:t>
+            </a:r>
+            <a:r>
+              <a:rPr lang="de-AT" dirty="0"/>
+              <a:t> </a:t>
+            </a:r>
+            <a:r>
+              <a:rPr lang="de-AT" dirty="0" err="1"/>
+              <a:t>optimization</a:t>
+            </a:r>
+            <a:r>
+              <a:rPr lang="de-AT" dirty="0"/>
+              <a:t> </a:t>
+            </a:r>
+            <a:r>
+              <a:rPr lang="de-AT" dirty="0" err="1"/>
+              <a:t>as</a:t>
+            </a:r>
+            <a:r>
+              <a:rPr lang="de-AT" dirty="0"/>
+              <a:t> </a:t>
+            </a:r>
+            <a:r>
+              <a:rPr lang="de-AT" dirty="0" err="1"/>
+              <a:t>well</a:t>
+            </a:r>
+            <a:r>
+              <a:rPr lang="de-AT" dirty="0"/>
+              <a:t> </a:t>
+            </a:r>
+            <a:r>
+              <a:rPr lang="de-AT" dirty="0" err="1"/>
+              <a:t>as</a:t>
+            </a:r>
+            <a:r>
+              <a:rPr lang="de-AT" dirty="0"/>
+              <a:t> an medium </a:t>
+            </a:r>
+            <a:r>
+              <a:rPr lang="de-AT" dirty="0" err="1"/>
+              <a:t>learn</a:t>
+            </a:r>
+            <a:r>
+              <a:rPr lang="de-AT" dirty="0"/>
+              <a:t> rate and </a:t>
+            </a:r>
+            <a:r>
+              <a:rPr lang="de-AT" dirty="0" err="1"/>
+              <a:t>regularization</a:t>
+            </a:r>
+            <a:r>
+              <a:rPr lang="de-AT" dirty="0"/>
+              <a:t>.</a:t>
+            </a:r>
+          </a:p>
+          <a:p>
+            <a:endParaRPr lang="de-AT" dirty="0"/>
+          </a:p>
+          <a:p>
+            <a:r>
+              <a:rPr lang="de-AT" dirty="0" err="1"/>
+              <a:t>We</a:t>
+            </a:r>
+            <a:r>
+              <a:rPr lang="de-AT" dirty="0"/>
+              <a:t> </a:t>
+            </a:r>
+            <a:r>
+              <a:rPr lang="de-AT" dirty="0" err="1"/>
+              <a:t>created</a:t>
+            </a:r>
+            <a:r>
+              <a:rPr lang="de-AT" dirty="0"/>
+              <a:t> a </a:t>
+            </a:r>
+            <a:r>
+              <a:rPr lang="de-AT" dirty="0" err="1"/>
+              <a:t>lot</a:t>
+            </a:r>
+            <a:r>
+              <a:rPr lang="de-AT" dirty="0"/>
+              <a:t> </a:t>
+            </a:r>
+            <a:r>
+              <a:rPr lang="de-AT" dirty="0" err="1"/>
+              <a:t>of</a:t>
+            </a:r>
+            <a:r>
+              <a:rPr lang="de-AT" dirty="0"/>
+              <a:t> </a:t>
+            </a:r>
+            <a:r>
+              <a:rPr lang="de-AT" dirty="0" err="1"/>
+              <a:t>models</a:t>
+            </a:r>
+            <a:r>
+              <a:rPr lang="de-AT" dirty="0"/>
+              <a:t> and </a:t>
+            </a:r>
+            <a:r>
+              <a:rPr lang="de-AT" dirty="0" err="1"/>
+              <a:t>tried</a:t>
+            </a:r>
+            <a:r>
+              <a:rPr lang="de-AT" dirty="0"/>
+              <a:t> out </a:t>
+            </a:r>
+            <a:r>
+              <a:rPr lang="de-AT" dirty="0" err="1"/>
+              <a:t>varying</a:t>
+            </a:r>
+            <a:r>
+              <a:rPr lang="de-AT" dirty="0"/>
+              <a:t> </a:t>
+            </a:r>
+            <a:r>
+              <a:rPr lang="de-AT" dirty="0" err="1"/>
+              <a:t>paramteres</a:t>
+            </a:r>
+            <a:r>
+              <a:rPr lang="de-AT" dirty="0"/>
+              <a:t> and </a:t>
+            </a:r>
+            <a:r>
+              <a:rPr lang="de-AT" dirty="0" err="1"/>
+              <a:t>played</a:t>
+            </a:r>
+            <a:r>
+              <a:rPr lang="de-AT" dirty="0"/>
+              <a:t> </a:t>
+            </a:r>
+            <a:r>
+              <a:rPr lang="de-AT" dirty="0" err="1"/>
+              <a:t>around</a:t>
+            </a:r>
+            <a:r>
+              <a:rPr lang="de-AT" dirty="0"/>
+              <a:t> </a:t>
+            </a:r>
+            <a:r>
+              <a:rPr lang="de-AT" dirty="0" err="1"/>
+              <a:t>with</a:t>
+            </a:r>
+            <a:r>
+              <a:rPr lang="de-AT" dirty="0"/>
+              <a:t> </a:t>
+            </a:r>
+            <a:r>
+              <a:rPr lang="de-AT" dirty="0" err="1"/>
+              <a:t>the</a:t>
+            </a:r>
+            <a:r>
+              <a:rPr lang="de-AT" dirty="0"/>
+              <a:t> </a:t>
+            </a:r>
+            <a:r>
+              <a:rPr lang="de-AT" dirty="0" err="1"/>
+              <a:t>contextual</a:t>
+            </a:r>
+            <a:r>
+              <a:rPr lang="de-AT" dirty="0"/>
+              <a:t> </a:t>
+            </a:r>
+            <a:r>
+              <a:rPr lang="de-AT" dirty="0" err="1"/>
+              <a:t>window</a:t>
+            </a:r>
+            <a:r>
+              <a:rPr lang="de-AT" dirty="0"/>
+              <a:t> </a:t>
+            </a:r>
+            <a:r>
+              <a:rPr lang="de-AT" dirty="0" err="1"/>
+              <a:t>parameters</a:t>
+            </a:r>
+            <a:r>
+              <a:rPr lang="de-AT" dirty="0"/>
+              <a:t> </a:t>
+            </a:r>
+            <a:r>
+              <a:rPr lang="de-AT" dirty="0" err="1"/>
+              <a:t>as</a:t>
+            </a:r>
+            <a:r>
+              <a:rPr lang="de-AT" dirty="0"/>
+              <a:t> </a:t>
+            </a:r>
+            <a:r>
+              <a:rPr lang="de-AT" dirty="0" err="1"/>
+              <a:t>well</a:t>
+            </a:r>
+            <a:r>
+              <a:rPr lang="de-AT" dirty="0"/>
+              <a:t>. The </a:t>
+            </a:r>
+            <a:r>
+              <a:rPr lang="de-AT" dirty="0" err="1"/>
+              <a:t>parameters</a:t>
+            </a:r>
+            <a:r>
+              <a:rPr lang="de-AT" dirty="0"/>
+              <a:t> </a:t>
+            </a:r>
+            <a:r>
+              <a:rPr lang="de-AT" dirty="0" err="1"/>
+              <a:t>mentioned</a:t>
+            </a:r>
+            <a:r>
+              <a:rPr lang="de-AT" dirty="0"/>
+              <a:t> </a:t>
+            </a:r>
+            <a:r>
+              <a:rPr lang="de-AT" dirty="0" err="1"/>
+              <a:t>before</a:t>
+            </a:r>
+            <a:r>
+              <a:rPr lang="de-AT" dirty="0"/>
+              <a:t> </a:t>
+            </a:r>
+            <a:r>
+              <a:rPr lang="de-AT" dirty="0" err="1"/>
+              <a:t>achieved</a:t>
+            </a:r>
+            <a:r>
+              <a:rPr lang="de-AT" dirty="0"/>
+              <a:t> </a:t>
+            </a:r>
+            <a:r>
+              <a:rPr lang="de-AT" dirty="0" err="1"/>
+              <a:t>the</a:t>
+            </a:r>
+            <a:r>
+              <a:rPr lang="de-AT" dirty="0"/>
+              <a:t> </a:t>
+            </a:r>
+            <a:r>
+              <a:rPr lang="de-AT" dirty="0" err="1"/>
+              <a:t>best</a:t>
+            </a:r>
+            <a:r>
+              <a:rPr lang="de-AT" dirty="0"/>
+              <a:t> </a:t>
+            </a:r>
+            <a:r>
+              <a:rPr lang="de-AT" dirty="0" err="1"/>
+              <a:t>statistics</a:t>
+            </a:r>
+            <a:r>
+              <a:rPr lang="de-AT" dirty="0"/>
+              <a:t> </a:t>
+            </a:r>
+            <a:r>
+              <a:rPr lang="de-AT" dirty="0" err="1"/>
+              <a:t>overall</a:t>
+            </a:r>
+            <a:r>
+              <a:rPr lang="de-AT" dirty="0"/>
+              <a:t>, </a:t>
+            </a:r>
+            <a:r>
+              <a:rPr lang="de-AT" dirty="0" err="1"/>
+              <a:t>which</a:t>
+            </a:r>
+            <a:r>
+              <a:rPr lang="de-AT" dirty="0"/>
+              <a:t> </a:t>
+            </a:r>
+            <a:r>
+              <a:rPr lang="de-AT" dirty="0" err="1"/>
+              <a:t>are</a:t>
+            </a:r>
+            <a:r>
+              <a:rPr lang="de-AT" dirty="0"/>
+              <a:t> </a:t>
+            </a:r>
+            <a:r>
+              <a:rPr lang="de-AT" dirty="0" err="1"/>
+              <a:t>shown</a:t>
+            </a:r>
+            <a:r>
+              <a:rPr lang="de-AT" dirty="0"/>
+              <a:t> on </a:t>
+            </a:r>
+            <a:r>
+              <a:rPr lang="de-AT" dirty="0" err="1"/>
+              <a:t>the</a:t>
+            </a:r>
+            <a:r>
+              <a:rPr lang="de-AT" dirty="0"/>
+              <a:t> </a:t>
+            </a:r>
+            <a:r>
+              <a:rPr lang="de-AT" dirty="0" err="1"/>
+              <a:t>slide</a:t>
+            </a:r>
+            <a:r>
+              <a:rPr lang="de-AT" dirty="0"/>
+              <a:t>. </a:t>
+            </a:r>
+            <a:r>
+              <a:rPr lang="de-AT" dirty="0" err="1"/>
+              <a:t>We</a:t>
+            </a:r>
+            <a:r>
+              <a:rPr lang="de-AT" dirty="0"/>
+              <a:t> </a:t>
+            </a:r>
+            <a:r>
+              <a:rPr lang="de-AT" dirty="0" err="1"/>
+              <a:t>can</a:t>
+            </a:r>
+            <a:r>
+              <a:rPr lang="de-AT" dirty="0"/>
+              <a:t> </a:t>
+            </a:r>
+            <a:r>
+              <a:rPr lang="de-AT" dirty="0" err="1"/>
+              <a:t>see</a:t>
+            </a:r>
+            <a:r>
+              <a:rPr lang="de-AT" dirty="0"/>
+              <a:t> </a:t>
+            </a:r>
+            <a:r>
+              <a:rPr lang="de-AT" dirty="0" err="1"/>
+              <a:t>upwards</a:t>
+            </a:r>
+            <a:r>
+              <a:rPr lang="de-AT" dirty="0"/>
+              <a:t> </a:t>
+            </a:r>
+            <a:r>
+              <a:rPr lang="de-AT" dirty="0" err="1"/>
+              <a:t>of</a:t>
+            </a:r>
+            <a:r>
+              <a:rPr lang="de-AT" dirty="0"/>
+              <a:t> 85% </a:t>
+            </a:r>
+            <a:r>
+              <a:rPr lang="de-AT" dirty="0" err="1"/>
+              <a:t>correct</a:t>
+            </a:r>
+            <a:r>
+              <a:rPr lang="de-AT" dirty="0"/>
+              <a:t> </a:t>
+            </a:r>
+            <a:r>
+              <a:rPr lang="de-AT" dirty="0" err="1"/>
+              <a:t>predicition</a:t>
+            </a:r>
+            <a:r>
+              <a:rPr lang="de-AT" dirty="0"/>
+              <a:t> </a:t>
+            </a:r>
+            <a:r>
+              <a:rPr lang="de-AT" dirty="0" err="1"/>
+              <a:t>for</a:t>
+            </a:r>
+            <a:r>
+              <a:rPr lang="de-AT" dirty="0"/>
+              <a:t> </a:t>
+            </a:r>
+            <a:r>
+              <a:rPr lang="de-AT" dirty="0" err="1"/>
+              <a:t>each</a:t>
+            </a:r>
+            <a:r>
+              <a:rPr lang="de-AT" dirty="0"/>
+              <a:t> </a:t>
+            </a:r>
+            <a:r>
+              <a:rPr lang="de-AT" dirty="0" err="1"/>
+              <a:t>punch</a:t>
+            </a:r>
+            <a:r>
+              <a:rPr lang="de-AT" dirty="0"/>
+              <a:t> type in </a:t>
+            </a:r>
+            <a:r>
+              <a:rPr lang="de-AT" dirty="0" err="1"/>
+              <a:t>the</a:t>
+            </a:r>
+            <a:r>
+              <a:rPr lang="de-AT" dirty="0"/>
+              <a:t> </a:t>
+            </a:r>
+            <a:r>
+              <a:rPr lang="de-AT" dirty="0" err="1"/>
+              <a:t>test</a:t>
+            </a:r>
+            <a:r>
+              <a:rPr lang="de-AT" dirty="0"/>
+              <a:t> </a:t>
+            </a:r>
+            <a:r>
+              <a:rPr lang="de-AT" dirty="0" err="1"/>
+              <a:t>statistics</a:t>
+            </a:r>
+            <a:r>
+              <a:rPr lang="de-AT" dirty="0"/>
+              <a:t>. </a:t>
+            </a:r>
+            <a:r>
+              <a:rPr lang="de-AT" dirty="0" err="1"/>
+              <a:t>For</a:t>
+            </a:r>
+            <a:r>
+              <a:rPr lang="de-AT" dirty="0"/>
+              <a:t> </a:t>
+            </a:r>
+            <a:r>
+              <a:rPr lang="de-AT" dirty="0" err="1"/>
+              <a:t>the</a:t>
+            </a:r>
+            <a:r>
+              <a:rPr lang="de-AT" dirty="0"/>
+              <a:t> </a:t>
+            </a:r>
+            <a:r>
+              <a:rPr lang="de-AT" dirty="0" err="1"/>
+              <a:t>jab</a:t>
+            </a:r>
+            <a:r>
+              <a:rPr lang="de-AT" dirty="0"/>
+              <a:t> and </a:t>
+            </a:r>
+            <a:r>
+              <a:rPr lang="de-AT" dirty="0" err="1"/>
+              <a:t>the</a:t>
+            </a:r>
+            <a:r>
+              <a:rPr lang="de-AT" dirty="0"/>
+              <a:t> </a:t>
+            </a:r>
+            <a:r>
+              <a:rPr lang="de-AT" dirty="0" err="1"/>
+              <a:t>sidehook</a:t>
+            </a:r>
+            <a:r>
+              <a:rPr lang="de-AT" dirty="0"/>
+              <a:t> </a:t>
+            </a:r>
+            <a:r>
+              <a:rPr lang="de-AT" dirty="0" err="1"/>
+              <a:t>they</a:t>
+            </a:r>
+            <a:r>
+              <a:rPr lang="de-AT" dirty="0"/>
+              <a:t> </a:t>
+            </a:r>
+            <a:r>
+              <a:rPr lang="de-AT" dirty="0" err="1"/>
+              <a:t>were</a:t>
+            </a:r>
+            <a:r>
+              <a:rPr lang="de-AT" dirty="0"/>
+              <a:t> </a:t>
+            </a:r>
+            <a:r>
+              <a:rPr lang="de-AT" dirty="0" err="1"/>
+              <a:t>even</a:t>
+            </a:r>
+            <a:r>
+              <a:rPr lang="de-AT" dirty="0"/>
+              <a:t> </a:t>
+            </a:r>
+            <a:r>
+              <a:rPr lang="de-AT" dirty="0" err="1"/>
+              <a:t>above</a:t>
+            </a:r>
+            <a:r>
+              <a:rPr lang="de-AT" dirty="0"/>
+              <a:t> 90%, </a:t>
+            </a:r>
+            <a:r>
+              <a:rPr lang="de-AT" dirty="0" err="1"/>
+              <a:t>which</a:t>
+            </a:r>
+            <a:r>
+              <a:rPr lang="de-AT" dirty="0"/>
+              <a:t> </a:t>
+            </a:r>
+            <a:r>
+              <a:rPr lang="de-AT" dirty="0" err="1"/>
+              <a:t>is</a:t>
+            </a:r>
+            <a:r>
+              <a:rPr lang="de-AT" dirty="0"/>
+              <a:t> </a:t>
+            </a:r>
+            <a:r>
+              <a:rPr lang="de-AT" dirty="0" err="1"/>
+              <a:t>more</a:t>
+            </a:r>
+            <a:r>
+              <a:rPr lang="de-AT" dirty="0"/>
+              <a:t> </a:t>
+            </a:r>
+            <a:r>
+              <a:rPr lang="de-AT" dirty="0" err="1"/>
+              <a:t>than</a:t>
+            </a:r>
+            <a:r>
+              <a:rPr lang="de-AT" dirty="0"/>
+              <a:t> </a:t>
+            </a:r>
+            <a:r>
+              <a:rPr lang="de-AT" dirty="0" err="1"/>
+              <a:t>good</a:t>
+            </a:r>
+            <a:r>
+              <a:rPr lang="de-AT" dirty="0"/>
+              <a:t> </a:t>
+            </a:r>
+            <a:r>
+              <a:rPr lang="de-AT" dirty="0" err="1"/>
+              <a:t>enough</a:t>
+            </a:r>
+            <a:r>
+              <a:rPr lang="de-AT" dirty="0"/>
+              <a:t> </a:t>
+            </a:r>
+            <a:r>
+              <a:rPr lang="de-AT" dirty="0" err="1"/>
+              <a:t>for</a:t>
+            </a:r>
+            <a:r>
+              <a:rPr lang="de-AT" dirty="0"/>
+              <a:t> </a:t>
+            </a:r>
+            <a:r>
+              <a:rPr lang="de-AT" dirty="0" err="1"/>
+              <a:t>our</a:t>
+            </a:r>
+            <a:r>
+              <a:rPr lang="de-AT" dirty="0"/>
+              <a:t> </a:t>
+            </a:r>
+            <a:r>
+              <a:rPr lang="de-AT" dirty="0" err="1"/>
+              <a:t>project</a:t>
+            </a:r>
+            <a:r>
+              <a:rPr lang="de-AT" dirty="0"/>
+              <a:t> </a:t>
+            </a:r>
           </a:p>
         </p:txBody>
       </p:sp>
@@ -11693,7 +15164,7 @@
                   <a:schemeClr val="bg1"/>
                 </a:solidFill>
               </a:rPr>
-              <a:t>Corneaux</a:t>
+              <a:t>Corneux</a:t>
             </a:r>
             <a:r>
               <a:rPr lang="en-GB" noProof="0" dirty="0">
@@ -12892,7 +16363,7 @@
           <p:nvPr>
             <p:extLst>
               <p:ext uri="{D42A27DB-BD31-4B8C-83A1-F6EECF244321}">
-                <p14:modId xmlns:p14="http://schemas.microsoft.com/office/powerpoint/2010/main" val="2324947360"/>
+                <p14:modId xmlns:p14="http://schemas.microsoft.com/office/powerpoint/2010/main" val="3638342055"/>
               </p:ext>
             </p:extLst>
           </p:nvPr>
@@ -17531,20 +21002,20 @@
 </file>
 
 <file path=customXml/item1.xml><?xml version="1.0" encoding="utf-8"?>
+<p:properties xmlns:p="http://schemas.microsoft.com/office/2006/metadata/properties" xmlns:xsi="http://www.w3.org/2001/XMLSchema-instance" xmlns:pc="http://schemas.microsoft.com/office/infopath/2007/PartnerControls">
+  <documentManagement>
+    <_activity xmlns="bf1a47b5-10f0-4178-af4a-bbe7cc4004c3" xsi:nil="true"/>
+  </documentManagement>
+</p:properties>
+</file>
+
+<file path=customXml/item2.xml><?xml version="1.0" encoding="utf-8"?>
 <?mso-contentType ?>
 <FormTemplates xmlns="http://schemas.microsoft.com/sharepoint/v3/contenttype/forms">
   <Display>DocumentLibraryForm</Display>
   <Edit>DocumentLibraryForm</Edit>
   <New>DocumentLibraryForm</New>
 </FormTemplates>
-</file>
-
-<file path=customXml/item2.xml><?xml version="1.0" encoding="utf-8"?>
-<p:properties xmlns:p="http://schemas.microsoft.com/office/2006/metadata/properties" xmlns:xsi="http://www.w3.org/2001/XMLSchema-instance" xmlns:pc="http://schemas.microsoft.com/office/infopath/2007/PartnerControls">
-  <documentManagement>
-    <_activity xmlns="bf1a47b5-10f0-4178-af4a-bbe7cc4004c3" xsi:nil="true"/>
-  </documentManagement>
-</p:properties>
 </file>
 
 <file path=customXml/item3.xml><?xml version="1.0" encoding="utf-8"?>
@@ -17736,14 +21207,6 @@
 </file>
 
 <file path=customXml/itemProps1.xml><?xml version="1.0" encoding="utf-8"?>
-<ds:datastoreItem xmlns:ds="http://schemas.openxmlformats.org/officeDocument/2006/customXml" ds:itemID="{D12945CB-A677-4013-820C-0AEFE2C4DC48}">
-  <ds:schemaRefs>
-    <ds:schemaRef ds:uri="http://schemas.microsoft.com/sharepoint/v3/contenttype/forms"/>
-  </ds:schemaRefs>
-</ds:datastoreItem>
-</file>
-
-<file path=customXml/itemProps2.xml><?xml version="1.0" encoding="utf-8"?>
 <ds:datastoreItem xmlns:ds="http://schemas.openxmlformats.org/officeDocument/2006/customXml" ds:itemID="{2C2A40F2-5398-4DE1-A8FC-C0BA56DCE4EA}">
   <ds:schemaRefs>
     <ds:schemaRef ds:uri="bf1a47b5-10f0-4178-af4a-bbe7cc4004c3"/>
@@ -17755,6 +21218,14 @@
     <ds:schemaRef ds:uri="http://www.w3.org/XML/1998/namespace"/>
     <ds:schemaRef ds:uri="http://purl.org/dc/dcmitype/"/>
     <ds:schemaRef ds:uri="http://schemas.microsoft.com/office/2006/metadata/properties"/>
+  </ds:schemaRefs>
+</ds:datastoreItem>
+</file>
+
+<file path=customXml/itemProps2.xml><?xml version="1.0" encoding="utf-8"?>
+<ds:datastoreItem xmlns:ds="http://schemas.openxmlformats.org/officeDocument/2006/customXml" ds:itemID="{D12945CB-A677-4013-820C-0AEFE2C4DC48}">
+  <ds:schemaRefs>
+    <ds:schemaRef ds:uri="http://schemas.microsoft.com/sharepoint/v3/contenttype/forms"/>
   </ds:schemaRefs>
 </ds:datastoreItem>
 </file>

</xml_diff>

<commit_message>
more tweaks to presentation
</commit_message>
<xml_diff>
--- a/report/Präsentation_final.pptx
+++ b/report/Präsentation_final.pptx
@@ -1826,10 +1826,9 @@
         <a:lstStyle/>
         <a:p>
           <a:r>
-            <a:rPr lang="en-GB"/>
+            <a:rPr lang="en-GB" noProof="0" dirty="0"/>
             <a:t>Purpose</a:t>
           </a:r>
-          <a:endParaRPr lang="en-US"/>
         </a:p>
       </dgm:t>
     </dgm:pt>
@@ -1863,10 +1862,9 @@
         <a:lstStyle/>
         <a:p>
           <a:r>
-            <a:rPr lang="en-GB" dirty="0"/>
+            <a:rPr lang="en-GB" noProof="0" dirty="0"/>
             <a:t>Accurate collection and evaluation of data</a:t>
           </a:r>
-          <a:endParaRPr lang="en-US" dirty="0"/>
         </a:p>
       </dgm:t>
     </dgm:pt>
@@ -1900,10 +1898,9 @@
         <a:lstStyle/>
         <a:p>
           <a:r>
-            <a:rPr lang="en-GB"/>
+            <a:rPr lang="en-GB" noProof="0" dirty="0"/>
             <a:t>Construction</a:t>
           </a:r>
-          <a:endParaRPr lang="en-US"/>
         </a:p>
       </dgm:t>
     </dgm:pt>
@@ -1937,10 +1934,9 @@
         <a:lstStyle/>
         <a:p>
           <a:r>
-            <a:rPr lang="en-GB" dirty="0"/>
+            <a:rPr lang="en-GB" noProof="0" dirty="0"/>
             <a:t>Holder fixation on box latch</a:t>
           </a:r>
-          <a:endParaRPr lang="en-US" dirty="0"/>
         </a:p>
       </dgm:t>
     </dgm:pt>
@@ -1974,10 +1970,9 @@
         <a:lstStyle/>
         <a:p>
           <a:r>
-            <a:rPr lang="en-GB" dirty="0"/>
+            <a:rPr lang="en-GB" noProof="0" dirty="0"/>
             <a:t>Custom fit cavity for battery</a:t>
           </a:r>
-          <a:endParaRPr lang="en-US" dirty="0"/>
         </a:p>
       </dgm:t>
     </dgm:pt>
@@ -2011,10 +2006,9 @@
         <a:lstStyle/>
         <a:p>
           <a:r>
-            <a:rPr lang="en-GB" dirty="0"/>
+            <a:rPr lang="en-GB" noProof="0" dirty="0"/>
             <a:t>Screwing points for PSOC6</a:t>
           </a:r>
-          <a:endParaRPr lang="en-US" dirty="0"/>
         </a:p>
       </dgm:t>
     </dgm:pt>
@@ -2048,10 +2042,9 @@
         <a:lstStyle/>
         <a:p>
           <a:r>
-            <a:rPr lang="en-GB"/>
+            <a:rPr lang="en-GB" noProof="0" dirty="0"/>
             <a:t>Result</a:t>
           </a:r>
-          <a:endParaRPr lang="en-US"/>
         </a:p>
       </dgm:t>
     </dgm:pt>
@@ -2085,10 +2078,9 @@
         <a:lstStyle/>
         <a:p>
           <a:r>
-            <a:rPr lang="en-GB" dirty="0"/>
+            <a:rPr lang="en-GB" noProof="0" dirty="0"/>
             <a:t>Worked perfectly during testing</a:t>
           </a:r>
-          <a:endParaRPr lang="en-US" dirty="0"/>
         </a:p>
       </dgm:t>
     </dgm:pt>
@@ -2263,10 +2255,9 @@
             </a:lnSpc>
           </a:pPr>
           <a:r>
-            <a:rPr lang="en-GB" sz="1600" dirty="0"/>
+            <a:rPr lang="en-GB" sz="1600" noProof="0" dirty="0"/>
             <a:t>Implementing the game function</a:t>
           </a:r>
-          <a:endParaRPr lang="en-US" sz="1600" dirty="0"/>
         </a:p>
       </dgm:t>
     </dgm:pt>
@@ -2310,10 +2301,9 @@
             </a:lnSpc>
           </a:pPr>
           <a:r>
-            <a:rPr lang="en-GB" sz="1600" dirty="0"/>
+            <a:rPr lang="en-GB" sz="1600" noProof="0" dirty="0"/>
             <a:t>Gathering more sampling data from more different people </a:t>
           </a:r>
-          <a:endParaRPr lang="en-US" sz="1600" dirty="0"/>
         </a:p>
       </dgm:t>
     </dgm:pt>
@@ -2357,10 +2347,9 @@
             </a:lnSpc>
           </a:pPr>
           <a:r>
-            <a:rPr lang="en-GB" sz="1600" dirty="0"/>
+            <a:rPr lang="en-GB" sz="1600" noProof="0" dirty="0"/>
             <a:t>Gather data of left-handed punches</a:t>
           </a:r>
-          <a:endParaRPr lang="en-US" sz="1600" dirty="0"/>
         </a:p>
       </dgm:t>
     </dgm:pt>
@@ -2404,10 +2393,9 @@
             </a:lnSpc>
           </a:pPr>
           <a:r>
-            <a:rPr lang="en-GB" sz="1600" dirty="0"/>
+            <a:rPr lang="en-GB" sz="1600" noProof="0" dirty="0"/>
             <a:t>Creation of charts for easier understanding/adding statistic analysis</a:t>
           </a:r>
-          <a:endParaRPr lang="en-US" sz="1600" dirty="0"/>
         </a:p>
       </dgm:t>
     </dgm:pt>
@@ -2786,10 +2774,9 @@
             <a:buChar char="•"/>
           </a:pPr>
           <a:r>
-            <a:rPr lang="en-GB" sz="1900" kern="1200" dirty="0"/>
+            <a:rPr lang="en-GB" sz="1900" kern="1200" noProof="0" dirty="0"/>
             <a:t>Accurate collection and evaluation of data</a:t>
           </a:r>
-          <a:endParaRPr lang="en-US" sz="1900" kern="1200" dirty="0"/>
         </a:p>
       </dsp:txBody>
       <dsp:txXfrm rot="-5400000">
@@ -2865,10 +2852,9 @@
             <a:buNone/>
           </a:pPr>
           <a:r>
-            <a:rPr lang="en-GB" sz="2000" kern="1200"/>
+            <a:rPr lang="en-GB" sz="2000" kern="1200" noProof="0" dirty="0"/>
             <a:t>Purpose</a:t>
           </a:r>
-          <a:endParaRPr lang="en-US" sz="2000" kern="1200"/>
         </a:p>
       </dsp:txBody>
       <dsp:txXfrm>
@@ -2946,10 +2932,9 @@
             <a:buChar char="•"/>
           </a:pPr>
           <a:r>
-            <a:rPr lang="en-GB" sz="1900" kern="1200" dirty="0"/>
+            <a:rPr lang="en-GB" sz="1900" kern="1200" noProof="0" dirty="0"/>
             <a:t>Holder fixation on box latch</a:t>
           </a:r>
-          <a:endParaRPr lang="en-US" sz="1900" kern="1200" dirty="0"/>
         </a:p>
         <a:p>
           <a:pPr marL="171450" lvl="1" indent="-171450" algn="l" defTabSz="844550">
@@ -2965,10 +2950,9 @@
             <a:buChar char="•"/>
           </a:pPr>
           <a:r>
-            <a:rPr lang="en-GB" sz="1900" kern="1200" dirty="0"/>
+            <a:rPr lang="en-GB" sz="1900" kern="1200" noProof="0" dirty="0"/>
             <a:t>Custom fit cavity for battery</a:t>
           </a:r>
-          <a:endParaRPr lang="en-US" sz="1900" kern="1200" dirty="0"/>
         </a:p>
         <a:p>
           <a:pPr marL="171450" lvl="1" indent="-171450" algn="l" defTabSz="844550">
@@ -2984,10 +2968,9 @@
             <a:buChar char="•"/>
           </a:pPr>
           <a:r>
-            <a:rPr lang="en-GB" sz="1900" kern="1200" dirty="0"/>
+            <a:rPr lang="en-GB" sz="1900" kern="1200" noProof="0" dirty="0"/>
             <a:t>Screwing points for PSOC6</a:t>
           </a:r>
-          <a:endParaRPr lang="en-US" sz="1900" kern="1200" dirty="0"/>
         </a:p>
       </dsp:txBody>
       <dsp:txXfrm rot="-5400000">
@@ -3063,10 +3046,9 @@
             <a:buNone/>
           </a:pPr>
           <a:r>
-            <a:rPr lang="en-GB" sz="2000" kern="1200"/>
+            <a:rPr lang="en-GB" sz="2000" kern="1200" noProof="0" dirty="0"/>
             <a:t>Construction</a:t>
           </a:r>
-          <a:endParaRPr lang="en-US" sz="2000" kern="1200"/>
         </a:p>
       </dsp:txBody>
       <dsp:txXfrm>
@@ -3144,10 +3126,9 @@
             <a:buChar char="•"/>
           </a:pPr>
           <a:r>
-            <a:rPr lang="en-GB" sz="1900" kern="1200" dirty="0"/>
+            <a:rPr lang="en-GB" sz="1900" kern="1200" noProof="0" dirty="0"/>
             <a:t>Worked perfectly during testing</a:t>
           </a:r>
-          <a:endParaRPr lang="en-US" sz="1900" kern="1200" dirty="0"/>
         </a:p>
       </dsp:txBody>
       <dsp:txXfrm rot="-5400000">
@@ -3223,10 +3204,9 @@
             <a:buNone/>
           </a:pPr>
           <a:r>
-            <a:rPr lang="en-GB" sz="2000" kern="1200"/>
+            <a:rPr lang="en-GB" sz="2000" kern="1200" noProof="0" dirty="0"/>
             <a:t>Result</a:t>
           </a:r>
-          <a:endParaRPr lang="en-US" sz="2000" kern="1200"/>
         </a:p>
       </dsp:txBody>
       <dsp:txXfrm>
@@ -3385,10 +3365,9 @@
             <a:buNone/>
           </a:pPr>
           <a:r>
-            <a:rPr lang="en-GB" sz="1600" kern="1200" dirty="0"/>
+            <a:rPr lang="en-GB" sz="1600" kern="1200" noProof="0" dirty="0"/>
             <a:t>Implementing the game function</a:t>
           </a:r>
-          <a:endParaRPr lang="en-US" sz="1600" kern="1200" dirty="0"/>
         </a:p>
       </dsp:txBody>
       <dsp:txXfrm>
@@ -3535,10 +3514,9 @@
             <a:buNone/>
           </a:pPr>
           <a:r>
-            <a:rPr lang="en-GB" sz="1600" kern="1200" dirty="0"/>
+            <a:rPr lang="en-GB" sz="1600" kern="1200" noProof="0" dirty="0"/>
             <a:t>Gathering more sampling data from more different people </a:t>
           </a:r>
-          <a:endParaRPr lang="en-US" sz="1600" kern="1200" dirty="0"/>
         </a:p>
       </dsp:txBody>
       <dsp:txXfrm>
@@ -3685,10 +3663,9 @@
             <a:buNone/>
           </a:pPr>
           <a:r>
-            <a:rPr lang="en-GB" sz="1600" kern="1200" dirty="0"/>
+            <a:rPr lang="en-GB" sz="1600" kern="1200" noProof="0" dirty="0"/>
             <a:t>Gather data of left-handed punches</a:t>
           </a:r>
-          <a:endParaRPr lang="en-US" sz="1600" kern="1200" dirty="0"/>
         </a:p>
       </dsp:txBody>
       <dsp:txXfrm>
@@ -3835,10 +3812,9 @@
             <a:buNone/>
           </a:pPr>
           <a:r>
-            <a:rPr lang="en-GB" sz="1600" kern="1200" dirty="0"/>
+            <a:rPr lang="en-GB" sz="1600" kern="1200" noProof="0" dirty="0"/>
             <a:t>Creation of charts for easier understanding/adding statistic analysis</a:t>
           </a:r>
-          <a:endParaRPr lang="en-US" sz="1600" kern="1200" dirty="0"/>
         </a:p>
       </dsp:txBody>
       <dsp:txXfrm>
@@ -8758,7 +8734,495 @@
           <a:bodyPr/>
           <a:lstStyle/>
           <a:p>
+            <a:r>
+              <a:rPr lang="de-AT" dirty="0"/>
+              <a:t>In </a:t>
+            </a:r>
+            <a:r>
+              <a:rPr lang="de-AT" dirty="0" err="1"/>
+              <a:t>the</a:t>
+            </a:r>
+            <a:r>
+              <a:rPr lang="de-AT" dirty="0"/>
+              <a:t> </a:t>
+            </a:r>
+            <a:r>
+              <a:rPr lang="de-AT" dirty="0" err="1"/>
+              <a:t>future</a:t>
+            </a:r>
+            <a:r>
+              <a:rPr lang="de-AT" dirty="0"/>
+              <a:t> </a:t>
+            </a:r>
+            <a:r>
+              <a:rPr lang="de-AT" dirty="0" err="1"/>
+              <a:t>we</a:t>
+            </a:r>
+            <a:r>
+              <a:rPr lang="de-AT" dirty="0"/>
+              <a:t> </a:t>
+            </a:r>
+            <a:r>
+              <a:rPr lang="de-AT" dirty="0" err="1"/>
+              <a:t>wanted</a:t>
+            </a:r>
+            <a:r>
+              <a:rPr lang="de-AT" dirty="0"/>
+              <a:t> </a:t>
+            </a:r>
+            <a:r>
+              <a:rPr lang="de-AT" dirty="0" err="1"/>
+              <a:t>to</a:t>
+            </a:r>
+            <a:r>
+              <a:rPr lang="de-AT" dirty="0"/>
+              <a:t> </a:t>
+            </a:r>
+            <a:r>
+              <a:rPr lang="de-AT" dirty="0" err="1"/>
+              <a:t>implement</a:t>
+            </a:r>
+            <a:r>
+              <a:rPr lang="de-AT" dirty="0"/>
+              <a:t> </a:t>
+            </a:r>
+            <a:r>
+              <a:rPr lang="de-AT" dirty="0" err="1"/>
+              <a:t>the</a:t>
+            </a:r>
+            <a:r>
+              <a:rPr lang="de-AT" dirty="0"/>
+              <a:t> game </a:t>
+            </a:r>
+            <a:r>
+              <a:rPr lang="de-AT" dirty="0" err="1"/>
+              <a:t>function</a:t>
+            </a:r>
+            <a:r>
+              <a:rPr lang="de-AT" dirty="0"/>
+              <a:t> </a:t>
+            </a:r>
+            <a:r>
+              <a:rPr lang="de-AT" dirty="0" err="1"/>
+              <a:t>that</a:t>
+            </a:r>
+            <a:r>
+              <a:rPr lang="de-AT" dirty="0"/>
+              <a:t> was </a:t>
+            </a:r>
+            <a:r>
+              <a:rPr lang="de-AT" dirty="0" err="1"/>
+              <a:t>mentioned</a:t>
+            </a:r>
+            <a:r>
+              <a:rPr lang="de-AT" dirty="0"/>
+              <a:t> </a:t>
+            </a:r>
+            <a:r>
+              <a:rPr lang="de-AT" dirty="0" err="1"/>
+              <a:t>earlier</a:t>
+            </a:r>
+            <a:r>
+              <a:rPr lang="de-AT" dirty="0"/>
+              <a:t> </a:t>
+            </a:r>
+          </a:p>
+          <a:p>
             <a:endParaRPr lang="de-AT" dirty="0"/>
+          </a:p>
+          <a:p>
+            <a:r>
+              <a:rPr lang="de-AT" dirty="0"/>
+              <a:t>Gather </a:t>
+            </a:r>
+            <a:r>
+              <a:rPr lang="de-AT" dirty="0" err="1"/>
+              <a:t>more</a:t>
+            </a:r>
+            <a:r>
+              <a:rPr lang="de-AT" dirty="0"/>
+              <a:t> </a:t>
+            </a:r>
+            <a:r>
+              <a:rPr lang="de-AT" dirty="0" err="1"/>
+              <a:t>data</a:t>
+            </a:r>
+            <a:r>
+              <a:rPr lang="de-AT" dirty="0"/>
+              <a:t> </a:t>
+            </a:r>
+            <a:r>
+              <a:rPr lang="de-AT" dirty="0" err="1"/>
+              <a:t>of</a:t>
+            </a:r>
+            <a:r>
+              <a:rPr lang="de-AT" dirty="0"/>
+              <a:t> different </a:t>
+            </a:r>
+            <a:r>
+              <a:rPr lang="de-AT" dirty="0" err="1"/>
+              <a:t>people</a:t>
+            </a:r>
+            <a:r>
+              <a:rPr lang="de-AT" dirty="0"/>
+              <a:t> and also </a:t>
+            </a:r>
+            <a:r>
+              <a:rPr lang="de-AT" dirty="0" err="1"/>
+              <a:t>have</a:t>
+            </a:r>
+            <a:r>
+              <a:rPr lang="de-AT" dirty="0"/>
+              <a:t> </a:t>
+            </a:r>
+            <a:r>
+              <a:rPr lang="de-AT" dirty="0" err="1"/>
+              <a:t>more</a:t>
+            </a:r>
+            <a:r>
+              <a:rPr lang="de-AT" dirty="0"/>
+              <a:t> </a:t>
+            </a:r>
+            <a:r>
+              <a:rPr lang="de-AT" dirty="0" err="1"/>
+              <a:t>session</a:t>
+            </a:r>
+            <a:r>
+              <a:rPr lang="de-AT" dirty="0"/>
+              <a:t> time in </a:t>
+            </a:r>
+            <a:r>
+              <a:rPr lang="de-AT" dirty="0" err="1"/>
+              <a:t>general</a:t>
+            </a:r>
+            <a:endParaRPr lang="de-AT" dirty="0"/>
+          </a:p>
+          <a:p>
+            <a:endParaRPr lang="de-AT" dirty="0"/>
+          </a:p>
+          <a:p>
+            <a:r>
+              <a:rPr lang="de-AT" dirty="0"/>
+              <a:t>Also </a:t>
+            </a:r>
+            <a:r>
+              <a:rPr lang="de-AT" dirty="0" err="1"/>
+              <a:t>implement</a:t>
+            </a:r>
+            <a:r>
+              <a:rPr lang="de-AT" dirty="0"/>
+              <a:t> </a:t>
+            </a:r>
+            <a:r>
+              <a:rPr lang="de-AT" dirty="0" err="1"/>
+              <a:t>the</a:t>
+            </a:r>
+            <a:r>
+              <a:rPr lang="de-AT" dirty="0"/>
+              <a:t> </a:t>
+            </a:r>
+            <a:r>
+              <a:rPr lang="de-AT" dirty="0" err="1"/>
+              <a:t>data</a:t>
+            </a:r>
+            <a:r>
+              <a:rPr lang="de-AT" dirty="0"/>
+              <a:t> </a:t>
+            </a:r>
+            <a:r>
+              <a:rPr lang="de-AT" dirty="0" err="1"/>
+              <a:t>of</a:t>
+            </a:r>
+            <a:r>
+              <a:rPr lang="de-AT" dirty="0"/>
+              <a:t> </a:t>
+            </a:r>
+            <a:r>
+              <a:rPr lang="de-AT" dirty="0" err="1"/>
+              <a:t>left-handed</a:t>
+            </a:r>
+            <a:r>
+              <a:rPr lang="de-AT" dirty="0"/>
+              <a:t> </a:t>
+            </a:r>
+            <a:r>
+              <a:rPr lang="de-AT" dirty="0" err="1"/>
+              <a:t>punches</a:t>
+            </a:r>
+            <a:r>
+              <a:rPr lang="de-AT" dirty="0"/>
+              <a:t> </a:t>
+            </a:r>
+            <a:r>
+              <a:rPr lang="de-AT" dirty="0" err="1"/>
+              <a:t>as</a:t>
+            </a:r>
+            <a:r>
+              <a:rPr lang="de-AT" dirty="0"/>
+              <a:t> </a:t>
+            </a:r>
+            <a:r>
+              <a:rPr lang="de-AT" dirty="0" err="1"/>
+              <a:t>the</a:t>
+            </a:r>
+            <a:r>
+              <a:rPr lang="de-AT" dirty="0"/>
+              <a:t> </a:t>
+            </a:r>
+            <a:r>
+              <a:rPr lang="de-AT" dirty="0" err="1"/>
+              <a:t>product</a:t>
+            </a:r>
+            <a:r>
+              <a:rPr lang="de-AT" dirty="0"/>
+              <a:t> </a:t>
+            </a:r>
+            <a:r>
+              <a:rPr lang="de-AT" dirty="0" err="1"/>
+              <a:t>is</a:t>
+            </a:r>
+            <a:r>
+              <a:rPr lang="de-AT" dirty="0"/>
+              <a:t> not </a:t>
+            </a:r>
+            <a:r>
+              <a:rPr lang="de-AT" dirty="0" err="1"/>
+              <a:t>very</a:t>
+            </a:r>
+            <a:r>
+              <a:rPr lang="de-AT" dirty="0"/>
+              <a:t> </a:t>
+            </a:r>
+            <a:r>
+              <a:rPr lang="de-AT" dirty="0" err="1"/>
+              <a:t>usable</a:t>
+            </a:r>
+            <a:r>
+              <a:rPr lang="de-AT" dirty="0"/>
+              <a:t> </a:t>
+            </a:r>
+            <a:r>
+              <a:rPr lang="de-AT" dirty="0" err="1"/>
+              <a:t>without</a:t>
+            </a:r>
+            <a:r>
+              <a:rPr lang="de-AT" dirty="0"/>
+              <a:t> </a:t>
+            </a:r>
+            <a:r>
+              <a:rPr lang="de-AT" dirty="0" err="1"/>
+              <a:t>it</a:t>
+            </a:r>
+            <a:endParaRPr lang="de-AT" dirty="0"/>
+          </a:p>
+          <a:p>
+            <a:endParaRPr lang="de-AT" dirty="0"/>
+          </a:p>
+          <a:p>
+            <a:r>
+              <a:rPr lang="de-AT" dirty="0"/>
+              <a:t>And </a:t>
+            </a:r>
+            <a:r>
+              <a:rPr lang="de-AT" dirty="0" err="1"/>
+              <a:t>finally</a:t>
+            </a:r>
+            <a:r>
+              <a:rPr lang="de-AT" dirty="0"/>
+              <a:t> </a:t>
+            </a:r>
+            <a:r>
+              <a:rPr lang="de-AT" dirty="0" err="1"/>
+              <a:t>create</a:t>
+            </a:r>
+            <a:r>
+              <a:rPr lang="de-AT" dirty="0"/>
+              <a:t> </a:t>
+            </a:r>
+            <a:r>
+              <a:rPr lang="de-AT" dirty="0" err="1"/>
+              <a:t>charts</a:t>
+            </a:r>
+            <a:r>
+              <a:rPr lang="de-AT" dirty="0"/>
+              <a:t> in </a:t>
+            </a:r>
+            <a:r>
+              <a:rPr lang="de-AT" dirty="0" err="1"/>
+              <a:t>the</a:t>
+            </a:r>
+            <a:r>
+              <a:rPr lang="de-AT" dirty="0"/>
+              <a:t> </a:t>
+            </a:r>
+            <a:r>
+              <a:rPr lang="de-AT" dirty="0" err="1"/>
+              <a:t>session</a:t>
+            </a:r>
+            <a:r>
+              <a:rPr lang="de-AT" dirty="0"/>
+              <a:t> </a:t>
+            </a:r>
+            <a:r>
+              <a:rPr lang="de-AT" dirty="0" err="1"/>
+              <a:t>analytics</a:t>
+            </a:r>
+            <a:r>
+              <a:rPr lang="de-AT" dirty="0"/>
+              <a:t> </a:t>
+            </a:r>
+            <a:r>
+              <a:rPr lang="de-AT" dirty="0" err="1"/>
+              <a:t>to</a:t>
+            </a:r>
+            <a:r>
+              <a:rPr lang="de-AT" dirty="0"/>
+              <a:t> </a:t>
+            </a:r>
+            <a:r>
+              <a:rPr lang="de-AT" dirty="0" err="1"/>
+              <a:t>make</a:t>
+            </a:r>
+            <a:r>
+              <a:rPr lang="de-AT" dirty="0"/>
+              <a:t> </a:t>
+            </a:r>
+            <a:r>
+              <a:rPr lang="de-AT" dirty="0" err="1"/>
+              <a:t>it</a:t>
+            </a:r>
+            <a:r>
+              <a:rPr lang="de-AT" dirty="0"/>
+              <a:t> </a:t>
+            </a:r>
+            <a:r>
+              <a:rPr lang="de-AT" dirty="0" err="1"/>
+              <a:t>easier</a:t>
+            </a:r>
+            <a:r>
+              <a:rPr lang="de-AT" dirty="0"/>
+              <a:t> </a:t>
+            </a:r>
+            <a:r>
+              <a:rPr lang="de-AT" dirty="0" err="1"/>
+              <a:t>for</a:t>
+            </a:r>
+            <a:r>
+              <a:rPr lang="de-AT" dirty="0"/>
+              <a:t> </a:t>
+            </a:r>
+            <a:r>
+              <a:rPr lang="de-AT" dirty="0" err="1"/>
+              <a:t>the</a:t>
+            </a:r>
+            <a:r>
+              <a:rPr lang="de-AT" dirty="0"/>
+              <a:t> </a:t>
+            </a:r>
+            <a:r>
+              <a:rPr lang="de-AT" dirty="0" err="1"/>
+              <a:t>user</a:t>
+            </a:r>
+            <a:r>
+              <a:rPr lang="de-AT" dirty="0"/>
+              <a:t> </a:t>
+            </a:r>
+            <a:r>
+              <a:rPr lang="de-AT" dirty="0" err="1"/>
+              <a:t>to</a:t>
+            </a:r>
+            <a:r>
+              <a:rPr lang="de-AT" dirty="0"/>
+              <a:t> </a:t>
+            </a:r>
+            <a:r>
+              <a:rPr lang="de-AT" dirty="0" err="1"/>
+              <a:t>see</a:t>
+            </a:r>
+            <a:r>
+              <a:rPr lang="de-AT" dirty="0"/>
+              <a:t> in </a:t>
+            </a:r>
+            <a:r>
+              <a:rPr lang="de-AT" dirty="0" err="1"/>
+              <a:t>the</a:t>
+            </a:r>
+            <a:r>
+              <a:rPr lang="de-AT" dirty="0"/>
+              <a:t> </a:t>
+            </a:r>
+            <a:r>
+              <a:rPr lang="de-AT" dirty="0" err="1"/>
+              <a:t>spot</a:t>
+            </a:r>
+            <a:r>
+              <a:rPr lang="de-AT" dirty="0"/>
+              <a:t> </a:t>
+            </a:r>
+            <a:r>
+              <a:rPr lang="de-AT" dirty="0" err="1"/>
+              <a:t>which</a:t>
+            </a:r>
+            <a:r>
+              <a:rPr lang="de-AT" dirty="0"/>
+              <a:t> </a:t>
+            </a:r>
+            <a:r>
+              <a:rPr lang="de-AT" dirty="0" err="1"/>
+              <a:t>punches</a:t>
+            </a:r>
+            <a:r>
+              <a:rPr lang="de-AT" dirty="0"/>
+              <a:t> and </a:t>
+            </a:r>
+            <a:r>
+              <a:rPr lang="de-AT" dirty="0" err="1"/>
+              <a:t>which</a:t>
+            </a:r>
+            <a:r>
+              <a:rPr lang="de-AT" dirty="0"/>
+              <a:t> </a:t>
+            </a:r>
+            <a:r>
+              <a:rPr lang="de-AT" dirty="0" err="1"/>
+              <a:t>combiantions</a:t>
+            </a:r>
+            <a:r>
+              <a:rPr lang="de-AT" dirty="0"/>
+              <a:t> </a:t>
+            </a:r>
+            <a:r>
+              <a:rPr lang="de-AT" dirty="0" err="1"/>
+              <a:t>were</a:t>
+            </a:r>
+            <a:r>
+              <a:rPr lang="de-AT" dirty="0"/>
+              <a:t> </a:t>
+            </a:r>
+            <a:r>
+              <a:rPr lang="de-AT" dirty="0" err="1"/>
+              <a:t>used</a:t>
+            </a:r>
+            <a:r>
+              <a:rPr lang="de-AT" dirty="0"/>
+              <a:t> </a:t>
+            </a:r>
+            <a:r>
+              <a:rPr lang="de-AT" dirty="0" err="1"/>
+              <a:t>the</a:t>
+            </a:r>
+            <a:r>
+              <a:rPr lang="de-AT" dirty="0"/>
+              <a:t> </a:t>
+            </a:r>
+            <a:r>
+              <a:rPr lang="de-AT" dirty="0" err="1"/>
+              <a:t>most</a:t>
+            </a:r>
+            <a:r>
+              <a:rPr lang="de-AT" dirty="0"/>
+              <a:t> </a:t>
+            </a:r>
           </a:p>
         </p:txBody>
       </p:sp>
@@ -8850,10 +9314,890 @@
           <a:lstStyle/>
           <a:p>
             <a:r>
-              <a:rPr lang="de-AT" dirty="0" err="1"/>
-              <a:t>Riedi</a:t>
-            </a:r>
+              <a:rPr lang="de-AT" dirty="0"/>
+              <a:t>The </a:t>
+            </a:r>
+            <a:r>
+              <a:rPr lang="de-AT" dirty="0" err="1"/>
+              <a:t>project</a:t>
+            </a:r>
+            <a:r>
+              <a:rPr lang="de-AT" dirty="0"/>
+              <a:t> </a:t>
+            </a:r>
+            <a:r>
+              <a:rPr lang="de-AT" dirty="0" err="1"/>
+              <a:t>idea</a:t>
+            </a:r>
+            <a:r>
+              <a:rPr lang="de-AT" dirty="0"/>
+              <a:t> was </a:t>
+            </a:r>
+            <a:r>
+              <a:rPr lang="de-AT" dirty="0" err="1"/>
+              <a:t>to</a:t>
+            </a:r>
+            <a:r>
+              <a:rPr lang="de-AT" dirty="0"/>
+              <a:t> </a:t>
+            </a:r>
+            <a:r>
+              <a:rPr lang="de-AT" dirty="0" err="1"/>
+              <a:t>detect</a:t>
+            </a:r>
+            <a:r>
+              <a:rPr lang="de-AT" dirty="0"/>
+              <a:t> and </a:t>
+            </a:r>
+            <a:r>
+              <a:rPr lang="de-AT" dirty="0" err="1"/>
+              <a:t>analyze</a:t>
+            </a:r>
+            <a:r>
+              <a:rPr lang="de-AT" dirty="0"/>
+              <a:t> </a:t>
+            </a:r>
+            <a:r>
+              <a:rPr lang="de-AT" dirty="0" err="1"/>
+              <a:t>thrown</a:t>
+            </a:r>
+            <a:r>
+              <a:rPr lang="de-AT" dirty="0"/>
+              <a:t> </a:t>
+            </a:r>
+            <a:r>
+              <a:rPr lang="de-AT" dirty="0" err="1"/>
+              <a:t>punches</a:t>
+            </a:r>
+            <a:r>
+              <a:rPr lang="de-AT" dirty="0"/>
+              <a:t> </a:t>
+            </a:r>
+            <a:r>
+              <a:rPr lang="de-AT" dirty="0" err="1"/>
+              <a:t>using</a:t>
+            </a:r>
+            <a:r>
+              <a:rPr lang="de-AT" dirty="0"/>
+              <a:t> </a:t>
+            </a:r>
+            <a:r>
+              <a:rPr lang="de-AT" dirty="0" err="1"/>
+              <a:t>the</a:t>
+            </a:r>
+            <a:r>
+              <a:rPr lang="de-AT" dirty="0"/>
+              <a:t> </a:t>
+            </a:r>
+            <a:r>
+              <a:rPr lang="de-AT" dirty="0" err="1"/>
+              <a:t>boards</a:t>
+            </a:r>
+            <a:r>
+              <a:rPr lang="de-AT" dirty="0"/>
+              <a:t> IMU</a:t>
+            </a:r>
+          </a:p>
+          <a:p>
             <a:endParaRPr lang="de-AT" dirty="0"/>
+          </a:p>
+          <a:p>
+            <a:r>
+              <a:rPr lang="de-AT" dirty="0"/>
+              <a:t>The </a:t>
+            </a:r>
+            <a:r>
+              <a:rPr lang="de-AT" dirty="0" err="1"/>
+              <a:t>punches</a:t>
+            </a:r>
+            <a:r>
+              <a:rPr lang="de-AT" dirty="0"/>
+              <a:t> </a:t>
+            </a:r>
+            <a:r>
+              <a:rPr lang="de-AT" dirty="0" err="1"/>
+              <a:t>we</a:t>
+            </a:r>
+            <a:r>
+              <a:rPr lang="de-AT" dirty="0"/>
+              <a:t> </a:t>
+            </a:r>
+            <a:r>
+              <a:rPr lang="de-AT" dirty="0" err="1"/>
+              <a:t>wanted</a:t>
+            </a:r>
+            <a:r>
+              <a:rPr lang="de-AT" dirty="0"/>
+              <a:t> </a:t>
+            </a:r>
+            <a:r>
+              <a:rPr lang="de-AT" dirty="0" err="1"/>
+              <a:t>to</a:t>
+            </a:r>
+            <a:r>
+              <a:rPr lang="de-AT" dirty="0"/>
+              <a:t> </a:t>
+            </a:r>
+            <a:r>
+              <a:rPr lang="de-AT" dirty="0" err="1"/>
+              <a:t>differentiate</a:t>
+            </a:r>
+            <a:r>
+              <a:rPr lang="de-AT" dirty="0"/>
+              <a:t> </a:t>
+            </a:r>
+            <a:r>
+              <a:rPr lang="de-AT" dirty="0" err="1"/>
+              <a:t>between</a:t>
+            </a:r>
+            <a:r>
+              <a:rPr lang="de-AT" dirty="0"/>
+              <a:t> </a:t>
+            </a:r>
+            <a:r>
+              <a:rPr lang="de-AT" dirty="0" err="1"/>
+              <a:t>were</a:t>
+            </a:r>
+            <a:r>
+              <a:rPr lang="de-AT" dirty="0"/>
+              <a:t> </a:t>
+            </a:r>
+            <a:r>
+              <a:rPr lang="de-AT" dirty="0" err="1"/>
+              <a:t>the</a:t>
+            </a:r>
+            <a:r>
+              <a:rPr lang="de-AT" dirty="0"/>
+              <a:t> </a:t>
+            </a:r>
+            <a:r>
+              <a:rPr lang="de-AT" dirty="0" err="1"/>
+              <a:t>jab</a:t>
+            </a:r>
+            <a:r>
+              <a:rPr lang="de-AT" dirty="0"/>
+              <a:t> , </a:t>
+            </a:r>
+            <a:r>
+              <a:rPr lang="de-AT" dirty="0" err="1"/>
+              <a:t>the</a:t>
+            </a:r>
+            <a:r>
+              <a:rPr lang="de-AT" dirty="0"/>
+              <a:t> hook and </a:t>
+            </a:r>
+            <a:r>
+              <a:rPr lang="de-AT" dirty="0" err="1"/>
+              <a:t>the</a:t>
+            </a:r>
+            <a:r>
+              <a:rPr lang="de-AT" dirty="0"/>
+              <a:t> </a:t>
+            </a:r>
+            <a:r>
+              <a:rPr lang="de-AT" dirty="0" err="1"/>
+              <a:t>uppercut</a:t>
+            </a:r>
+            <a:endParaRPr lang="de-AT" dirty="0"/>
+          </a:p>
+          <a:p>
+            <a:endParaRPr lang="de-AT" dirty="0"/>
+          </a:p>
+          <a:p>
+            <a:r>
+              <a:rPr lang="de-AT" dirty="0"/>
+              <a:t>The </a:t>
+            </a:r>
+            <a:r>
+              <a:rPr lang="de-AT" dirty="0" err="1"/>
+              <a:t>goal</a:t>
+            </a:r>
+            <a:r>
+              <a:rPr lang="de-AT" dirty="0"/>
+              <a:t> </a:t>
+            </a:r>
+            <a:r>
+              <a:rPr lang="de-AT" dirty="0" err="1"/>
+              <a:t>of</a:t>
+            </a:r>
+            <a:r>
+              <a:rPr lang="de-AT" dirty="0"/>
+              <a:t> </a:t>
+            </a:r>
+            <a:r>
+              <a:rPr lang="de-AT" dirty="0" err="1"/>
+              <a:t>this</a:t>
+            </a:r>
+            <a:r>
+              <a:rPr lang="de-AT" dirty="0"/>
+              <a:t> </a:t>
+            </a:r>
+            <a:r>
+              <a:rPr lang="de-AT" dirty="0" err="1"/>
+              <a:t>product</a:t>
+            </a:r>
+            <a:r>
+              <a:rPr lang="de-AT" dirty="0"/>
+              <a:t> </a:t>
+            </a:r>
+            <a:r>
+              <a:rPr lang="de-AT" dirty="0" err="1"/>
+              <a:t>or</a:t>
+            </a:r>
+            <a:r>
+              <a:rPr lang="de-AT" dirty="0"/>
+              <a:t> </a:t>
+            </a:r>
+            <a:r>
+              <a:rPr lang="de-AT" dirty="0" err="1"/>
+              <a:t>idea</a:t>
+            </a:r>
+            <a:r>
+              <a:rPr lang="de-AT" dirty="0"/>
+              <a:t> was </a:t>
+            </a:r>
+            <a:r>
+              <a:rPr lang="de-AT" dirty="0" err="1"/>
+              <a:t>to</a:t>
+            </a:r>
+            <a:r>
+              <a:rPr lang="de-AT" dirty="0"/>
+              <a:t> </a:t>
+            </a:r>
+            <a:r>
+              <a:rPr lang="de-AT" dirty="0" err="1"/>
+              <a:t>help</a:t>
+            </a:r>
+            <a:r>
+              <a:rPr lang="de-AT" dirty="0"/>
+              <a:t> </a:t>
+            </a:r>
+            <a:r>
+              <a:rPr lang="de-AT" dirty="0" err="1"/>
+              <a:t>boxers</a:t>
+            </a:r>
+            <a:r>
+              <a:rPr lang="de-AT" dirty="0"/>
+              <a:t> </a:t>
+            </a:r>
+            <a:r>
+              <a:rPr lang="de-AT" dirty="0" err="1"/>
+              <a:t>understand</a:t>
+            </a:r>
+            <a:r>
+              <a:rPr lang="de-AT" dirty="0"/>
+              <a:t> </a:t>
+            </a:r>
+            <a:r>
+              <a:rPr lang="de-AT" dirty="0" err="1"/>
+              <a:t>their</a:t>
+            </a:r>
+            <a:r>
+              <a:rPr lang="de-AT" dirty="0"/>
+              <a:t> </a:t>
+            </a:r>
+            <a:r>
+              <a:rPr lang="de-AT" dirty="0" err="1"/>
+              <a:t>performance</a:t>
+            </a:r>
+            <a:r>
+              <a:rPr lang="de-AT" dirty="0"/>
+              <a:t> </a:t>
+            </a:r>
+            <a:r>
+              <a:rPr lang="de-AT" dirty="0" err="1"/>
+              <a:t>during</a:t>
+            </a:r>
+            <a:r>
+              <a:rPr lang="de-AT" dirty="0"/>
+              <a:t> </a:t>
+            </a:r>
+            <a:r>
+              <a:rPr lang="de-AT" dirty="0" err="1"/>
+              <a:t>boxing</a:t>
+            </a:r>
+            <a:r>
+              <a:rPr lang="de-AT" dirty="0"/>
+              <a:t> </a:t>
+            </a:r>
+            <a:r>
+              <a:rPr lang="de-AT" dirty="0" err="1"/>
+              <a:t>sessions</a:t>
+            </a:r>
+            <a:r>
+              <a:rPr lang="de-AT" dirty="0"/>
+              <a:t> and </a:t>
+            </a:r>
+            <a:r>
+              <a:rPr lang="de-AT" dirty="0" err="1"/>
+              <a:t>prevent</a:t>
+            </a:r>
+            <a:r>
+              <a:rPr lang="de-AT" dirty="0"/>
+              <a:t> </a:t>
+            </a:r>
+            <a:r>
+              <a:rPr lang="de-AT" dirty="0" err="1"/>
+              <a:t>them</a:t>
+            </a:r>
+            <a:r>
+              <a:rPr lang="de-AT" dirty="0"/>
+              <a:t> </a:t>
+            </a:r>
+            <a:r>
+              <a:rPr lang="de-AT" dirty="0" err="1"/>
+              <a:t>from</a:t>
+            </a:r>
+            <a:r>
+              <a:rPr lang="de-AT" dirty="0"/>
+              <a:t> </a:t>
+            </a:r>
+            <a:r>
+              <a:rPr lang="de-AT" dirty="0" err="1"/>
+              <a:t>developing</a:t>
+            </a:r>
+            <a:r>
+              <a:rPr lang="de-AT" dirty="0"/>
+              <a:t> </a:t>
+            </a:r>
+            <a:r>
+              <a:rPr lang="de-AT" dirty="0" err="1"/>
+              <a:t>habits</a:t>
+            </a:r>
+            <a:r>
+              <a:rPr lang="de-AT" dirty="0"/>
+              <a:t> </a:t>
+            </a:r>
+            <a:r>
+              <a:rPr lang="de-AT" dirty="0" err="1"/>
+              <a:t>of</a:t>
+            </a:r>
+            <a:r>
+              <a:rPr lang="de-AT" dirty="0"/>
+              <a:t> </a:t>
+            </a:r>
+            <a:r>
+              <a:rPr lang="de-AT" dirty="0" err="1"/>
+              <a:t>overusing</a:t>
+            </a:r>
+            <a:r>
+              <a:rPr lang="de-AT" dirty="0"/>
+              <a:t> </a:t>
+            </a:r>
+            <a:r>
+              <a:rPr lang="de-AT" dirty="0" err="1"/>
+              <a:t>the</a:t>
+            </a:r>
+            <a:r>
+              <a:rPr lang="de-AT" dirty="0"/>
+              <a:t> same type </a:t>
+            </a:r>
+            <a:r>
+              <a:rPr lang="de-AT" dirty="0" err="1"/>
+              <a:t>of</a:t>
+            </a:r>
+            <a:r>
+              <a:rPr lang="de-AT" dirty="0"/>
+              <a:t> </a:t>
+            </a:r>
+            <a:r>
+              <a:rPr lang="de-AT" dirty="0" err="1"/>
+              <a:t>punch</a:t>
+            </a:r>
+            <a:r>
+              <a:rPr lang="de-AT" dirty="0"/>
+              <a:t> and </a:t>
+            </a:r>
+            <a:r>
+              <a:rPr lang="de-AT" dirty="0" err="1"/>
+              <a:t>become</a:t>
+            </a:r>
+            <a:r>
+              <a:rPr lang="de-AT" dirty="0"/>
+              <a:t> </a:t>
+            </a:r>
+            <a:r>
+              <a:rPr lang="de-AT" dirty="0" err="1"/>
+              <a:t>less</a:t>
+            </a:r>
+            <a:r>
+              <a:rPr lang="de-AT" dirty="0"/>
+              <a:t> </a:t>
+            </a:r>
+            <a:r>
+              <a:rPr lang="de-AT" dirty="0" err="1"/>
+              <a:t>predictable</a:t>
+            </a:r>
+            <a:r>
+              <a:rPr lang="de-AT" dirty="0"/>
+              <a:t> </a:t>
+            </a:r>
+            <a:r>
+              <a:rPr lang="de-AT" dirty="0" err="1"/>
+              <a:t>for</a:t>
+            </a:r>
+            <a:r>
+              <a:rPr lang="de-AT" dirty="0"/>
+              <a:t> </a:t>
+            </a:r>
+            <a:r>
+              <a:rPr lang="de-AT" dirty="0" err="1"/>
+              <a:t>their</a:t>
+            </a:r>
+            <a:r>
+              <a:rPr lang="de-AT" dirty="0"/>
+              <a:t> </a:t>
+            </a:r>
+            <a:r>
+              <a:rPr lang="de-AT" dirty="0" err="1"/>
+              <a:t>opponent</a:t>
+            </a:r>
+            <a:endParaRPr lang="de-AT" dirty="0"/>
+          </a:p>
+          <a:p>
+            <a:endParaRPr lang="de-AT" dirty="0"/>
+          </a:p>
+          <a:p>
+            <a:r>
+              <a:rPr lang="de-AT" dirty="0" err="1"/>
+              <a:t>We</a:t>
+            </a:r>
+            <a:r>
+              <a:rPr lang="de-AT" dirty="0"/>
+              <a:t> </a:t>
+            </a:r>
+            <a:r>
+              <a:rPr lang="de-AT" dirty="0" err="1"/>
+              <a:t>wanted</a:t>
+            </a:r>
+            <a:r>
+              <a:rPr lang="de-AT" dirty="0"/>
+              <a:t> </a:t>
+            </a:r>
+            <a:r>
+              <a:rPr lang="de-AT" dirty="0" err="1"/>
+              <a:t>to</a:t>
+            </a:r>
+            <a:r>
+              <a:rPr lang="de-AT" dirty="0"/>
+              <a:t> </a:t>
+            </a:r>
+            <a:r>
+              <a:rPr lang="de-AT" dirty="0" err="1"/>
+              <a:t>assist</a:t>
+            </a:r>
+            <a:r>
+              <a:rPr lang="de-AT" dirty="0"/>
+              <a:t> </a:t>
+            </a:r>
+            <a:r>
+              <a:rPr lang="de-AT" dirty="0" err="1"/>
+              <a:t>this</a:t>
+            </a:r>
+            <a:r>
+              <a:rPr lang="de-AT" dirty="0"/>
+              <a:t> </a:t>
+            </a:r>
+            <a:r>
+              <a:rPr lang="de-AT" dirty="0" err="1"/>
+              <a:t>process</a:t>
+            </a:r>
+            <a:r>
+              <a:rPr lang="de-AT" dirty="0"/>
+              <a:t> </a:t>
+            </a:r>
+            <a:r>
+              <a:rPr lang="de-AT" dirty="0" err="1"/>
+              <a:t>by</a:t>
+            </a:r>
+            <a:r>
+              <a:rPr lang="de-AT" dirty="0"/>
+              <a:t> </a:t>
+            </a:r>
+            <a:r>
+              <a:rPr lang="de-AT" dirty="0" err="1"/>
+              <a:t>implementing</a:t>
+            </a:r>
+            <a:r>
+              <a:rPr lang="de-AT" dirty="0"/>
+              <a:t> a game </a:t>
+            </a:r>
+            <a:r>
+              <a:rPr lang="de-AT" dirty="0" err="1"/>
+              <a:t>function</a:t>
+            </a:r>
+            <a:r>
+              <a:rPr lang="de-AT" dirty="0"/>
+              <a:t> in </a:t>
+            </a:r>
+            <a:r>
+              <a:rPr lang="de-AT" dirty="0" err="1"/>
+              <a:t>which</a:t>
+            </a:r>
+            <a:r>
+              <a:rPr lang="de-AT" dirty="0"/>
+              <a:t> </a:t>
+            </a:r>
+            <a:r>
+              <a:rPr lang="de-AT" dirty="0" err="1"/>
+              <a:t>the</a:t>
+            </a:r>
+            <a:r>
+              <a:rPr lang="de-AT" dirty="0"/>
+              <a:t> </a:t>
+            </a:r>
+            <a:r>
+              <a:rPr lang="de-AT" dirty="0" err="1"/>
+              <a:t>boxer</a:t>
+            </a:r>
+            <a:r>
+              <a:rPr lang="de-AT" dirty="0"/>
+              <a:t> </a:t>
+            </a:r>
+            <a:r>
+              <a:rPr lang="de-AT" dirty="0" err="1"/>
+              <a:t>gets</a:t>
+            </a:r>
+            <a:r>
+              <a:rPr lang="de-AT" dirty="0"/>
+              <a:t> </a:t>
+            </a:r>
+            <a:r>
+              <a:rPr lang="de-AT" dirty="0" err="1"/>
+              <a:t>rewarded</a:t>
+            </a:r>
+            <a:r>
+              <a:rPr lang="de-AT" dirty="0"/>
+              <a:t> </a:t>
+            </a:r>
+            <a:r>
+              <a:rPr lang="de-AT" dirty="0" err="1"/>
+              <a:t>points</a:t>
+            </a:r>
+            <a:r>
+              <a:rPr lang="de-AT" dirty="0"/>
+              <a:t> </a:t>
+            </a:r>
+            <a:r>
+              <a:rPr lang="de-AT" dirty="0" err="1"/>
+              <a:t>for</a:t>
+            </a:r>
+            <a:r>
+              <a:rPr lang="de-AT" dirty="0"/>
+              <a:t> </a:t>
+            </a:r>
+            <a:r>
+              <a:rPr lang="de-AT" dirty="0" err="1"/>
+              <a:t>following</a:t>
+            </a:r>
+            <a:r>
+              <a:rPr lang="de-AT" dirty="0"/>
+              <a:t> </a:t>
+            </a:r>
+            <a:r>
+              <a:rPr lang="de-AT" dirty="0" err="1"/>
+              <a:t>instructed</a:t>
+            </a:r>
+            <a:r>
+              <a:rPr lang="de-AT" dirty="0"/>
+              <a:t> </a:t>
+            </a:r>
+            <a:r>
+              <a:rPr lang="de-AT" dirty="0" err="1"/>
+              <a:t>punches</a:t>
+            </a:r>
+            <a:endParaRPr lang="de-AT" dirty="0"/>
+          </a:p>
+          <a:p>
+            <a:endParaRPr lang="de-AT" dirty="0"/>
+          </a:p>
+          <a:p>
+            <a:r>
+              <a:rPr lang="de-AT" dirty="0"/>
+              <a:t>These </a:t>
+            </a:r>
+            <a:r>
+              <a:rPr lang="de-AT" dirty="0" err="1"/>
+              <a:t>punches</a:t>
+            </a:r>
+            <a:r>
+              <a:rPr lang="de-AT" dirty="0"/>
+              <a:t> </a:t>
+            </a:r>
+            <a:r>
+              <a:rPr lang="de-AT" dirty="0" err="1"/>
+              <a:t>would</a:t>
+            </a:r>
+            <a:r>
+              <a:rPr lang="de-AT" dirty="0"/>
+              <a:t> </a:t>
+            </a:r>
+            <a:r>
+              <a:rPr lang="de-AT" dirty="0" err="1"/>
+              <a:t>be</a:t>
+            </a:r>
+            <a:r>
+              <a:rPr lang="de-AT" dirty="0"/>
+              <a:t> </a:t>
+            </a:r>
+            <a:r>
+              <a:rPr lang="de-AT" dirty="0" err="1"/>
+              <a:t>ordered</a:t>
+            </a:r>
+            <a:r>
+              <a:rPr lang="de-AT" dirty="0"/>
+              <a:t> in a </a:t>
+            </a:r>
+            <a:r>
+              <a:rPr lang="de-AT" dirty="0" err="1"/>
+              <a:t>way</a:t>
+            </a:r>
+            <a:r>
+              <a:rPr lang="de-AT" dirty="0"/>
+              <a:t> </a:t>
+            </a:r>
+            <a:r>
+              <a:rPr lang="de-AT" dirty="0" err="1"/>
+              <a:t>that</a:t>
+            </a:r>
+            <a:r>
+              <a:rPr lang="de-AT" dirty="0"/>
+              <a:t> </a:t>
+            </a:r>
+            <a:r>
+              <a:rPr lang="de-AT" dirty="0" err="1"/>
+              <a:t>the</a:t>
+            </a:r>
+            <a:r>
+              <a:rPr lang="de-AT" dirty="0"/>
+              <a:t> </a:t>
+            </a:r>
+            <a:r>
+              <a:rPr lang="de-AT" dirty="0" err="1"/>
+              <a:t>boxer</a:t>
+            </a:r>
+            <a:r>
+              <a:rPr lang="de-AT" dirty="0"/>
+              <a:t> </a:t>
+            </a:r>
+            <a:r>
+              <a:rPr lang="de-AT" dirty="0" err="1"/>
+              <a:t>always</a:t>
+            </a:r>
+            <a:r>
+              <a:rPr lang="de-AT" dirty="0"/>
+              <a:t> </a:t>
+            </a:r>
+            <a:r>
+              <a:rPr lang="de-AT" dirty="0" err="1"/>
+              <a:t>uses</a:t>
+            </a:r>
+            <a:r>
+              <a:rPr lang="de-AT" dirty="0"/>
+              <a:t> different </a:t>
+            </a:r>
+            <a:r>
+              <a:rPr lang="de-AT" dirty="0" err="1"/>
+              <a:t>combinations</a:t>
+            </a:r>
+            <a:r>
+              <a:rPr lang="de-AT" dirty="0"/>
+              <a:t> and </a:t>
+            </a:r>
+            <a:r>
+              <a:rPr lang="de-AT" dirty="0" err="1"/>
+              <a:t>the</a:t>
+            </a:r>
+            <a:r>
+              <a:rPr lang="de-AT" dirty="0"/>
+              <a:t> </a:t>
+            </a:r>
+            <a:r>
+              <a:rPr lang="de-AT" dirty="0" err="1"/>
+              <a:t>longer</a:t>
+            </a:r>
+            <a:r>
+              <a:rPr lang="de-AT" dirty="0"/>
+              <a:t> he </a:t>
+            </a:r>
+            <a:r>
+              <a:rPr lang="de-AT" dirty="0" err="1"/>
+              <a:t>can</a:t>
+            </a:r>
+            <a:r>
+              <a:rPr lang="de-AT" dirty="0"/>
+              <a:t> hold out and </a:t>
+            </a:r>
+            <a:r>
+              <a:rPr lang="de-AT" dirty="0" err="1"/>
+              <a:t>the</a:t>
+            </a:r>
+            <a:r>
+              <a:rPr lang="de-AT" dirty="0"/>
+              <a:t> </a:t>
+            </a:r>
+            <a:r>
+              <a:rPr lang="de-AT" dirty="0" err="1"/>
+              <a:t>better</a:t>
+            </a:r>
+            <a:r>
+              <a:rPr lang="de-AT" dirty="0"/>
+              <a:t> </a:t>
+            </a:r>
+            <a:r>
+              <a:rPr lang="de-AT" dirty="0" err="1"/>
+              <a:t>the</a:t>
+            </a:r>
+            <a:r>
+              <a:rPr lang="de-AT" dirty="0"/>
+              <a:t> </a:t>
+            </a:r>
+            <a:r>
+              <a:rPr lang="de-AT" dirty="0" err="1"/>
+              <a:t>punch</a:t>
+            </a:r>
+            <a:r>
+              <a:rPr lang="de-AT" dirty="0"/>
+              <a:t> </a:t>
+            </a:r>
+            <a:r>
+              <a:rPr lang="de-AT" dirty="0" err="1"/>
+              <a:t>is</a:t>
+            </a:r>
+            <a:r>
+              <a:rPr lang="de-AT" dirty="0"/>
+              <a:t> </a:t>
+            </a:r>
+            <a:r>
+              <a:rPr lang="de-AT" dirty="0" err="1"/>
+              <a:t>thrown</a:t>
+            </a:r>
+            <a:r>
+              <a:rPr lang="de-AT" dirty="0"/>
+              <a:t> </a:t>
+            </a:r>
+            <a:r>
+              <a:rPr lang="de-AT" dirty="0" err="1"/>
+              <a:t>the</a:t>
+            </a:r>
+            <a:r>
+              <a:rPr lang="de-AT" dirty="0"/>
+              <a:t> </a:t>
+            </a:r>
+            <a:r>
+              <a:rPr lang="de-AT" dirty="0" err="1"/>
+              <a:t>more</a:t>
+            </a:r>
+            <a:r>
+              <a:rPr lang="de-AT" dirty="0"/>
+              <a:t> </a:t>
+            </a:r>
+            <a:r>
+              <a:rPr lang="de-AT" dirty="0" err="1"/>
+              <a:t>points</a:t>
+            </a:r>
+            <a:r>
+              <a:rPr lang="de-AT" dirty="0"/>
+              <a:t> he </a:t>
+            </a:r>
+            <a:r>
+              <a:rPr lang="de-AT" dirty="0" err="1"/>
+              <a:t>gets</a:t>
+            </a:r>
+            <a:endParaRPr lang="de-AT" dirty="0"/>
+          </a:p>
+          <a:p>
+            <a:endParaRPr lang="de-AT" dirty="0"/>
+          </a:p>
+          <a:p>
+            <a:r>
+              <a:rPr lang="de-AT" dirty="0" err="1"/>
+              <a:t>Sadly</a:t>
+            </a:r>
+            <a:r>
+              <a:rPr lang="de-AT" dirty="0"/>
+              <a:t> </a:t>
+            </a:r>
+            <a:r>
+              <a:rPr lang="de-AT" dirty="0" err="1"/>
+              <a:t>the</a:t>
+            </a:r>
+            <a:r>
+              <a:rPr lang="de-AT" dirty="0"/>
+              <a:t> </a:t>
+            </a:r>
+            <a:r>
+              <a:rPr lang="de-AT" dirty="0" err="1"/>
+              <a:t>timespan</a:t>
+            </a:r>
+            <a:r>
+              <a:rPr lang="de-AT" dirty="0"/>
+              <a:t> </a:t>
+            </a:r>
+            <a:r>
+              <a:rPr lang="de-AT" dirty="0" err="1"/>
+              <a:t>of</a:t>
+            </a:r>
+            <a:r>
+              <a:rPr lang="de-AT" dirty="0"/>
+              <a:t> </a:t>
+            </a:r>
+            <a:r>
+              <a:rPr lang="de-AT" dirty="0" err="1"/>
+              <a:t>this</a:t>
+            </a:r>
+            <a:r>
+              <a:rPr lang="de-AT" dirty="0"/>
+              <a:t> </a:t>
+            </a:r>
+            <a:r>
+              <a:rPr lang="de-AT" dirty="0" err="1"/>
+              <a:t>project</a:t>
+            </a:r>
+            <a:r>
+              <a:rPr lang="de-AT" dirty="0"/>
+              <a:t> was not </a:t>
+            </a:r>
+            <a:r>
+              <a:rPr lang="de-AT" dirty="0" err="1"/>
+              <a:t>enough</a:t>
+            </a:r>
+            <a:r>
+              <a:rPr lang="de-AT" dirty="0"/>
+              <a:t> </a:t>
+            </a:r>
+            <a:r>
+              <a:rPr lang="de-AT" dirty="0" err="1"/>
+              <a:t>to</a:t>
+            </a:r>
+            <a:r>
+              <a:rPr lang="de-AT" dirty="0"/>
+              <a:t> </a:t>
+            </a:r>
+            <a:r>
+              <a:rPr lang="de-AT" dirty="0" err="1"/>
+              <a:t>implement</a:t>
+            </a:r>
+            <a:r>
+              <a:rPr lang="de-AT" dirty="0"/>
+              <a:t> </a:t>
+            </a:r>
+            <a:r>
+              <a:rPr lang="de-AT" dirty="0" err="1"/>
+              <a:t>this</a:t>
+            </a:r>
+            <a:r>
+              <a:rPr lang="de-AT" dirty="0"/>
+              <a:t> </a:t>
+            </a:r>
+            <a:r>
+              <a:rPr lang="de-AT" dirty="0" err="1"/>
+              <a:t>function</a:t>
+            </a:r>
+            <a:r>
+              <a:rPr lang="de-AT" dirty="0"/>
+              <a:t> </a:t>
+            </a:r>
           </a:p>
         </p:txBody>
       </p:sp>
@@ -8946,7 +10290,663 @@
           <a:p>
             <a:r>
               <a:rPr lang="de-AT" dirty="0" err="1"/>
-              <a:t>Riedi</a:t>
+              <a:t>We</a:t>
+            </a:r>
+            <a:r>
+              <a:rPr lang="de-AT" dirty="0"/>
+              <a:t> </a:t>
+            </a:r>
+            <a:r>
+              <a:rPr lang="de-AT" dirty="0" err="1"/>
+              <a:t>designed</a:t>
+            </a:r>
+            <a:r>
+              <a:rPr lang="de-AT" dirty="0"/>
+              <a:t> a holder </a:t>
+            </a:r>
+            <a:r>
+              <a:rPr lang="de-AT" dirty="0" err="1"/>
+              <a:t>for</a:t>
+            </a:r>
+            <a:r>
+              <a:rPr lang="de-AT" dirty="0"/>
+              <a:t> </a:t>
+            </a:r>
+            <a:r>
+              <a:rPr lang="de-AT" dirty="0" err="1"/>
+              <a:t>the</a:t>
+            </a:r>
+            <a:r>
+              <a:rPr lang="de-AT" dirty="0"/>
+              <a:t> </a:t>
+            </a:r>
+            <a:r>
+              <a:rPr lang="de-AT" dirty="0" err="1"/>
+              <a:t>board</a:t>
+            </a:r>
+            <a:r>
+              <a:rPr lang="de-AT" dirty="0"/>
+              <a:t> </a:t>
+            </a:r>
+            <a:r>
+              <a:rPr lang="de-AT" dirty="0" err="1"/>
+              <a:t>with</a:t>
+            </a:r>
+            <a:r>
+              <a:rPr lang="de-AT" dirty="0"/>
+              <a:t> </a:t>
+            </a:r>
+            <a:r>
+              <a:rPr lang="de-AT" dirty="0" err="1"/>
+              <a:t>the</a:t>
+            </a:r>
+            <a:r>
+              <a:rPr lang="de-AT" dirty="0"/>
+              <a:t> </a:t>
+            </a:r>
+            <a:r>
+              <a:rPr lang="de-AT" dirty="0" err="1"/>
+              <a:t>intention</a:t>
+            </a:r>
+            <a:r>
+              <a:rPr lang="de-AT" dirty="0"/>
+              <a:t> </a:t>
+            </a:r>
+            <a:r>
+              <a:rPr lang="de-AT" dirty="0" err="1"/>
+              <a:t>to</a:t>
+            </a:r>
+            <a:r>
+              <a:rPr lang="de-AT" dirty="0"/>
+              <a:t> </a:t>
+            </a:r>
+            <a:r>
+              <a:rPr lang="de-AT" dirty="0" err="1"/>
+              <a:t>meassure</a:t>
+            </a:r>
+            <a:r>
+              <a:rPr lang="de-AT" dirty="0"/>
+              <a:t> and </a:t>
+            </a:r>
+            <a:r>
+              <a:rPr lang="de-AT" dirty="0" err="1"/>
+              <a:t>evaluate</a:t>
+            </a:r>
+            <a:r>
+              <a:rPr lang="de-AT" dirty="0"/>
+              <a:t> </a:t>
+            </a:r>
+            <a:r>
+              <a:rPr lang="de-AT" dirty="0" err="1"/>
+              <a:t>data</a:t>
+            </a:r>
+            <a:r>
+              <a:rPr lang="de-AT" dirty="0"/>
+              <a:t> </a:t>
+            </a:r>
+            <a:r>
+              <a:rPr lang="de-AT" dirty="0" err="1"/>
+              <a:t>as</a:t>
+            </a:r>
+            <a:r>
+              <a:rPr lang="de-AT" dirty="0"/>
+              <a:t> </a:t>
+            </a:r>
+            <a:r>
+              <a:rPr lang="de-AT" dirty="0" err="1"/>
+              <a:t>closely</a:t>
+            </a:r>
+            <a:r>
+              <a:rPr lang="de-AT" dirty="0"/>
+              <a:t> </a:t>
+            </a:r>
+            <a:r>
+              <a:rPr lang="de-AT" dirty="0" err="1"/>
+              <a:t>as</a:t>
+            </a:r>
+            <a:r>
+              <a:rPr lang="de-AT" dirty="0"/>
+              <a:t> </a:t>
+            </a:r>
+            <a:r>
+              <a:rPr lang="de-AT" dirty="0" err="1"/>
+              <a:t>it</a:t>
+            </a:r>
+            <a:r>
+              <a:rPr lang="de-AT" dirty="0"/>
+              <a:t> </a:t>
+            </a:r>
+            <a:r>
+              <a:rPr lang="de-AT" dirty="0" err="1"/>
+              <a:t>would</a:t>
+            </a:r>
+            <a:r>
+              <a:rPr lang="de-AT" dirty="0"/>
+              <a:t> happen in a real </a:t>
+            </a:r>
+            <a:r>
+              <a:rPr lang="de-AT" dirty="0" err="1"/>
+              <a:t>life</a:t>
+            </a:r>
+            <a:r>
+              <a:rPr lang="de-AT" dirty="0"/>
+              <a:t> </a:t>
+            </a:r>
+            <a:r>
+              <a:rPr lang="de-AT" dirty="0" err="1"/>
+              <a:t>application</a:t>
+            </a:r>
+            <a:endParaRPr lang="de-AT" dirty="0"/>
+          </a:p>
+          <a:p>
+            <a:endParaRPr lang="de-AT" dirty="0"/>
+          </a:p>
+          <a:p>
+            <a:r>
+              <a:rPr lang="de-AT" dirty="0" err="1"/>
+              <a:t>For</a:t>
+            </a:r>
+            <a:r>
+              <a:rPr lang="de-AT" dirty="0"/>
+              <a:t> </a:t>
+            </a:r>
+            <a:r>
+              <a:rPr lang="de-AT" dirty="0" err="1"/>
+              <a:t>this</a:t>
+            </a:r>
+            <a:r>
+              <a:rPr lang="de-AT" dirty="0"/>
+              <a:t> </a:t>
+            </a:r>
+            <a:r>
+              <a:rPr lang="de-AT" dirty="0" err="1"/>
+              <a:t>we</a:t>
+            </a:r>
+            <a:r>
+              <a:rPr lang="de-AT" dirty="0"/>
+              <a:t> </a:t>
+            </a:r>
+            <a:r>
+              <a:rPr lang="de-AT" dirty="0" err="1"/>
+              <a:t>constructed</a:t>
+            </a:r>
+            <a:r>
+              <a:rPr lang="de-AT" dirty="0"/>
+              <a:t> a 3d printed </a:t>
+            </a:r>
+            <a:r>
+              <a:rPr lang="de-AT" dirty="0" err="1"/>
+              <a:t>model</a:t>
+            </a:r>
+            <a:r>
+              <a:rPr lang="de-AT" dirty="0"/>
+              <a:t> </a:t>
+            </a:r>
+            <a:r>
+              <a:rPr lang="de-AT" dirty="0" err="1"/>
+              <a:t>that</a:t>
+            </a:r>
+            <a:r>
+              <a:rPr lang="de-AT" dirty="0"/>
+              <a:t> </a:t>
+            </a:r>
+            <a:r>
+              <a:rPr lang="de-AT" dirty="0" err="1"/>
+              <a:t>uses</a:t>
+            </a:r>
+            <a:r>
+              <a:rPr lang="de-AT" dirty="0"/>
+              <a:t> </a:t>
+            </a:r>
+            <a:r>
+              <a:rPr lang="de-AT" dirty="0" err="1"/>
+              <a:t>the</a:t>
+            </a:r>
+            <a:r>
+              <a:rPr lang="de-AT" dirty="0"/>
+              <a:t> </a:t>
+            </a:r>
+            <a:r>
+              <a:rPr lang="de-AT" dirty="0" err="1"/>
+              <a:t>boxing</a:t>
+            </a:r>
+            <a:r>
+              <a:rPr lang="de-AT" dirty="0"/>
+              <a:t> </a:t>
+            </a:r>
+            <a:r>
+              <a:rPr lang="de-AT" dirty="0" err="1"/>
+              <a:t>glove‘s</a:t>
+            </a:r>
+            <a:r>
+              <a:rPr lang="de-AT" dirty="0"/>
+              <a:t> </a:t>
+            </a:r>
+            <a:r>
+              <a:rPr lang="de-AT" dirty="0" err="1"/>
+              <a:t>latch</a:t>
+            </a:r>
+            <a:r>
+              <a:rPr lang="de-AT" dirty="0"/>
+              <a:t> </a:t>
+            </a:r>
+            <a:r>
+              <a:rPr lang="de-AT" dirty="0" err="1"/>
+              <a:t>to</a:t>
+            </a:r>
+            <a:r>
+              <a:rPr lang="de-AT" dirty="0"/>
+              <a:t> </a:t>
+            </a:r>
+            <a:r>
+              <a:rPr lang="de-AT" dirty="0" err="1"/>
+              <a:t>fixiate</a:t>
+            </a:r>
+            <a:r>
+              <a:rPr lang="de-AT" dirty="0"/>
+              <a:t> </a:t>
+            </a:r>
+            <a:r>
+              <a:rPr lang="de-AT" dirty="0" err="1"/>
+              <a:t>onto</a:t>
+            </a:r>
+            <a:r>
+              <a:rPr lang="de-AT" dirty="0"/>
+              <a:t>. This happend </a:t>
+            </a:r>
+            <a:r>
+              <a:rPr lang="de-AT" dirty="0" err="1"/>
+              <a:t>by</a:t>
+            </a:r>
+            <a:r>
+              <a:rPr lang="de-AT" dirty="0"/>
+              <a:t> </a:t>
+            </a:r>
+            <a:r>
+              <a:rPr lang="de-AT" dirty="0" err="1"/>
+              <a:t>threading</a:t>
+            </a:r>
+            <a:r>
+              <a:rPr lang="de-AT" dirty="0"/>
+              <a:t> </a:t>
+            </a:r>
+            <a:r>
+              <a:rPr lang="de-AT" dirty="0" err="1"/>
+              <a:t>the</a:t>
+            </a:r>
+            <a:r>
+              <a:rPr lang="de-AT" dirty="0"/>
+              <a:t> </a:t>
+            </a:r>
+            <a:r>
+              <a:rPr lang="de-AT" dirty="0" err="1"/>
+              <a:t>latch</a:t>
+            </a:r>
+            <a:r>
+              <a:rPr lang="de-AT" dirty="0"/>
+              <a:t> </a:t>
+            </a:r>
+            <a:r>
+              <a:rPr lang="de-AT" dirty="0" err="1"/>
+              <a:t>through</a:t>
+            </a:r>
+            <a:r>
+              <a:rPr lang="de-AT" dirty="0"/>
+              <a:t> a hole in </a:t>
+            </a:r>
+            <a:r>
+              <a:rPr lang="de-AT" dirty="0" err="1"/>
+              <a:t>the</a:t>
+            </a:r>
+            <a:r>
+              <a:rPr lang="de-AT" dirty="0"/>
+              <a:t> holder</a:t>
+            </a:r>
+          </a:p>
+          <a:p>
+            <a:endParaRPr lang="de-AT" dirty="0"/>
+          </a:p>
+          <a:p>
+            <a:r>
+              <a:rPr lang="de-AT" dirty="0"/>
+              <a:t>On top </a:t>
+            </a:r>
+            <a:r>
+              <a:rPr lang="de-AT" dirty="0" err="1"/>
+              <a:t>of</a:t>
+            </a:r>
+            <a:r>
+              <a:rPr lang="de-AT" dirty="0"/>
+              <a:t> </a:t>
+            </a:r>
+            <a:r>
+              <a:rPr lang="de-AT" dirty="0" err="1"/>
+              <a:t>this</a:t>
+            </a:r>
+            <a:r>
+              <a:rPr lang="de-AT" dirty="0"/>
+              <a:t> hole </a:t>
+            </a:r>
+            <a:r>
+              <a:rPr lang="de-AT" dirty="0" err="1"/>
+              <a:t>is</a:t>
+            </a:r>
+            <a:r>
+              <a:rPr lang="de-AT" dirty="0"/>
+              <a:t> a </a:t>
+            </a:r>
+            <a:r>
+              <a:rPr lang="de-AT" dirty="0" err="1"/>
+              <a:t>custom</a:t>
+            </a:r>
+            <a:r>
+              <a:rPr lang="de-AT" dirty="0"/>
+              <a:t> fit </a:t>
+            </a:r>
+            <a:r>
+              <a:rPr lang="de-AT" dirty="0" err="1"/>
+              <a:t>cavity</a:t>
+            </a:r>
+            <a:r>
+              <a:rPr lang="de-AT" dirty="0"/>
+              <a:t> </a:t>
+            </a:r>
+            <a:r>
+              <a:rPr lang="de-AT" dirty="0" err="1"/>
+              <a:t>for</a:t>
+            </a:r>
+            <a:r>
+              <a:rPr lang="de-AT" dirty="0"/>
+              <a:t> </a:t>
+            </a:r>
+            <a:r>
+              <a:rPr lang="de-AT" dirty="0" err="1"/>
+              <a:t>the</a:t>
+            </a:r>
+            <a:r>
+              <a:rPr lang="de-AT" dirty="0"/>
+              <a:t> </a:t>
+            </a:r>
+            <a:r>
+              <a:rPr lang="de-AT" dirty="0" err="1"/>
+              <a:t>battery</a:t>
+            </a:r>
+            <a:r>
+              <a:rPr lang="de-AT" dirty="0"/>
+              <a:t> </a:t>
+            </a:r>
+            <a:r>
+              <a:rPr lang="de-AT" dirty="0" err="1"/>
+              <a:t>that</a:t>
+            </a:r>
+            <a:r>
+              <a:rPr lang="de-AT" dirty="0"/>
+              <a:t> was </a:t>
+            </a:r>
+            <a:r>
+              <a:rPr lang="de-AT" dirty="0" err="1"/>
+              <a:t>borrowed</a:t>
+            </a:r>
+            <a:r>
+              <a:rPr lang="de-AT" dirty="0"/>
+              <a:t> </a:t>
+            </a:r>
+            <a:r>
+              <a:rPr lang="de-AT" dirty="0" err="1"/>
+              <a:t>to</a:t>
+            </a:r>
+            <a:r>
+              <a:rPr lang="de-AT" dirty="0"/>
+              <a:t> </a:t>
+            </a:r>
+            <a:r>
+              <a:rPr lang="de-AT" dirty="0" err="1"/>
+              <a:t>us</a:t>
+            </a:r>
+            <a:r>
+              <a:rPr lang="de-AT" dirty="0"/>
+              <a:t> and on top </a:t>
+            </a:r>
+            <a:r>
+              <a:rPr lang="de-AT" dirty="0" err="1"/>
+              <a:t>of</a:t>
+            </a:r>
+            <a:r>
+              <a:rPr lang="de-AT" dirty="0"/>
+              <a:t> </a:t>
+            </a:r>
+            <a:r>
+              <a:rPr lang="de-AT" dirty="0" err="1"/>
+              <a:t>that</a:t>
+            </a:r>
+            <a:r>
+              <a:rPr lang="de-AT" dirty="0"/>
+              <a:t> </a:t>
+            </a:r>
+            <a:r>
+              <a:rPr lang="de-AT" dirty="0" err="1"/>
+              <a:t>is</a:t>
+            </a:r>
+            <a:r>
+              <a:rPr lang="de-AT" dirty="0"/>
+              <a:t> </a:t>
+            </a:r>
+            <a:r>
+              <a:rPr lang="de-AT" dirty="0" err="1"/>
+              <a:t>the</a:t>
+            </a:r>
+            <a:r>
+              <a:rPr lang="de-AT" dirty="0"/>
+              <a:t> </a:t>
+            </a:r>
+            <a:r>
+              <a:rPr lang="de-AT" dirty="0" err="1"/>
+              <a:t>PsoC</a:t>
+            </a:r>
+            <a:r>
+              <a:rPr lang="de-AT" dirty="0"/>
+              <a:t> </a:t>
+            </a:r>
+            <a:r>
+              <a:rPr lang="de-AT" dirty="0" err="1"/>
+              <a:t>that</a:t>
+            </a:r>
+            <a:r>
+              <a:rPr lang="de-AT" dirty="0"/>
+              <a:t> </a:t>
+            </a:r>
+            <a:r>
+              <a:rPr lang="de-AT" dirty="0" err="1"/>
+              <a:t>is</a:t>
+            </a:r>
+            <a:r>
+              <a:rPr lang="de-AT" dirty="0"/>
+              <a:t> </a:t>
+            </a:r>
+            <a:r>
+              <a:rPr lang="de-AT" dirty="0" err="1"/>
+              <a:t>simply</a:t>
+            </a:r>
+            <a:r>
+              <a:rPr lang="de-AT" dirty="0"/>
+              <a:t> </a:t>
+            </a:r>
+            <a:r>
+              <a:rPr lang="de-AT" dirty="0" err="1"/>
+              <a:t>screwed</a:t>
+            </a:r>
+            <a:r>
+              <a:rPr lang="de-AT" dirty="0"/>
+              <a:t> on.</a:t>
+            </a:r>
+          </a:p>
+          <a:p>
+            <a:endParaRPr lang="de-AT" dirty="0"/>
+          </a:p>
+          <a:p>
+            <a:r>
+              <a:rPr lang="de-AT" dirty="0" err="1"/>
+              <a:t>During</a:t>
+            </a:r>
+            <a:r>
+              <a:rPr lang="de-AT" dirty="0"/>
+              <a:t> </a:t>
+            </a:r>
+            <a:r>
+              <a:rPr lang="de-AT" dirty="0" err="1"/>
+              <a:t>our</a:t>
+            </a:r>
+            <a:r>
+              <a:rPr lang="de-AT" dirty="0"/>
+              <a:t> </a:t>
+            </a:r>
+            <a:r>
+              <a:rPr lang="de-AT" dirty="0" err="1"/>
+              <a:t>testing</a:t>
+            </a:r>
+            <a:r>
+              <a:rPr lang="de-AT" dirty="0"/>
+              <a:t> </a:t>
+            </a:r>
+            <a:r>
+              <a:rPr lang="de-AT" dirty="0" err="1"/>
+              <a:t>this</a:t>
+            </a:r>
+            <a:r>
+              <a:rPr lang="de-AT" dirty="0"/>
+              <a:t> holder </a:t>
+            </a:r>
+            <a:r>
+              <a:rPr lang="de-AT" dirty="0" err="1"/>
+              <a:t>worked</a:t>
+            </a:r>
+            <a:r>
+              <a:rPr lang="de-AT" dirty="0"/>
+              <a:t> out </a:t>
+            </a:r>
+            <a:r>
+              <a:rPr lang="de-AT" dirty="0" err="1"/>
+              <a:t>perfectly</a:t>
+            </a:r>
+            <a:r>
+              <a:rPr lang="de-AT" dirty="0"/>
+              <a:t> </a:t>
+            </a:r>
+            <a:r>
+              <a:rPr lang="de-AT" dirty="0" err="1"/>
+              <a:t>with</a:t>
+            </a:r>
+            <a:r>
+              <a:rPr lang="de-AT" dirty="0"/>
+              <a:t> </a:t>
+            </a:r>
+            <a:r>
+              <a:rPr lang="de-AT" dirty="0" err="1"/>
+              <a:t>no</a:t>
+            </a:r>
+            <a:r>
+              <a:rPr lang="de-AT" dirty="0"/>
+              <a:t> </a:t>
+            </a:r>
+            <a:r>
+              <a:rPr lang="de-AT" dirty="0" err="1"/>
+              <a:t>rattling</a:t>
+            </a:r>
+            <a:r>
+              <a:rPr lang="de-AT" dirty="0"/>
+              <a:t> </a:t>
+            </a:r>
+            <a:r>
+              <a:rPr lang="de-AT" dirty="0" err="1"/>
+              <a:t>or</a:t>
+            </a:r>
+            <a:r>
+              <a:rPr lang="de-AT" dirty="0"/>
+              <a:t> </a:t>
+            </a:r>
+            <a:r>
+              <a:rPr lang="de-AT" dirty="0" err="1"/>
+              <a:t>unwanted</a:t>
+            </a:r>
+            <a:r>
+              <a:rPr lang="de-AT" dirty="0"/>
+              <a:t> </a:t>
+            </a:r>
+            <a:r>
+              <a:rPr lang="de-AT" dirty="0" err="1"/>
+              <a:t>noise</a:t>
+            </a:r>
+            <a:r>
+              <a:rPr lang="de-AT" dirty="0"/>
+              <a:t> in </a:t>
+            </a:r>
+            <a:r>
+              <a:rPr lang="de-AT" dirty="0" err="1"/>
+              <a:t>the</a:t>
+            </a:r>
+            <a:r>
+              <a:rPr lang="de-AT" dirty="0"/>
+              <a:t> </a:t>
+            </a:r>
+            <a:r>
+              <a:rPr lang="de-AT" dirty="0" err="1"/>
+              <a:t>sessions</a:t>
+            </a:r>
+            <a:r>
+              <a:rPr lang="de-AT" dirty="0"/>
+              <a:t> </a:t>
+            </a:r>
+            <a:r>
+              <a:rPr lang="de-AT" dirty="0" err="1"/>
+              <a:t>as</a:t>
+            </a:r>
+            <a:r>
+              <a:rPr lang="de-AT" dirty="0"/>
+              <a:t> </a:t>
+            </a:r>
+            <a:r>
+              <a:rPr lang="de-AT" dirty="0" err="1"/>
+              <a:t>we</a:t>
+            </a:r>
+            <a:r>
+              <a:rPr lang="de-AT" dirty="0"/>
+              <a:t> </a:t>
+            </a:r>
+            <a:r>
+              <a:rPr lang="de-AT" dirty="0" err="1"/>
+              <a:t>could</a:t>
+            </a:r>
+            <a:r>
+              <a:rPr lang="de-AT" dirty="0"/>
+              <a:t> </a:t>
+            </a:r>
+            <a:r>
+              <a:rPr lang="de-AT" dirty="0" err="1"/>
+              <a:t>fixiate</a:t>
+            </a:r>
+            <a:r>
+              <a:rPr lang="de-AT" dirty="0"/>
+              <a:t> </a:t>
+            </a:r>
+            <a:r>
+              <a:rPr lang="de-AT" dirty="0" err="1"/>
+              <a:t>it</a:t>
+            </a:r>
+            <a:r>
+              <a:rPr lang="de-AT" dirty="0"/>
+              <a:t> </a:t>
+            </a:r>
+            <a:r>
+              <a:rPr lang="de-AT" dirty="0" err="1"/>
+              <a:t>very</a:t>
+            </a:r>
+            <a:r>
+              <a:rPr lang="de-AT" dirty="0"/>
+              <a:t> </a:t>
+            </a:r>
+            <a:r>
+              <a:rPr lang="de-AT" dirty="0" err="1"/>
+              <a:t>tightly</a:t>
             </a:r>
             <a:endParaRPr lang="de-AT" dirty="0"/>
           </a:p>
@@ -9040,9 +11040,1033 @@
           <a:lstStyle/>
           <a:p>
             <a:r>
-              <a:rPr lang="de-AT"/>
-              <a:t>Rief</a:t>
-            </a:r>
+              <a:rPr lang="de-AT" dirty="0"/>
+              <a:t>The </a:t>
+            </a:r>
+            <a:r>
+              <a:rPr lang="de-AT" dirty="0" err="1"/>
+              <a:t>data</a:t>
+            </a:r>
+            <a:r>
+              <a:rPr lang="de-AT" dirty="0"/>
+              <a:t> </a:t>
+            </a:r>
+            <a:r>
+              <a:rPr lang="de-AT" dirty="0" err="1"/>
+              <a:t>we</a:t>
+            </a:r>
+            <a:r>
+              <a:rPr lang="de-AT" dirty="0"/>
+              <a:t> </a:t>
+            </a:r>
+            <a:r>
+              <a:rPr lang="de-AT" dirty="0" err="1"/>
+              <a:t>sampled</a:t>
+            </a:r>
+            <a:r>
+              <a:rPr lang="de-AT" dirty="0"/>
+              <a:t> </a:t>
+            </a:r>
+            <a:r>
+              <a:rPr lang="de-AT" dirty="0" err="1"/>
+              <a:t>contained</a:t>
+            </a:r>
+            <a:r>
+              <a:rPr lang="de-AT" dirty="0"/>
+              <a:t> </a:t>
+            </a:r>
+            <a:r>
+              <a:rPr lang="de-AT" dirty="0" err="1"/>
+              <a:t>roughly</a:t>
+            </a:r>
+            <a:r>
+              <a:rPr lang="de-AT" dirty="0"/>
+              <a:t> 1h30min and </a:t>
+            </a:r>
+            <a:r>
+              <a:rPr lang="de-AT" dirty="0" err="1"/>
+              <a:t>consists</a:t>
+            </a:r>
+            <a:r>
+              <a:rPr lang="de-AT" dirty="0"/>
+              <a:t> </a:t>
+            </a:r>
+            <a:r>
+              <a:rPr lang="de-AT" dirty="0" err="1"/>
+              <a:t>of</a:t>
+            </a:r>
+            <a:r>
+              <a:rPr lang="de-AT" dirty="0"/>
+              <a:t> </a:t>
+            </a:r>
+            <a:r>
+              <a:rPr lang="de-AT" dirty="0" err="1"/>
+              <a:t>about</a:t>
+            </a:r>
+            <a:r>
+              <a:rPr lang="de-AT" dirty="0"/>
+              <a:t> an </a:t>
+            </a:r>
+            <a:r>
+              <a:rPr lang="de-AT" dirty="0" err="1"/>
+              <a:t>hour</a:t>
+            </a:r>
+            <a:r>
+              <a:rPr lang="de-AT" dirty="0"/>
+              <a:t> </a:t>
+            </a:r>
+            <a:r>
+              <a:rPr lang="de-AT" dirty="0" err="1"/>
+              <a:t>of</a:t>
+            </a:r>
+            <a:r>
+              <a:rPr lang="de-AT" dirty="0"/>
+              <a:t> </a:t>
+            </a:r>
+            <a:r>
+              <a:rPr lang="de-AT" dirty="0" err="1"/>
+              <a:t>labled</a:t>
+            </a:r>
+            <a:r>
+              <a:rPr lang="de-AT" dirty="0"/>
+              <a:t> </a:t>
+            </a:r>
+            <a:r>
+              <a:rPr lang="de-AT" dirty="0" err="1"/>
+              <a:t>data</a:t>
+            </a:r>
+            <a:r>
+              <a:rPr lang="de-AT" dirty="0"/>
+              <a:t> and </a:t>
+            </a:r>
+            <a:r>
+              <a:rPr lang="de-AT" dirty="0" err="1"/>
+              <a:t>the</a:t>
+            </a:r>
+            <a:r>
+              <a:rPr lang="de-AT" dirty="0"/>
+              <a:t> </a:t>
+            </a:r>
+            <a:r>
+              <a:rPr lang="de-AT" dirty="0" err="1"/>
+              <a:t>rest</a:t>
+            </a:r>
+            <a:r>
+              <a:rPr lang="de-AT" dirty="0"/>
+              <a:t> </a:t>
+            </a:r>
+            <a:r>
+              <a:rPr lang="de-AT" dirty="0" err="1"/>
+              <a:t>of</a:t>
+            </a:r>
+            <a:r>
+              <a:rPr lang="de-AT" dirty="0"/>
+              <a:t> </a:t>
+            </a:r>
+            <a:r>
+              <a:rPr lang="de-AT" dirty="0" err="1"/>
+              <a:t>unlabeld</a:t>
+            </a:r>
+            <a:r>
+              <a:rPr lang="de-AT" dirty="0"/>
+              <a:t> </a:t>
+            </a:r>
+            <a:r>
+              <a:rPr lang="de-AT" dirty="0" err="1"/>
+              <a:t>data</a:t>
+            </a:r>
+            <a:r>
+              <a:rPr lang="de-AT" dirty="0"/>
+              <a:t>.</a:t>
+            </a:r>
+          </a:p>
+          <a:p>
+            <a:endParaRPr lang="de-AT" dirty="0"/>
+          </a:p>
+          <a:p>
+            <a:r>
+              <a:rPr lang="de-AT" dirty="0" err="1"/>
+              <a:t>For</a:t>
+            </a:r>
+            <a:r>
+              <a:rPr lang="de-AT" dirty="0"/>
+              <a:t> </a:t>
+            </a:r>
+            <a:r>
+              <a:rPr lang="de-AT" dirty="0" err="1"/>
+              <a:t>collection</a:t>
+            </a:r>
+            <a:r>
+              <a:rPr lang="de-AT" dirty="0"/>
+              <a:t> </a:t>
+            </a:r>
+            <a:r>
+              <a:rPr lang="de-AT" dirty="0" err="1"/>
+              <a:t>only</a:t>
+            </a:r>
+            <a:r>
+              <a:rPr lang="de-AT" dirty="0"/>
+              <a:t> </a:t>
+            </a:r>
+            <a:r>
+              <a:rPr lang="de-AT" dirty="0" err="1"/>
+              <a:t>the</a:t>
+            </a:r>
+            <a:r>
+              <a:rPr lang="de-AT" dirty="0"/>
+              <a:t> </a:t>
+            </a:r>
+            <a:r>
+              <a:rPr lang="de-AT" dirty="0" err="1"/>
+              <a:t>right</a:t>
+            </a:r>
+            <a:r>
+              <a:rPr lang="de-AT" dirty="0"/>
+              <a:t> </a:t>
+            </a:r>
+            <a:r>
+              <a:rPr lang="de-AT" dirty="0" err="1"/>
+              <a:t>hand</a:t>
+            </a:r>
+            <a:r>
+              <a:rPr lang="de-AT" dirty="0"/>
+              <a:t> was </a:t>
+            </a:r>
+            <a:r>
+              <a:rPr lang="de-AT" dirty="0" err="1"/>
+              <a:t>used</a:t>
+            </a:r>
+            <a:r>
+              <a:rPr lang="de-AT" dirty="0"/>
+              <a:t> </a:t>
+            </a:r>
+            <a:r>
+              <a:rPr lang="de-AT" dirty="0" err="1"/>
+              <a:t>as</a:t>
+            </a:r>
+            <a:r>
+              <a:rPr lang="de-AT" dirty="0"/>
+              <a:t> </a:t>
+            </a:r>
+            <a:r>
+              <a:rPr lang="de-AT" dirty="0" err="1"/>
+              <a:t>we</a:t>
+            </a:r>
+            <a:r>
+              <a:rPr lang="de-AT" dirty="0"/>
+              <a:t> </a:t>
+            </a:r>
+            <a:r>
+              <a:rPr lang="de-AT" dirty="0" err="1"/>
+              <a:t>were</a:t>
+            </a:r>
+            <a:r>
+              <a:rPr lang="de-AT" dirty="0"/>
+              <a:t> </a:t>
+            </a:r>
+            <a:r>
+              <a:rPr lang="de-AT" dirty="0" err="1"/>
+              <a:t>told</a:t>
+            </a:r>
+            <a:r>
+              <a:rPr lang="de-AT" dirty="0"/>
+              <a:t> </a:t>
+            </a:r>
+            <a:r>
+              <a:rPr lang="de-AT" dirty="0" err="1"/>
+              <a:t>to</a:t>
+            </a:r>
+            <a:r>
+              <a:rPr lang="de-AT" dirty="0"/>
+              <a:t> </a:t>
+            </a:r>
+            <a:r>
+              <a:rPr lang="de-AT" dirty="0" err="1"/>
+              <a:t>only</a:t>
+            </a:r>
+            <a:r>
+              <a:rPr lang="de-AT" dirty="0"/>
+              <a:t> </a:t>
+            </a:r>
+            <a:r>
+              <a:rPr lang="de-AT" dirty="0" err="1"/>
+              <a:t>focus</a:t>
+            </a:r>
+            <a:r>
+              <a:rPr lang="de-AT" dirty="0"/>
+              <a:t> on a </a:t>
+            </a:r>
+            <a:r>
+              <a:rPr lang="de-AT" dirty="0" err="1"/>
+              <a:t>proof</a:t>
+            </a:r>
+            <a:r>
+              <a:rPr lang="de-AT" dirty="0"/>
+              <a:t> </a:t>
+            </a:r>
+            <a:r>
+              <a:rPr lang="de-AT" dirty="0" err="1"/>
+              <a:t>of</a:t>
+            </a:r>
+            <a:r>
+              <a:rPr lang="de-AT" dirty="0"/>
+              <a:t> </a:t>
+            </a:r>
+            <a:r>
+              <a:rPr lang="de-AT" dirty="0" err="1"/>
+              <a:t>concept</a:t>
+            </a:r>
+            <a:r>
+              <a:rPr lang="de-AT" dirty="0"/>
+              <a:t> </a:t>
+            </a:r>
+            <a:r>
+              <a:rPr lang="de-AT" dirty="0" err="1"/>
+              <a:t>for</a:t>
+            </a:r>
+            <a:r>
+              <a:rPr lang="de-AT" dirty="0"/>
+              <a:t> </a:t>
+            </a:r>
+            <a:r>
+              <a:rPr lang="de-AT" dirty="0" err="1"/>
+              <a:t>this</a:t>
+            </a:r>
+            <a:r>
+              <a:rPr lang="de-AT" dirty="0"/>
+              <a:t> </a:t>
+            </a:r>
+            <a:r>
+              <a:rPr lang="de-AT" dirty="0" err="1"/>
+              <a:t>project</a:t>
+            </a:r>
+            <a:endParaRPr lang="de-AT" dirty="0"/>
+          </a:p>
+          <a:p>
+            <a:endParaRPr lang="de-AT" dirty="0"/>
+          </a:p>
+          <a:p>
+            <a:r>
+              <a:rPr lang="de-AT" dirty="0"/>
+              <a:t>The </a:t>
+            </a:r>
+            <a:r>
+              <a:rPr lang="de-AT" dirty="0" err="1"/>
+              <a:t>data</a:t>
+            </a:r>
+            <a:r>
+              <a:rPr lang="de-AT" dirty="0"/>
+              <a:t> </a:t>
+            </a:r>
+            <a:r>
+              <a:rPr lang="de-AT" dirty="0" err="1"/>
+              <a:t>we</a:t>
+            </a:r>
+            <a:r>
+              <a:rPr lang="de-AT" dirty="0"/>
+              <a:t> </a:t>
+            </a:r>
+            <a:r>
+              <a:rPr lang="de-AT" dirty="0" err="1"/>
+              <a:t>sampled</a:t>
+            </a:r>
+            <a:r>
+              <a:rPr lang="de-AT" dirty="0"/>
+              <a:t> was </a:t>
+            </a:r>
+            <a:r>
+              <a:rPr lang="de-AT" dirty="0" err="1"/>
+              <a:t>taken</a:t>
+            </a:r>
+            <a:r>
+              <a:rPr lang="de-AT" dirty="0"/>
+              <a:t> </a:t>
+            </a:r>
+            <a:r>
+              <a:rPr lang="de-AT" dirty="0" err="1"/>
+              <a:t>from</a:t>
+            </a:r>
+            <a:r>
+              <a:rPr lang="de-AT" dirty="0"/>
+              <a:t> </a:t>
+            </a:r>
+            <a:r>
+              <a:rPr lang="de-AT" dirty="0" err="1"/>
+              <a:t>every</a:t>
+            </a:r>
+            <a:r>
+              <a:rPr lang="de-AT" dirty="0"/>
+              <a:t> </a:t>
+            </a:r>
+            <a:r>
+              <a:rPr lang="de-AT" dirty="0" err="1"/>
+              <a:t>member</a:t>
+            </a:r>
+            <a:r>
+              <a:rPr lang="de-AT" dirty="0"/>
+              <a:t> </a:t>
+            </a:r>
+            <a:r>
+              <a:rPr lang="de-AT" dirty="0" err="1"/>
+              <a:t>of</a:t>
+            </a:r>
+            <a:r>
+              <a:rPr lang="de-AT" dirty="0"/>
+              <a:t> </a:t>
+            </a:r>
+            <a:r>
+              <a:rPr lang="de-AT" dirty="0" err="1"/>
+              <a:t>the</a:t>
+            </a:r>
+            <a:r>
+              <a:rPr lang="de-AT" dirty="0"/>
+              <a:t> </a:t>
+            </a:r>
+            <a:r>
+              <a:rPr lang="de-AT" dirty="0" err="1"/>
+              <a:t>team</a:t>
+            </a:r>
+            <a:r>
+              <a:rPr lang="de-AT" dirty="0"/>
+              <a:t> so </a:t>
+            </a:r>
+            <a:r>
+              <a:rPr lang="de-AT" dirty="0" err="1"/>
+              <a:t>we</a:t>
+            </a:r>
+            <a:r>
+              <a:rPr lang="de-AT" dirty="0"/>
+              <a:t> </a:t>
+            </a:r>
+            <a:r>
+              <a:rPr lang="de-AT" dirty="0" err="1"/>
+              <a:t>would</a:t>
+            </a:r>
+            <a:r>
+              <a:rPr lang="de-AT" dirty="0"/>
+              <a:t> </a:t>
+            </a:r>
+            <a:r>
+              <a:rPr lang="de-AT" dirty="0" err="1"/>
+              <a:t>have</a:t>
+            </a:r>
+            <a:r>
+              <a:rPr lang="de-AT" dirty="0"/>
+              <a:t> different </a:t>
+            </a:r>
+            <a:r>
+              <a:rPr lang="de-AT" dirty="0" err="1"/>
+              <a:t>techniques</a:t>
+            </a:r>
+            <a:r>
+              <a:rPr lang="de-AT" dirty="0"/>
+              <a:t> and all </a:t>
+            </a:r>
+            <a:r>
+              <a:rPr lang="de-AT" dirty="0" err="1"/>
+              <a:t>of</a:t>
+            </a:r>
+            <a:r>
+              <a:rPr lang="de-AT" dirty="0"/>
+              <a:t> </a:t>
+            </a:r>
+            <a:r>
+              <a:rPr lang="de-AT" dirty="0" err="1"/>
+              <a:t>us</a:t>
+            </a:r>
+            <a:r>
+              <a:rPr lang="de-AT" dirty="0"/>
+              <a:t> also </a:t>
+            </a:r>
+            <a:r>
+              <a:rPr lang="de-AT" dirty="0" err="1"/>
+              <a:t>tried</a:t>
+            </a:r>
+            <a:r>
+              <a:rPr lang="de-AT" dirty="0"/>
+              <a:t> </a:t>
+            </a:r>
+            <a:r>
+              <a:rPr lang="de-AT" dirty="0" err="1"/>
+              <a:t>to</a:t>
+            </a:r>
+            <a:r>
+              <a:rPr lang="de-AT" dirty="0"/>
+              <a:t> </a:t>
+            </a:r>
+            <a:r>
+              <a:rPr lang="de-AT" dirty="0" err="1"/>
+              <a:t>use</a:t>
+            </a:r>
+            <a:r>
+              <a:rPr lang="de-AT" dirty="0"/>
+              <a:t> different </a:t>
+            </a:r>
+            <a:r>
+              <a:rPr lang="de-AT" dirty="0" err="1"/>
+              <a:t>speeds</a:t>
+            </a:r>
+            <a:r>
+              <a:rPr lang="de-AT" dirty="0"/>
+              <a:t> </a:t>
+            </a:r>
+            <a:r>
+              <a:rPr lang="de-AT" dirty="0" err="1"/>
+              <a:t>for</a:t>
+            </a:r>
+            <a:r>
+              <a:rPr lang="de-AT" dirty="0"/>
+              <a:t> a </a:t>
+            </a:r>
+            <a:r>
+              <a:rPr lang="de-AT" dirty="0" err="1"/>
+              <a:t>greater</a:t>
+            </a:r>
+            <a:r>
+              <a:rPr lang="de-AT" dirty="0"/>
+              <a:t> </a:t>
+            </a:r>
+            <a:r>
+              <a:rPr lang="de-AT" dirty="0" err="1"/>
+              <a:t>variety</a:t>
+            </a:r>
+            <a:endParaRPr lang="de-AT" dirty="0"/>
+          </a:p>
+          <a:p>
+            <a:endParaRPr lang="de-AT" dirty="0"/>
+          </a:p>
+          <a:p>
+            <a:r>
+              <a:rPr lang="de-AT" dirty="0"/>
+              <a:t>The </a:t>
+            </a:r>
+            <a:r>
+              <a:rPr lang="de-AT" dirty="0" err="1"/>
+              <a:t>sessions</a:t>
+            </a:r>
+            <a:r>
+              <a:rPr lang="de-AT" dirty="0"/>
+              <a:t> </a:t>
+            </a:r>
+            <a:r>
+              <a:rPr lang="de-AT" dirty="0" err="1"/>
+              <a:t>were</a:t>
+            </a:r>
+            <a:r>
+              <a:rPr lang="de-AT" dirty="0"/>
+              <a:t> </a:t>
+            </a:r>
+            <a:r>
+              <a:rPr lang="de-AT" dirty="0" err="1"/>
+              <a:t>mostly</a:t>
+            </a:r>
+            <a:r>
+              <a:rPr lang="de-AT" dirty="0"/>
+              <a:t> </a:t>
+            </a:r>
+            <a:r>
+              <a:rPr lang="de-AT" dirty="0" err="1"/>
+              <a:t>only</a:t>
+            </a:r>
+            <a:r>
+              <a:rPr lang="de-AT" dirty="0"/>
+              <a:t> </a:t>
+            </a:r>
+            <a:r>
+              <a:rPr lang="de-AT" dirty="0" err="1"/>
+              <a:t>one</a:t>
+            </a:r>
+            <a:r>
+              <a:rPr lang="de-AT" dirty="0"/>
+              <a:t> type </a:t>
+            </a:r>
+            <a:r>
+              <a:rPr lang="de-AT" dirty="0" err="1"/>
+              <a:t>of</a:t>
+            </a:r>
+            <a:r>
+              <a:rPr lang="de-AT" dirty="0"/>
+              <a:t> </a:t>
+            </a:r>
+            <a:r>
+              <a:rPr lang="de-AT" dirty="0" err="1"/>
+              <a:t>punch</a:t>
+            </a:r>
+            <a:r>
+              <a:rPr lang="de-AT" dirty="0"/>
+              <a:t> </a:t>
+            </a:r>
+            <a:r>
+              <a:rPr lang="de-AT" dirty="0" err="1"/>
+              <a:t>with</a:t>
+            </a:r>
+            <a:r>
+              <a:rPr lang="de-AT" dirty="0"/>
+              <a:t> </a:t>
+            </a:r>
+            <a:r>
+              <a:rPr lang="de-AT" dirty="0" err="1"/>
+              <a:t>enough</a:t>
+            </a:r>
+            <a:r>
+              <a:rPr lang="de-AT" dirty="0"/>
+              <a:t> time </a:t>
+            </a:r>
+            <a:r>
+              <a:rPr lang="de-AT" dirty="0" err="1"/>
+              <a:t>inbetween</a:t>
+            </a:r>
+            <a:r>
+              <a:rPr lang="de-AT" dirty="0"/>
+              <a:t> so </a:t>
+            </a:r>
+            <a:r>
+              <a:rPr lang="de-AT" dirty="0" err="1"/>
+              <a:t>we</a:t>
+            </a:r>
+            <a:r>
+              <a:rPr lang="de-AT" dirty="0"/>
+              <a:t> </a:t>
+            </a:r>
+            <a:r>
+              <a:rPr lang="de-AT" dirty="0" err="1"/>
+              <a:t>could</a:t>
+            </a:r>
+            <a:r>
+              <a:rPr lang="de-AT" dirty="0"/>
+              <a:t> </a:t>
+            </a:r>
+            <a:r>
+              <a:rPr lang="de-AT" dirty="0" err="1"/>
+              <a:t>label</a:t>
+            </a:r>
+            <a:r>
+              <a:rPr lang="de-AT" dirty="0"/>
+              <a:t> </a:t>
+            </a:r>
+            <a:r>
+              <a:rPr lang="de-AT" dirty="0" err="1"/>
+              <a:t>the</a:t>
+            </a:r>
+            <a:r>
+              <a:rPr lang="de-AT" dirty="0"/>
+              <a:t> </a:t>
+            </a:r>
+            <a:r>
+              <a:rPr lang="de-AT" dirty="0" err="1"/>
+              <a:t>data</a:t>
+            </a:r>
+            <a:r>
+              <a:rPr lang="de-AT" dirty="0"/>
+              <a:t> </a:t>
+            </a:r>
+            <a:r>
+              <a:rPr lang="de-AT" dirty="0" err="1"/>
+              <a:t>very</a:t>
+            </a:r>
+            <a:r>
+              <a:rPr lang="de-AT" dirty="0"/>
+              <a:t> </a:t>
+            </a:r>
+            <a:r>
+              <a:rPr lang="de-AT" dirty="0" err="1"/>
+              <a:t>accuratly</a:t>
+            </a:r>
+            <a:r>
+              <a:rPr lang="de-AT" dirty="0"/>
+              <a:t> </a:t>
+            </a:r>
+          </a:p>
+          <a:p>
+            <a:endParaRPr lang="de-AT" dirty="0"/>
+          </a:p>
+          <a:p>
+            <a:r>
+              <a:rPr lang="de-AT" dirty="0" err="1"/>
+              <a:t>Some</a:t>
+            </a:r>
+            <a:r>
+              <a:rPr lang="de-AT" dirty="0"/>
+              <a:t> </a:t>
+            </a:r>
+            <a:r>
+              <a:rPr lang="de-AT" dirty="0" err="1"/>
+              <a:t>session</a:t>
+            </a:r>
+            <a:r>
+              <a:rPr lang="de-AT" dirty="0"/>
+              <a:t> also </a:t>
+            </a:r>
+            <a:r>
+              <a:rPr lang="de-AT" dirty="0" err="1"/>
+              <a:t>contained</a:t>
+            </a:r>
+            <a:r>
+              <a:rPr lang="de-AT" dirty="0"/>
+              <a:t> </a:t>
+            </a:r>
+            <a:r>
+              <a:rPr lang="de-AT" dirty="0" err="1"/>
+              <a:t>mixtures</a:t>
+            </a:r>
+            <a:r>
+              <a:rPr lang="de-AT" dirty="0"/>
+              <a:t> </a:t>
+            </a:r>
+            <a:r>
+              <a:rPr lang="de-AT" dirty="0" err="1"/>
+              <a:t>of</a:t>
+            </a:r>
+            <a:r>
+              <a:rPr lang="de-AT" dirty="0"/>
+              <a:t> </a:t>
+            </a:r>
+            <a:r>
+              <a:rPr lang="de-AT" dirty="0" err="1"/>
+              <a:t>punches</a:t>
+            </a:r>
+            <a:r>
+              <a:rPr lang="de-AT" dirty="0"/>
+              <a:t> </a:t>
+            </a:r>
+            <a:r>
+              <a:rPr lang="de-AT" dirty="0" err="1"/>
+              <a:t>to</a:t>
+            </a:r>
+            <a:r>
+              <a:rPr lang="de-AT" dirty="0"/>
+              <a:t> </a:t>
+            </a:r>
+            <a:r>
+              <a:rPr lang="de-AT" dirty="0" err="1"/>
+              <a:t>help</a:t>
+            </a:r>
+            <a:r>
+              <a:rPr lang="de-AT" dirty="0"/>
+              <a:t> </a:t>
+            </a:r>
+            <a:r>
+              <a:rPr lang="de-AT" dirty="0" err="1"/>
+              <a:t>the</a:t>
+            </a:r>
+            <a:r>
+              <a:rPr lang="de-AT" dirty="0"/>
+              <a:t> </a:t>
+            </a:r>
+            <a:r>
+              <a:rPr lang="de-AT" dirty="0" err="1"/>
+              <a:t>model</a:t>
+            </a:r>
+            <a:r>
+              <a:rPr lang="de-AT" dirty="0"/>
+              <a:t> in </a:t>
+            </a:r>
+            <a:r>
+              <a:rPr lang="de-AT" dirty="0" err="1"/>
+              <a:t>seeing</a:t>
+            </a:r>
+            <a:r>
+              <a:rPr lang="de-AT" dirty="0"/>
+              <a:t> </a:t>
+            </a:r>
+            <a:r>
+              <a:rPr lang="de-AT" dirty="0" err="1"/>
+              <a:t>faster</a:t>
+            </a:r>
+            <a:r>
+              <a:rPr lang="de-AT" dirty="0"/>
+              <a:t> </a:t>
+            </a:r>
+            <a:r>
+              <a:rPr lang="de-AT" dirty="0" err="1"/>
+              <a:t>transition</a:t>
+            </a:r>
+            <a:r>
+              <a:rPr lang="de-AT" dirty="0"/>
+              <a:t> </a:t>
+            </a:r>
+            <a:r>
+              <a:rPr lang="de-AT" dirty="0" err="1"/>
+              <a:t>between</a:t>
+            </a:r>
+            <a:r>
+              <a:rPr lang="de-AT" dirty="0"/>
+              <a:t> </a:t>
+            </a:r>
+            <a:r>
+              <a:rPr lang="de-AT" dirty="0" err="1"/>
+              <a:t>punches</a:t>
+            </a:r>
+            <a:r>
+              <a:rPr lang="de-AT" dirty="0"/>
+              <a:t> </a:t>
+            </a:r>
+            <a:r>
+              <a:rPr lang="de-AT" dirty="0" err="1"/>
+              <a:t>better</a:t>
+            </a:r>
+            <a:endParaRPr lang="de-AT" dirty="0"/>
+          </a:p>
+          <a:p>
+            <a:endParaRPr lang="de-AT" dirty="0"/>
+          </a:p>
+          <a:p>
+            <a:r>
+              <a:rPr lang="de-AT" dirty="0" err="1"/>
+              <a:t>For</a:t>
+            </a:r>
+            <a:r>
+              <a:rPr lang="de-AT" dirty="0"/>
+              <a:t> </a:t>
+            </a:r>
+            <a:r>
+              <a:rPr lang="de-AT" dirty="0" err="1"/>
+              <a:t>sampling</a:t>
+            </a:r>
+            <a:r>
+              <a:rPr lang="de-AT" dirty="0"/>
+              <a:t> </a:t>
+            </a:r>
+            <a:r>
+              <a:rPr lang="de-AT" dirty="0" err="1"/>
+              <a:t>we</a:t>
+            </a:r>
+            <a:r>
+              <a:rPr lang="de-AT" dirty="0"/>
+              <a:t> </a:t>
+            </a:r>
+            <a:r>
+              <a:rPr lang="de-AT" dirty="0" err="1"/>
+              <a:t>used</a:t>
+            </a:r>
+            <a:r>
+              <a:rPr lang="de-AT" dirty="0"/>
+              <a:t> a IMU </a:t>
+            </a:r>
+            <a:r>
+              <a:rPr lang="de-AT" dirty="0" err="1"/>
+              <a:t>frequency</a:t>
+            </a:r>
+            <a:r>
+              <a:rPr lang="de-AT" dirty="0"/>
+              <a:t> </a:t>
+            </a:r>
+            <a:r>
+              <a:rPr lang="de-AT" dirty="0" err="1"/>
+              <a:t>of</a:t>
+            </a:r>
+            <a:r>
+              <a:rPr lang="de-AT" dirty="0"/>
+              <a:t> 400Hz</a:t>
+            </a:r>
+          </a:p>
+          <a:p>
+            <a:endParaRPr lang="de-AT" dirty="0"/>
+          </a:p>
+          <a:p>
+            <a:r>
+              <a:rPr lang="de-AT" dirty="0"/>
+              <a:t>Under </a:t>
+            </a:r>
+            <a:r>
+              <a:rPr lang="de-AT" dirty="0" err="1"/>
+              <a:t>that</a:t>
+            </a:r>
+            <a:r>
+              <a:rPr lang="de-AT" dirty="0"/>
+              <a:t> </a:t>
+            </a:r>
+            <a:r>
+              <a:rPr lang="de-AT" dirty="0" err="1"/>
+              <a:t>you</a:t>
+            </a:r>
+            <a:r>
+              <a:rPr lang="de-AT" dirty="0"/>
+              <a:t> </a:t>
+            </a:r>
+            <a:r>
+              <a:rPr lang="de-AT" dirty="0" err="1"/>
+              <a:t>can</a:t>
+            </a:r>
+            <a:r>
+              <a:rPr lang="de-AT" dirty="0"/>
+              <a:t> </a:t>
+            </a:r>
+            <a:r>
+              <a:rPr lang="de-AT" dirty="0" err="1"/>
+              <a:t>see</a:t>
+            </a:r>
+            <a:r>
+              <a:rPr lang="de-AT" dirty="0"/>
+              <a:t> </a:t>
+            </a:r>
+            <a:r>
+              <a:rPr lang="de-AT" dirty="0" err="1"/>
+              <a:t>the</a:t>
+            </a:r>
+            <a:r>
+              <a:rPr lang="de-AT" dirty="0"/>
+              <a:t> </a:t>
+            </a:r>
+            <a:r>
+              <a:rPr lang="de-AT" dirty="0" err="1"/>
+              <a:t>three</a:t>
+            </a:r>
+            <a:r>
+              <a:rPr lang="de-AT" dirty="0"/>
+              <a:t> </a:t>
+            </a:r>
+            <a:r>
+              <a:rPr lang="de-AT" dirty="0" err="1"/>
+              <a:t>punches</a:t>
+            </a:r>
+            <a:r>
+              <a:rPr lang="de-AT" dirty="0"/>
+              <a:t> </a:t>
+            </a:r>
+            <a:r>
+              <a:rPr lang="de-AT" dirty="0" err="1"/>
+              <a:t>we</a:t>
+            </a:r>
+            <a:r>
+              <a:rPr lang="de-AT" dirty="0"/>
+              <a:t> </a:t>
+            </a:r>
+            <a:r>
+              <a:rPr lang="de-AT" dirty="0" err="1"/>
+              <a:t>labeld</a:t>
+            </a:r>
+            <a:r>
+              <a:rPr lang="de-AT" dirty="0"/>
+              <a:t> </a:t>
+            </a:r>
+            <a:r>
+              <a:rPr lang="de-AT" dirty="0" err="1"/>
+              <a:t>with</a:t>
+            </a:r>
+            <a:r>
+              <a:rPr lang="de-AT" dirty="0"/>
+              <a:t> </a:t>
+            </a:r>
+            <a:r>
+              <a:rPr lang="de-AT" dirty="0" err="1"/>
+              <a:t>the</a:t>
+            </a:r>
+            <a:r>
+              <a:rPr lang="de-AT" dirty="0"/>
+              <a:t> </a:t>
+            </a:r>
+            <a:r>
+              <a:rPr lang="de-AT" dirty="0" err="1"/>
+              <a:t>jab</a:t>
+            </a:r>
+            <a:r>
+              <a:rPr lang="de-AT" dirty="0"/>
+              <a:t> </a:t>
+            </a:r>
+            <a:r>
+              <a:rPr lang="de-AT" dirty="0" err="1"/>
+              <a:t>being</a:t>
+            </a:r>
+            <a:r>
+              <a:rPr lang="de-AT" dirty="0"/>
+              <a:t> </a:t>
+            </a:r>
+            <a:r>
+              <a:rPr lang="de-AT" dirty="0" err="1"/>
+              <a:t>the</a:t>
+            </a:r>
+            <a:r>
+              <a:rPr lang="de-AT" dirty="0"/>
+              <a:t> </a:t>
+            </a:r>
+            <a:r>
+              <a:rPr lang="de-AT" dirty="0" err="1"/>
+              <a:t>most</a:t>
+            </a:r>
+            <a:r>
+              <a:rPr lang="de-AT" dirty="0"/>
+              <a:t> </a:t>
+            </a:r>
+            <a:r>
+              <a:rPr lang="de-AT" dirty="0" err="1"/>
+              <a:t>unique</a:t>
+            </a:r>
+            <a:r>
+              <a:rPr lang="de-AT" dirty="0"/>
+              <a:t> and </a:t>
+            </a:r>
+            <a:r>
+              <a:rPr lang="de-AT" dirty="0" err="1"/>
+              <a:t>the</a:t>
+            </a:r>
+            <a:r>
+              <a:rPr lang="de-AT" dirty="0"/>
+              <a:t> </a:t>
+            </a:r>
+            <a:r>
+              <a:rPr lang="de-AT" dirty="0" err="1"/>
+              <a:t>other</a:t>
+            </a:r>
+            <a:r>
+              <a:rPr lang="de-AT" dirty="0"/>
+              <a:t> </a:t>
+            </a:r>
+            <a:r>
+              <a:rPr lang="de-AT" dirty="0" err="1"/>
+              <a:t>two</a:t>
+            </a:r>
+            <a:r>
+              <a:rPr lang="de-AT" dirty="0"/>
+              <a:t> </a:t>
+            </a:r>
+            <a:r>
+              <a:rPr lang="de-AT" dirty="0" err="1"/>
+              <a:t>with</a:t>
+            </a:r>
+            <a:r>
+              <a:rPr lang="de-AT" dirty="0"/>
+              <a:t> </a:t>
+            </a:r>
+            <a:r>
+              <a:rPr lang="de-AT" dirty="0" err="1"/>
+              <a:t>some</a:t>
+            </a:r>
+            <a:r>
+              <a:rPr lang="de-AT" dirty="0"/>
+              <a:t> </a:t>
+            </a:r>
+            <a:r>
+              <a:rPr lang="de-AT" dirty="0" err="1"/>
+              <a:t>similarities</a:t>
+            </a:r>
+            <a:r>
+              <a:rPr lang="de-AT" dirty="0"/>
+              <a:t> but still </a:t>
+            </a:r>
+            <a:r>
+              <a:rPr lang="de-AT" dirty="0" err="1"/>
+              <a:t>some</a:t>
+            </a:r>
+            <a:r>
+              <a:rPr lang="de-AT" dirty="0"/>
+              <a:t> </a:t>
+            </a:r>
+            <a:r>
+              <a:rPr lang="de-AT" dirty="0" err="1"/>
+              <a:t>great</a:t>
+            </a:r>
+            <a:r>
+              <a:rPr lang="de-AT" dirty="0"/>
+              <a:t> </a:t>
+            </a:r>
+            <a:r>
+              <a:rPr lang="de-AT" dirty="0" err="1"/>
+              <a:t>differences</a:t>
+            </a:r>
+            <a:endParaRPr lang="de-AT" dirty="0"/>
+          </a:p>
+          <a:p>
             <a:endParaRPr lang="de-AT" dirty="0"/>
           </a:p>
         </p:txBody>
@@ -14864,7 +17888,23 @@
                   <a:schemeClr val="bg1"/>
                 </a:solidFill>
               </a:rPr>
-              <a:t>Tobias Riedelberger, Theo Corneux, Tobias Holzner</a:t>
+              <a:t>Tobias Riedelberger, Theo </a:t>
+            </a:r>
+            <a:r>
+              <a:rPr lang="en-GB" noProof="0" dirty="0" err="1">
+                <a:solidFill>
+                  <a:schemeClr val="bg1"/>
+                </a:solidFill>
+              </a:rPr>
+              <a:t>Corneux</a:t>
+            </a:r>
+            <a:r>
+              <a:rPr lang="en-GB" noProof="0" dirty="0">
+                <a:solidFill>
+                  <a:schemeClr val="bg1"/>
+                </a:solidFill>
+              </a:rPr>
+              <a:t>, Tobias Holzner</a:t>
             </a:r>
           </a:p>
         </p:txBody>
@@ -14942,10 +17982,9 @@
           <a:lstStyle/>
           <a:p>
             <a:r>
-              <a:rPr lang="de-DE" noProof="0"/>
+              <a:rPr lang="en-GB" noProof="0" dirty="0"/>
               <a:t>23.02.2026</a:t>
             </a:r>
-            <a:endParaRPr lang="en-GB" noProof="0" dirty="0"/>
           </a:p>
         </p:txBody>
       </p:sp>
@@ -15036,10 +18075,9 @@
           <a:lstStyle/>
           <a:p>
             <a:r>
-              <a:rPr lang="de-DE" noProof="0"/>
+              <a:rPr lang="en-GB" noProof="0" dirty="0"/>
               <a:t>23.02.2026</a:t>
             </a:r>
-            <a:endParaRPr lang="en-GB" noProof="0" dirty="0"/>
           </a:p>
         </p:txBody>
       </p:sp>
@@ -15177,102 +18215,61 @@
           <a:lstStyle/>
           <a:p>
             <a:r>
-              <a:rPr lang="en-GB" dirty="0"/>
+              <a:rPr lang="en-GB" noProof="0" dirty="0"/>
               <a:t>Publish punch data to </a:t>
             </a:r>
             <a:r>
-              <a:rPr lang="en-GB" dirty="0" err="1"/>
+              <a:rPr lang="en-GB" noProof="0" dirty="0" err="1"/>
               <a:t>Ubidots</a:t>
             </a:r>
-            <a:endParaRPr lang="en-GB" dirty="0"/>
-          </a:p>
-          <a:p>
-            <a:r>
-              <a:rPr lang="en-GB" dirty="0"/>
+            <a:endParaRPr lang="en-GB" noProof="0" dirty="0"/>
+          </a:p>
+          <a:p>
+            <a:r>
+              <a:rPr lang="en-GB" noProof="0" dirty="0"/>
               <a:t>Mode of operation</a:t>
             </a:r>
           </a:p>
           <a:p>
             <a:pPr lvl="1"/>
             <a:r>
-              <a:rPr lang="en-GB" dirty="0"/>
+              <a:rPr lang="en-GB" noProof="0" dirty="0"/>
               <a:t>Same as first program</a:t>
             </a:r>
           </a:p>
           <a:p>
             <a:pPr lvl="1"/>
             <a:r>
-              <a:rPr lang="en-GB" dirty="0"/>
+              <a:rPr lang="en-GB" noProof="0" dirty="0"/>
               <a:t>Publish to MQTT server</a:t>
             </a:r>
           </a:p>
           <a:p>
             <a:r>
-              <a:rPr lang="en-GB" dirty="0"/>
+              <a:rPr lang="en-GB" noProof="0" dirty="0"/>
               <a:t>Dashboard</a:t>
             </a:r>
           </a:p>
           <a:p>
             <a:pPr lvl="1"/>
             <a:r>
-              <a:rPr lang="en-GB" dirty="0"/>
+              <a:rPr lang="en-GB" noProof="0" dirty="0"/>
               <a:t>Save data in a table</a:t>
             </a:r>
           </a:p>
           <a:p>
             <a:pPr lvl="1"/>
             <a:r>
-              <a:rPr lang="de-AT" dirty="0"/>
-              <a:t>Start </a:t>
-            </a:r>
-            <a:r>
-              <a:rPr lang="de-AT" dirty="0" err="1"/>
-              <a:t>new</a:t>
-            </a:r>
-            <a:r>
-              <a:rPr lang="de-AT" dirty="0"/>
-              <a:t> </a:t>
-            </a:r>
-            <a:r>
-              <a:rPr lang="de-AT" dirty="0" err="1"/>
-              <a:t>training</a:t>
-            </a:r>
-            <a:r>
-              <a:rPr lang="de-AT" dirty="0"/>
-              <a:t> </a:t>
-            </a:r>
-            <a:r>
-              <a:rPr lang="de-AT" dirty="0" err="1"/>
-              <a:t>sessions</a:t>
-            </a:r>
-            <a:r>
-              <a:rPr lang="de-AT" dirty="0"/>
-              <a:t> </a:t>
-            </a:r>
-            <a:r>
-              <a:rPr lang="de-AT" dirty="0" err="1"/>
-              <a:t>with</a:t>
-            </a:r>
-            <a:r>
-              <a:rPr lang="de-AT" dirty="0"/>
-              <a:t> </a:t>
-            </a:r>
-            <a:r>
-              <a:rPr lang="de-AT" dirty="0" err="1"/>
-              <a:t>user</a:t>
-            </a:r>
-            <a:r>
-              <a:rPr lang="de-AT" dirty="0"/>
-              <a:t> </a:t>
+              <a:rPr lang="en-GB" noProof="0" dirty="0"/>
+              <a:t>Start new training sessions with user </a:t>
             </a:r>
             <a:br>
-              <a:rPr lang="de-AT" dirty="0"/>
+              <a:rPr lang="en-GB" noProof="0" dirty="0"/>
             </a:br>
             <a:r>
-              <a:rPr lang="de-AT" dirty="0" err="1"/>
+              <a:rPr lang="en-GB" noProof="0" dirty="0"/>
               <a:t>button</a:t>
             </a:r>
-            <a:endParaRPr lang="de-AT" dirty="0"/>
           </a:p>
         </p:txBody>
       </p:sp>
@@ -15392,86 +18389,73 @@
           <a:p>
             <a:r>
               <a:rPr lang="en-GB" noProof="0" dirty="0"/>
-              <a:t>Overlapping labels</a:t>
-            </a:r>
-            <a:r>
-              <a:rPr lang="en-GB" dirty="0"/>
-              <a:t>, DEEPCRAFT Studio sometimes set two labels above each other</a:t>
+              <a:t>Overlapping labels, DEEPCRAFT Studio sometimes set two labels above each other</a:t>
+            </a:r>
+          </a:p>
+          <a:p>
+            <a:r>
+              <a:rPr lang="en-GB" noProof="0" dirty="0"/>
+              <a:t>No clear indications on what makes model better or worse</a:t>
+            </a:r>
+          </a:p>
+          <a:p>
+            <a:r>
+              <a:rPr lang="en-GB" noProof="0" dirty="0"/>
+              <a:t>It was not achievable to enqueue Data fast enough in our </a:t>
+            </a:r>
+            <a:r>
+              <a:rPr lang="en-GB" noProof="0" dirty="0" err="1"/>
+              <a:t>Micropython</a:t>
+            </a:r>
+            <a:r>
+              <a:rPr lang="en-GB" noProof="0" dirty="0"/>
+              <a:t> Code (fastest Loop runtime 3ms). Needed to </a:t>
+            </a:r>
+            <a:r>
+              <a:rPr lang="en-GB" noProof="0" dirty="0" err="1"/>
+              <a:t>downsample</a:t>
+            </a:r>
+            <a:r>
+              <a:rPr lang="en-GB" noProof="0" dirty="0"/>
+              <a:t> our Data to 100Hz</a:t>
+            </a:r>
+          </a:p>
+          <a:p>
+            <a:r>
+              <a:rPr lang="en-GB" noProof="0" dirty="0"/>
+              <a:t>Using an if-selection to time enqueue did not work/lead to the PSOC6 stalling after a few seconds (Busy waiting). Used </a:t>
+            </a:r>
+            <a:r>
+              <a:rPr lang="en-GB" noProof="0" dirty="0" err="1"/>
+              <a:t>time.wait_ms</a:t>
+            </a:r>
+            <a:r>
+              <a:rPr lang="en-GB" noProof="0" dirty="0"/>
+              <a:t>() instead</a:t>
+            </a:r>
+          </a:p>
+          <a:p>
+            <a:r>
+              <a:rPr lang="en-GB" noProof="0" dirty="0"/>
+              <a:t>Predictions for one punch are greater than 0.6 over two contextual windows.</a:t>
+            </a:r>
+          </a:p>
+          <a:p>
+            <a:r>
+              <a:rPr lang="en-GB" noProof="0" dirty="0"/>
+              <a:t>Reaction and loop time got worse publishing messages to </a:t>
+            </a:r>
+            <a:r>
+              <a:rPr lang="en-GB" noProof="0" dirty="0" err="1"/>
+              <a:t>Ubidots</a:t>
             </a:r>
             <a:endParaRPr lang="en-GB" noProof="0" dirty="0"/>
           </a:p>
           <a:p>
-            <a:r>
-              <a:rPr lang="en-GB" noProof="0" dirty="0"/>
-              <a:t>No clear indications on what ma</a:t>
-            </a:r>
-            <a:r>
-              <a:rPr lang="en-GB" dirty="0" err="1"/>
-              <a:t>kes</a:t>
-            </a:r>
-            <a:r>
-              <a:rPr lang="en-GB" dirty="0"/>
-              <a:t> model better or worse</a:t>
-            </a:r>
-          </a:p>
-          <a:p>
-            <a:r>
-              <a:rPr lang="en-GB" dirty="0"/>
-              <a:t>It was not achievable to enqueue Data fast enough in our </a:t>
-            </a:r>
-            <a:r>
-              <a:rPr lang="en-GB" dirty="0" err="1"/>
-              <a:t>Micropython</a:t>
-            </a:r>
-            <a:r>
-              <a:rPr lang="en-GB" dirty="0"/>
-              <a:t> Code (fastest Loop runtime 3ms). Needed to </a:t>
-            </a:r>
-            <a:r>
-              <a:rPr lang="en-GB" dirty="0" err="1"/>
-              <a:t>downsample</a:t>
-            </a:r>
-            <a:r>
-              <a:rPr lang="en-GB" dirty="0"/>
-              <a:t> our Data to 100Hz</a:t>
-            </a:r>
-          </a:p>
-          <a:p>
-            <a:r>
-              <a:rPr lang="en-GB" dirty="0"/>
-              <a:t>Using an if-selection to time enqueue did not work/lead to the PSOC6 stalling after a few seconds (Busy waiting). Used </a:t>
-            </a:r>
-            <a:r>
-              <a:rPr lang="en-GB" dirty="0" err="1"/>
-              <a:t>time.wait_ms</a:t>
-            </a:r>
-            <a:r>
-              <a:rPr lang="en-GB" dirty="0"/>
-              <a:t>() instead</a:t>
-            </a:r>
-          </a:p>
-          <a:p>
-            <a:r>
-              <a:rPr lang="en-GB" dirty="0"/>
-              <a:t>Predictions for one punch are greater than 0.6 over two contextual windows.</a:t>
-            </a:r>
-          </a:p>
-          <a:p>
-            <a:r>
-              <a:rPr lang="en-GB" dirty="0"/>
-              <a:t>Reaction and loop time got worse publishing messages to </a:t>
-            </a:r>
-            <a:r>
-              <a:rPr lang="en-GB" dirty="0" err="1"/>
-              <a:t>Ubidots</a:t>
-            </a:r>
-            <a:endParaRPr lang="en-GB" dirty="0"/>
-          </a:p>
-          <a:p>
-            <a:endParaRPr lang="en-GB" dirty="0"/>
-          </a:p>
-          <a:p>
-            <a:endParaRPr lang="en-GB" dirty="0"/>
+            <a:endParaRPr lang="en-GB" noProof="0" dirty="0"/>
+          </a:p>
+          <a:p>
+            <a:endParaRPr lang="en-GB" noProof="0" dirty="0"/>
           </a:p>
           <a:p>
             <a:endParaRPr lang="en-GB" noProof="0" dirty="0"/>
@@ -15500,10 +18484,9 @@
           <a:lstStyle/>
           <a:p>
             <a:r>
-              <a:rPr lang="de-DE" noProof="0"/>
+              <a:rPr lang="en-GB" noProof="0" dirty="0"/>
               <a:t>23.02.2026</a:t>
             </a:r>
-            <a:endParaRPr lang="en-GB" noProof="0" dirty="0"/>
           </a:p>
         </p:txBody>
       </p:sp>
@@ -15717,10 +18700,9 @@
           <a:lstStyle/>
           <a:p>
             <a:r>
-              <a:rPr lang="de-DE" noProof="0"/>
+              <a:rPr lang="en-GB" noProof="0" dirty="0"/>
               <a:t>23.02.2026</a:t>
             </a:r>
-            <a:endParaRPr lang="en-GB" noProof="0" dirty="0"/>
           </a:p>
         </p:txBody>
       </p:sp>
@@ -15961,18 +18943,13 @@
           <a:lstStyle/>
           <a:p>
             <a:r>
-              <a:rPr lang="de-DE" dirty="0">
+              <a:rPr lang="en-GB" noProof="0" dirty="0">
                 <a:solidFill>
                   <a:schemeClr val="bg1"/>
                 </a:solidFill>
               </a:rPr>
               <a:t>23.02.2026</a:t>
             </a:r>
-            <a:endParaRPr lang="de-AT" dirty="0">
-              <a:solidFill>
-                <a:schemeClr val="bg1"/>
-              </a:solidFill>
-            </a:endParaRPr>
           </a:p>
         </p:txBody>
       </p:sp>
@@ -15998,14 +18975,14 @@
           <a:lstStyle/>
           <a:p>
             <a:fld id="{533690DF-FFD6-462A-8578-786984FF8DCB}" type="slidenum">
-              <a:rPr lang="de-AT" smtClean="0">
+              <a:rPr lang="en-GB" noProof="0" smtClean="0">
                 <a:solidFill>
                   <a:schemeClr val="bg1"/>
                 </a:solidFill>
               </a:rPr>
               <a:t>13</a:t>
             </a:fld>
-            <a:endParaRPr lang="de-AT" dirty="0">
+            <a:endParaRPr lang="en-GB" noProof="0" dirty="0">
               <a:solidFill>
                 <a:schemeClr val="bg1"/>
               </a:solidFill>
@@ -16028,7 +19005,7 @@
           <p:nvPr>
             <p:extLst>
               <p:ext uri="{D42A27DB-BD31-4B8C-83A1-F6EECF244321}">
-                <p14:modId xmlns:p14="http://schemas.microsoft.com/office/powerpoint/2010/main" val="2423330161"/>
+                <p14:modId xmlns:p14="http://schemas.microsoft.com/office/powerpoint/2010/main" val="774377457"/>
               </p:ext>
             </p:extLst>
           </p:nvPr>
@@ -16097,7 +19074,7 @@
               <a:defRPr/>
             </a:pPr>
             <a:r>
-              <a:rPr lang="en-GB" sz="4000" b="1" kern="0">
+              <a:rPr lang="en-GB" sz="4000" b="1" kern="0" noProof="0" dirty="0">
                 <a:solidFill>
                   <a:srgbClr val="FFFFFF"/>
                 </a:solidFill>
@@ -16106,7 +19083,7 @@
               </a:rPr>
               <a:t>About the future </a:t>
             </a:r>
-            <a:endParaRPr lang="en-GB" sz="4000" b="1" i="1" kern="0" baseline="30000">
+            <a:endParaRPr lang="en-GB" sz="4000" b="1" i="1" kern="0" baseline="30000" noProof="0" dirty="0">
               <a:solidFill>
                 <a:srgbClr val="FFFFFF"/>
               </a:solidFill>
@@ -16273,21 +19250,8 @@
                   <a:schemeClr val="bg1"/>
                 </a:solidFill>
               </a:rPr>
-              <a:t>Thank you for</a:t>
-            </a:r>
-            <a:r>
-              <a:rPr lang="en-GB" sz="6000" dirty="0">
-                <a:solidFill>
-                  <a:schemeClr val="bg1"/>
-                </a:solidFill>
-              </a:rPr>
-              <a:t> your attention!</a:t>
-            </a:r>
-            <a:endParaRPr lang="en-GB" sz="6000" noProof="0" dirty="0">
-              <a:solidFill>
-                <a:schemeClr val="bg1"/>
-              </a:solidFill>
-            </a:endParaRPr>
+              <a:t>Thank you for your attention!</a:t>
+            </a:r>
           </a:p>
         </p:txBody>
       </p:sp>
@@ -16325,7 +19289,23 @@
                   <a:schemeClr val="bg1"/>
                 </a:solidFill>
               </a:rPr>
-              <a:t>Tobias Riedelberger, Theo Corneux, Tobias Holzner</a:t>
+              <a:t>Tobias Riedelberger, Theo </a:t>
+            </a:r>
+            <a:r>
+              <a:rPr lang="en-GB" noProof="0" dirty="0" err="1">
+                <a:solidFill>
+                  <a:schemeClr val="bg1"/>
+                </a:solidFill>
+              </a:rPr>
+              <a:t>Corneux</a:t>
+            </a:r>
+            <a:r>
+              <a:rPr lang="en-GB" noProof="0" dirty="0">
+                <a:solidFill>
+                  <a:schemeClr val="bg1"/>
+                </a:solidFill>
+              </a:rPr>
+              <a:t>, Tobias Holzner</a:t>
             </a:r>
           </a:p>
         </p:txBody>
@@ -16403,10 +19383,9 @@
           <a:lstStyle/>
           <a:p>
             <a:r>
-              <a:rPr lang="de-DE" noProof="0"/>
+              <a:rPr lang="en-GB" noProof="0" dirty="0"/>
               <a:t>23.02.2026</a:t>
             </a:r>
-            <a:endParaRPr lang="en-GB" noProof="0" dirty="0"/>
           </a:p>
         </p:txBody>
       </p:sp>
@@ -16492,89 +19471,66 @@
           <a:p>
             <a:pPr lvl="0"/>
             <a:r>
-              <a:rPr lang="en-GB" dirty="0"/>
+              <a:rPr lang="en-GB" noProof="0" dirty="0"/>
               <a:t>Punch detection and analyzation with IMU</a:t>
             </a:r>
           </a:p>
           <a:p>
             <a:r>
-              <a:rPr lang="de-AT" dirty="0"/>
-              <a:t>Differentiation </a:t>
-            </a:r>
-            <a:r>
-              <a:rPr lang="de-AT" dirty="0" err="1"/>
-              <a:t>between</a:t>
-            </a:r>
-            <a:r>
-              <a:rPr lang="de-AT" dirty="0"/>
-              <a:t> </a:t>
-            </a:r>
-            <a:r>
-              <a:rPr lang="de-AT" dirty="0" err="1"/>
-              <a:t>punch</a:t>
-            </a:r>
-            <a:r>
-              <a:rPr lang="de-AT" dirty="0"/>
-              <a:t> </a:t>
-            </a:r>
-            <a:r>
-              <a:rPr lang="de-AT" dirty="0" err="1"/>
-              <a:t>types</a:t>
-            </a:r>
-            <a:endParaRPr lang="de-AT" dirty="0"/>
+              <a:rPr lang="en-GB" noProof="0" dirty="0"/>
+              <a:t>Differentiation between punch types</a:t>
+            </a:r>
           </a:p>
           <a:p>
             <a:pPr lvl="1"/>
             <a:r>
-              <a:rPr lang="de-AT" dirty="0"/>
+              <a:rPr lang="en-GB" noProof="0" dirty="0"/>
               <a:t>Jab</a:t>
             </a:r>
           </a:p>
           <a:p>
             <a:pPr lvl="1"/>
             <a:r>
-              <a:rPr lang="de-AT" dirty="0"/>
+              <a:rPr lang="en-GB" noProof="0" dirty="0"/>
               <a:t>Hook</a:t>
             </a:r>
           </a:p>
           <a:p>
             <a:pPr lvl="1"/>
             <a:r>
-              <a:rPr lang="de-AT" dirty="0"/>
+              <a:rPr lang="en-GB" noProof="0" dirty="0"/>
               <a:t>Uppercut</a:t>
             </a:r>
           </a:p>
           <a:p>
             <a:r>
-              <a:rPr lang="en-US" dirty="0"/>
+              <a:rPr lang="en-GB" noProof="0" dirty="0"/>
               <a:t>Goals</a:t>
             </a:r>
           </a:p>
           <a:p>
             <a:pPr lvl="1"/>
             <a:r>
-              <a:rPr lang="en-GB" dirty="0"/>
+              <a:rPr lang="en-GB" noProof="0" dirty="0"/>
               <a:t>Prevent developing habits/predictability</a:t>
             </a:r>
-            <a:endParaRPr lang="en-US" dirty="0"/>
           </a:p>
           <a:p>
             <a:pPr lvl="1"/>
             <a:r>
-              <a:rPr lang="en-GB" dirty="0"/>
+              <a:rPr lang="en-GB" noProof="0" dirty="0"/>
               <a:t>Game which gives different punch combinations</a:t>
             </a:r>
-            <a:endParaRPr lang="en-US" dirty="0"/>
           </a:p>
           <a:p>
             <a:pPr marL="0" indent="0">
               <a:buNone/>
             </a:pPr>
-            <a:endParaRPr lang="en-US" dirty="0"/>
+            <a:endParaRPr lang="en-GB" noProof="0" dirty="0"/>
           </a:p>
           <a:p>
             <a:pPr lvl="0"/>
-            <a:endParaRPr lang="en-US" dirty="0"/>
+            <a:endParaRPr lang="en-GB" noProof="0" dirty="0"/>
           </a:p>
         </p:txBody>
       </p:sp>
@@ -16600,10 +19556,9 @@
           <a:lstStyle/>
           <a:p>
             <a:r>
-              <a:rPr lang="de-DE" noProof="0"/>
+              <a:rPr lang="en-GB" noProof="0" dirty="0"/>
               <a:t>23.02.2026</a:t>
             </a:r>
-            <a:endParaRPr lang="en-GB" noProof="0" dirty="0"/>
           </a:p>
         </p:txBody>
       </p:sp>
@@ -16774,15 +19729,6 @@
           <a:effectLst>
             <a:reflection blurRad="12700" stA="38000" endPos="28000" dist="5000" dir="5400000" sy="-100000" algn="bl" rotWithShape="0"/>
           </a:effectLst>
-          <a:extLst>
-            <a:ext uri="{909E8E84-426E-40DD-AFC4-6F175D3DCCD1}">
-              <a14:hiddenFill xmlns:a14="http://schemas.microsoft.com/office/drawing/2010/main">
-                <a:solidFill>
-                  <a:srgbClr val="FFFFFF"/>
-                </a:solidFill>
-              </a14:hiddenFill>
-            </a:ext>
-          </a:extLst>
         </p:spPr>
       </p:pic>
     </p:spTree>
@@ -16885,7 +19831,7 @@
           <a:lstStyle/>
           <a:p>
             <a:pPr algn="ctr"/>
-            <a:endParaRPr lang="en-US"/>
+            <a:endParaRPr lang="en-GB" noProof="0" dirty="0"/>
           </a:p>
         </p:txBody>
       </p:sp>
@@ -17026,7 +19972,7 @@
               <a:tabLst/>
               <a:defRPr/>
             </a:pPr>
-            <a:endParaRPr kumimoji="0" lang="en-US" sz="1800" b="0" i="0" u="none" strike="noStrike" kern="1200" cap="none" spc="0" normalizeH="0" baseline="0" noProof="0">
+            <a:endParaRPr kumimoji="0" lang="en-GB" sz="1800" b="0" i="0" u="none" strike="noStrike" kern="1200" cap="none" spc="0" normalizeH="0" baseline="0" noProof="0" dirty="0">
               <a:ln>
                 <a:noFill/>
               </a:ln>
@@ -17077,10 +20023,9 @@
               </a:spcAft>
             </a:pPr>
             <a:r>
-              <a:rPr lang="de-DE" noProof="0"/>
+              <a:rPr lang="en-GB" noProof="0" dirty="0"/>
               <a:t>23.02.2026</a:t>
             </a:r>
-            <a:endParaRPr lang="en-GB" noProof="0"/>
           </a:p>
         </p:txBody>
       </p:sp>
@@ -17220,7 +20165,7 @@
           <a:lstStyle/>
           <a:p>
             <a:pPr algn="ctr"/>
-            <a:endParaRPr lang="en-US" dirty="0"/>
+            <a:endParaRPr lang="en-GB" noProof="0" dirty="0"/>
           </a:p>
         </p:txBody>
       </p:sp>
@@ -17345,7 +20290,7 @@
               </a:pPr>
               <a:t>3</a:t>
             </a:fld>
-            <a:endParaRPr lang="en-GB" noProof="0">
+            <a:endParaRPr lang="en-GB" noProof="0" dirty="0">
               <a:solidFill>
                 <a:srgbClr val="FFFFFF"/>
               </a:solidFill>
@@ -17445,6 +20390,11 @@
           </p:cNvGraphicFramePr>
           <p:nvPr>
             <p:ph idx="1"/>
+            <p:extLst>
+              <p:ext uri="{D42A27DB-BD31-4B8C-83A1-F6EECF244321}">
+                <p14:modId xmlns:p14="http://schemas.microsoft.com/office/powerpoint/2010/main" val="2204171667"/>
+              </p:ext>
+            </p:extLst>
           </p:nvPr>
         </p:nvGraphicFramePr>
         <p:xfrm>
@@ -17515,41 +20465,41 @@
           <a:lstStyle/>
           <a:p>
             <a:r>
-              <a:rPr lang="en-GB" dirty="0"/>
+              <a:rPr lang="en-GB" noProof="0" dirty="0"/>
               <a:t>Sampled roughly 1h30min of data</a:t>
             </a:r>
           </a:p>
           <a:p>
             <a:pPr lvl="1"/>
             <a:r>
-              <a:rPr lang="en-GB" dirty="0"/>
+              <a:rPr lang="en-GB" noProof="0" dirty="0"/>
               <a:t>1h labelled and rest unlabelled</a:t>
             </a:r>
           </a:p>
           <a:p>
             <a:pPr lvl="1"/>
             <a:r>
-              <a:rPr lang="en-GB" dirty="0"/>
+              <a:rPr lang="en-GB" noProof="0" dirty="0"/>
               <a:t>Collection of right-hand punches</a:t>
             </a:r>
           </a:p>
           <a:p>
             <a:r>
-              <a:rPr lang="en-GB" dirty="0"/>
+              <a:rPr lang="en-GB" noProof="0" dirty="0"/>
               <a:t>Collection of various punch techniques and speed</a:t>
             </a:r>
           </a:p>
           <a:p>
             <a:r>
-              <a:rPr lang="en-GB" dirty="0"/>
+              <a:rPr lang="en-GB" noProof="0" dirty="0"/>
               <a:t>IMU Frequency of 400Hz</a:t>
             </a:r>
           </a:p>
           <a:p>
-            <a:endParaRPr lang="en-GB" dirty="0"/>
-          </a:p>
-          <a:p>
-            <a:endParaRPr lang="en-GB" dirty="0"/>
+            <a:endParaRPr lang="en-GB" noProof="0" dirty="0"/>
+          </a:p>
+          <a:p>
+            <a:endParaRPr lang="en-GB" noProof="0" dirty="0"/>
           </a:p>
         </p:txBody>
       </p:sp>
@@ -17575,10 +20525,9 @@
           <a:lstStyle/>
           <a:p>
             <a:r>
-              <a:rPr lang="de-DE" noProof="0"/>
+              <a:rPr lang="en-GB" noProof="0" dirty="0"/>
               <a:t>23.02.2026</a:t>
             </a:r>
-            <a:endParaRPr lang="en-GB" noProof="0" dirty="0"/>
           </a:p>
         </p:txBody>
       </p:sp>
@@ -17832,33 +20781,33 @@
           <a:lstStyle/>
           <a:p>
             <a:r>
-              <a:rPr lang="en-GB" dirty="0"/>
+              <a:rPr lang="en-GB" noProof="0" dirty="0"/>
               <a:t>Data of one person</a:t>
             </a:r>
           </a:p>
           <a:p>
             <a:pPr lvl="1"/>
             <a:r>
-              <a:rPr lang="en-GB" dirty="0"/>
+              <a:rPr lang="en-GB" noProof="0" dirty="0"/>
               <a:t>greater accuracy</a:t>
             </a:r>
           </a:p>
           <a:p>
             <a:pPr lvl="1"/>
             <a:r>
-              <a:rPr lang="en-GB" dirty="0"/>
+              <a:rPr lang="en-GB" noProof="0" dirty="0"/>
               <a:t>45 minutes of data, 18,5 of which are labelled</a:t>
             </a:r>
           </a:p>
           <a:p>
             <a:r>
-              <a:rPr lang="en-GB" dirty="0"/>
+              <a:rPr lang="en-GB" noProof="0" dirty="0"/>
               <a:t>Train/Validation/Test split is roughly 60/20/20</a:t>
             </a:r>
           </a:p>
           <a:p>
             <a:r>
-              <a:rPr lang="en-GB" dirty="0"/>
+              <a:rPr lang="en-GB" noProof="0" dirty="0"/>
               <a:t>Implementation of negative Data</a:t>
             </a:r>
           </a:p>
@@ -17889,10 +20838,9 @@
           <a:lstStyle/>
           <a:p>
             <a:r>
-              <a:rPr lang="de-DE" noProof="0"/>
+              <a:rPr lang="en-GB" noProof="0" dirty="0"/>
               <a:t>23.02.2026</a:t>
             </a:r>
-            <a:endParaRPr lang="en-GB" noProof="0" dirty="0"/>
           </a:p>
         </p:txBody>
       </p:sp>
@@ -18223,7 +21171,7 @@
           </a:lstStyle>
           <a:p>
             <a:pPr algn="ctr"/>
-            <a:endParaRPr lang="en-US"/>
+            <a:endParaRPr lang="en-GB" noProof="0" dirty="0"/>
           </a:p>
         </p:txBody>
       </p:sp>
@@ -18298,18 +21246,13 @@
               </a:spcAft>
             </a:pPr>
             <a:r>
-              <a:rPr lang="de-DE" noProof="0">
+              <a:rPr lang="en-GB" noProof="0" dirty="0">
                 <a:solidFill>
                   <a:srgbClr val="FFFFFF"/>
                 </a:solidFill>
               </a:rPr>
               <a:t>23.02.2026</a:t>
             </a:r>
-            <a:endParaRPr lang="en-US" noProof="0">
-              <a:solidFill>
-                <a:srgbClr val="FFFFFF"/>
-              </a:solidFill>
-            </a:endParaRPr>
           </a:p>
         </p:txBody>
       </p:sp>
@@ -18347,7 +21290,7 @@
               </a:spcAft>
             </a:pPr>
             <a:fld id="{533690DF-FFD6-462A-8578-786984FF8DCB}" type="slidenum">
-              <a:rPr lang="en-US" noProof="0">
+              <a:rPr lang="en-GB" noProof="0" smtClean="0">
                 <a:solidFill>
                   <a:srgbClr val="FFFFFF"/>
                 </a:solidFill>
@@ -18359,7 +21302,7 @@
               </a:pPr>
               <a:t>6</a:t>
             </a:fld>
-            <a:endParaRPr lang="en-US" noProof="0">
+            <a:endParaRPr lang="en-GB" noProof="0" dirty="0">
               <a:solidFill>
                 <a:srgbClr val="FFFFFF"/>
               </a:solidFill>
@@ -18515,41 +21458,41 @@
           <a:lstStyle/>
           <a:p>
             <a:r>
-              <a:rPr lang="en-GB" dirty="0"/>
+              <a:rPr lang="en-GB" noProof="0" dirty="0"/>
               <a:t>Contextual Window </a:t>
             </a:r>
           </a:p>
           <a:p>
             <a:r>
-              <a:rPr lang="en-GB" dirty="0"/>
+              <a:rPr lang="en-GB" noProof="0" dirty="0"/>
               <a:t>Created a model with:</a:t>
             </a:r>
           </a:p>
           <a:p>
             <a:pPr lvl="1"/>
             <a:r>
-              <a:rPr lang="en-GB" dirty="0"/>
+              <a:rPr lang="en-GB" noProof="0" dirty="0"/>
               <a:t>Model Family Conv1d</a:t>
             </a:r>
           </a:p>
           <a:p>
             <a:pPr lvl="1"/>
             <a:r>
-              <a:rPr lang="en-GB" dirty="0"/>
+              <a:rPr lang="en-GB" noProof="0" dirty="0"/>
               <a:t>Medium Model Size</a:t>
             </a:r>
           </a:p>
           <a:p>
             <a:pPr lvl="1"/>
             <a:r>
-              <a:rPr lang="en-GB" dirty="0"/>
+              <a:rPr lang="en-GB" noProof="0" dirty="0"/>
               <a:t>Balanced Optimization</a:t>
             </a:r>
           </a:p>
           <a:p>
             <a:pPr lvl="1"/>
             <a:r>
-              <a:rPr lang="en-GB" dirty="0"/>
+              <a:rPr lang="en-GB" noProof="0" dirty="0"/>
               <a:t>Mid Learning Rate &amp; Regularization</a:t>
             </a:r>
           </a:p>
@@ -18557,17 +21500,17 @@
             <a:pPr marL="457200" lvl="1" indent="0">
               <a:buNone/>
             </a:pPr>
-            <a:endParaRPr lang="en-GB" dirty="0"/>
-          </a:p>
-          <a:p>
-            <a:r>
-              <a:rPr lang="en-GB" dirty="0"/>
+            <a:endParaRPr lang="en-GB" noProof="0" dirty="0"/>
+          </a:p>
+          <a:p>
+            <a:r>
+              <a:rPr lang="en-GB" noProof="0" dirty="0"/>
               <a:t>Different parameters used</a:t>
             </a:r>
           </a:p>
           <a:p>
             <a:r>
-              <a:rPr lang="en-GB" dirty="0"/>
+              <a:rPr lang="en-GB" noProof="0" dirty="0"/>
               <a:t>Selection of classification with best test statistics</a:t>
             </a:r>
           </a:p>
@@ -18595,10 +21538,9 @@
           <a:lstStyle/>
           <a:p>
             <a:r>
-              <a:rPr lang="de-DE" noProof="0"/>
+              <a:rPr lang="en-GB" noProof="0" dirty="0"/>
               <a:t>23.02.2026</a:t>
             </a:r>
-            <a:endParaRPr lang="en-GB" noProof="0" dirty="0"/>
           </a:p>
         </p:txBody>
       </p:sp>
@@ -18880,7 +21822,7 @@
               <a:tabLst/>
               <a:defRPr/>
             </a:pPr>
-            <a:endParaRPr kumimoji="0" lang="en-US" sz="1800" b="0" i="0" u="none" strike="noStrike" kern="1200" cap="none" spc="0" normalizeH="0" baseline="0" noProof="0">
+            <a:endParaRPr kumimoji="0" lang="en-GB" sz="1800" b="0" i="0" u="none" strike="noStrike" kern="1200" cap="none" spc="0" normalizeH="0" baseline="0" noProof="0" dirty="0">
               <a:ln>
                 <a:noFill/>
               </a:ln>
@@ -18990,19 +21932,14 @@
           </a:p>
           <a:p>
             <a:r>
-              <a:rPr lang="en-GB" dirty="0"/>
+              <a:rPr lang="en-GB" noProof="0" dirty="0"/>
               <a:t>Conversion to usable MP-model</a:t>
             </a:r>
-            <a:endParaRPr lang="en-GB" noProof="0" dirty="0"/>
           </a:p>
           <a:p>
             <a:r>
               <a:rPr lang="en-GB" noProof="0" dirty="0"/>
-              <a:t>Implementation</a:t>
-            </a:r>
-            <a:r>
-              <a:rPr lang="en-GB" dirty="0"/>
-              <a:t> in two programs</a:t>
+              <a:t>Implementation in two programs</a:t>
             </a:r>
           </a:p>
           <a:p>
@@ -19088,7 +22025,7 @@
               <a:tabLst/>
               <a:defRPr/>
             </a:pPr>
-            <a:endParaRPr kumimoji="0" lang="en-US" sz="1800" b="0" i="0" u="none" strike="noStrike" kern="1200" cap="none" spc="0" normalizeH="0" baseline="0" noProof="0">
+            <a:endParaRPr kumimoji="0" lang="en-GB" sz="1800" b="0" i="0" u="none" strike="noStrike" kern="1200" cap="none" spc="0" normalizeH="0" baseline="0" noProof="0" dirty="0">
               <a:ln>
                 <a:noFill/>
               </a:ln>
@@ -19151,7 +22088,7 @@
               <a:defRPr/>
             </a:pPr>
             <a:r>
-              <a:rPr kumimoji="0" lang="de-DE" sz="1200" b="0" i="0" u="none" strike="noStrike" kern="1200" cap="none" spc="0" normalizeH="0" baseline="0" noProof="0">
+              <a:rPr kumimoji="0" lang="en-GB" sz="1200" b="0" i="0" u="none" strike="noStrike" kern="1200" cap="none" spc="0" normalizeH="0" baseline="0" noProof="0" dirty="0">
                 <a:ln>
                   <a:noFill/>
                 </a:ln>
@@ -19169,22 +22106,6 @@
               </a:rPr>
               <a:t>23.02.2026</a:t>
             </a:r>
-            <a:endParaRPr kumimoji="0" lang="en-GB" sz="1200" b="0" i="0" u="none" strike="noStrike" kern="1200" cap="none" spc="0" normalizeH="0" baseline="0" noProof="0">
-              <a:ln>
-                <a:noFill/>
-              </a:ln>
-              <a:solidFill>
-                <a:prstClr val="black">
-                  <a:tint val="82000"/>
-                </a:prstClr>
-              </a:solidFill>
-              <a:effectLst/>
-              <a:uLnTx/>
-              <a:uFillTx/>
-              <a:latin typeface="Aptos" panose="02110004020202020204"/>
-              <a:ea typeface="+mn-ea"/>
-              <a:cs typeface="+mn-cs"/>
-            </a:endParaRPr>
           </a:p>
         </p:txBody>
       </p:sp>
@@ -19334,7 +22255,7 @@
               <a:tabLst/>
               <a:defRPr/>
             </a:pPr>
-            <a:endParaRPr kumimoji="0" lang="en-US" sz="1800" b="0" i="0" u="none" strike="noStrike" kern="1200" cap="none" spc="0" normalizeH="0" baseline="0" noProof="0" dirty="0">
+            <a:endParaRPr kumimoji="0" lang="en-GB" sz="1800" b="0" i="0" u="none" strike="noStrike" kern="1200" cap="none" spc="0" normalizeH="0" baseline="0" noProof="0" dirty="0">
               <a:ln>
                 <a:noFill/>
               </a:ln>
@@ -19430,7 +22351,7 @@
               </a:pPr>
               <a:t>8</a:t>
             </a:fld>
-            <a:endParaRPr kumimoji="0" lang="en-GB" sz="1200" b="0" i="0" u="none" strike="noStrike" kern="1200" cap="none" spc="0" normalizeH="0" baseline="0" noProof="0">
+            <a:endParaRPr kumimoji="0" lang="en-GB" sz="1200" b="0" i="0" u="none" strike="noStrike" kern="1200" cap="none" spc="0" normalizeH="0" baseline="0" noProof="0" dirty="0">
               <a:ln>
                 <a:noFill/>
               </a:ln>
@@ -19505,7 +22426,7 @@
               <a:tabLst/>
               <a:defRPr/>
             </a:pPr>
-            <a:endParaRPr kumimoji="0" lang="de-AT" sz="1800" b="0" i="0" u="none" strike="noStrike" kern="1200" cap="none" spc="0" normalizeH="0" baseline="0" noProof="0">
+            <a:endParaRPr kumimoji="0" lang="en-GB" sz="1800" b="0" i="0" u="none" strike="noStrike" kern="1200" cap="none" spc="0" normalizeH="0" baseline="0" noProof="0" dirty="0">
               <a:ln>
                 <a:noFill/>
               </a:ln>
@@ -19763,52 +22684,52 @@
           <a:lstStyle/>
           <a:p>
             <a:r>
-              <a:rPr lang="en-GB" dirty="0"/>
+              <a:rPr lang="en-GB" noProof="0" dirty="0"/>
               <a:t>Transmission of punch data to client via </a:t>
             </a:r>
             <a:r>
-              <a:rPr lang="en-GB" dirty="0" err="1"/>
+              <a:rPr lang="en-GB" noProof="0" dirty="0" err="1"/>
               <a:t>WiFi</a:t>
             </a:r>
-            <a:endParaRPr lang="en-GB" dirty="0"/>
+            <a:endParaRPr lang="en-GB" noProof="0" dirty="0"/>
           </a:p>
           <a:p>
             <a:pPr marL="0" indent="0">
               <a:buNone/>
             </a:pPr>
-            <a:endParaRPr lang="en-GB" dirty="0"/>
-          </a:p>
-          <a:p>
-            <a:r>
-              <a:rPr lang="en-GB" dirty="0"/>
+            <a:endParaRPr lang="en-GB" noProof="0" dirty="0"/>
+          </a:p>
+          <a:p>
+            <a:r>
+              <a:rPr lang="en-GB" noProof="0" dirty="0"/>
               <a:t>Mode of operation</a:t>
             </a:r>
           </a:p>
           <a:p>
             <a:pPr lvl="1"/>
             <a:r>
-              <a:rPr lang="en-GB" dirty="0"/>
+              <a:rPr lang="en-GB" noProof="0" dirty="0"/>
               <a:t>Read Acceleration and Gyroscope data</a:t>
             </a:r>
           </a:p>
           <a:p>
             <a:pPr lvl="1"/>
             <a:r>
-              <a:rPr lang="en-GB" dirty="0"/>
+              <a:rPr lang="en-GB" noProof="0" dirty="0"/>
               <a:t>Hand over data to model</a:t>
             </a:r>
           </a:p>
           <a:p>
             <a:pPr lvl="1"/>
             <a:r>
-              <a:rPr lang="en-GB" dirty="0"/>
+              <a:rPr lang="en-GB" noProof="0" dirty="0"/>
               <a:t>Decision Logic</a:t>
             </a:r>
           </a:p>
           <a:p>
             <a:pPr lvl="1"/>
             <a:r>
-              <a:rPr lang="en-GB" dirty="0"/>
+              <a:rPr lang="en-GB" noProof="0" dirty="0"/>
               <a:t>Transmission of result to client</a:t>
             </a:r>
           </a:p>
@@ -19816,11 +22737,11 @@
             <a:pPr marL="457200" lvl="1" indent="0">
               <a:buNone/>
             </a:pPr>
-            <a:endParaRPr lang="en-GB" dirty="0"/>
-          </a:p>
-          <a:p>
-            <a:r>
-              <a:rPr lang="en-GB" dirty="0"/>
+            <a:endParaRPr lang="en-GB" noProof="0" dirty="0"/>
+          </a:p>
+          <a:p>
+            <a:r>
+              <a:rPr lang="en-GB" noProof="0" dirty="0"/>
               <a:t>Calculating velocity of punch using the IMU-acceleration</a:t>
             </a:r>
           </a:p>
@@ -19848,10 +22769,9 @@
           <a:lstStyle/>
           <a:p>
             <a:r>
-              <a:rPr lang="de-DE" noProof="0"/>
+              <a:rPr lang="en-GB" noProof="0" dirty="0"/>
               <a:t>23.02.2026</a:t>
             </a:r>
-            <a:endParaRPr lang="en-GB" noProof="0" dirty="0"/>
           </a:p>
         </p:txBody>
       </p:sp>
@@ -20642,6 +23562,14 @@
 </file>
 
 <file path=customXml/item1.xml><?xml version="1.0" encoding="utf-8"?>
+<p:properties xmlns:p="http://schemas.microsoft.com/office/2006/metadata/properties" xmlns:xsi="http://www.w3.org/2001/XMLSchema-instance" xmlns:pc="http://schemas.microsoft.com/office/infopath/2007/PartnerControls">
+  <documentManagement>
+    <_activity xmlns="bf1a47b5-10f0-4178-af4a-bbe7cc4004c3" xsi:nil="true"/>
+  </documentManagement>
+</p:properties>
+</file>
+
+<file path=customXml/item2.xml><?xml version="1.0" encoding="utf-8"?>
 <ct:contentTypeSchema xmlns:ct="http://schemas.microsoft.com/office/2006/metadata/contentType" xmlns:ma="http://schemas.microsoft.com/office/2006/metadata/properties/metaAttributes" ct:_="" ma:_="" ma:contentTypeName="Dokument" ma:contentTypeID="0x010100B041D5FB7F9ADB4FA3268D6933894E4E" ma:contentTypeVersion="11" ma:contentTypeDescription="Ein neues Dokument erstellen." ma:contentTypeScope="" ma:versionID="1716f861161e7a5f6104ad8e56853467">
   <xsd:schema xmlns:xsd="http://www.w3.org/2001/XMLSchema" xmlns:xs="http://www.w3.org/2001/XMLSchema" xmlns:p="http://schemas.microsoft.com/office/2006/metadata/properties" xmlns:ns3="bf1a47b5-10f0-4178-af4a-bbe7cc4004c3" targetNamespace="http://schemas.microsoft.com/office/2006/metadata/properties" ma:root="true" ma:fieldsID="8ee1bf931531000dc41501df99fd4e2b" ns3:_="">
     <xsd:import namespace="bf1a47b5-10f0-4178-af4a-bbe7cc4004c3"/>
@@ -20829,14 +23757,6 @@
 </ct:contentTypeSchema>
 </file>
 
-<file path=customXml/item2.xml><?xml version="1.0" encoding="utf-8"?>
-<p:properties xmlns:p="http://schemas.microsoft.com/office/2006/metadata/properties" xmlns:xsi="http://www.w3.org/2001/XMLSchema-instance" xmlns:pc="http://schemas.microsoft.com/office/infopath/2007/PartnerControls">
-  <documentManagement>
-    <_activity xmlns="bf1a47b5-10f0-4178-af4a-bbe7cc4004c3" xsi:nil="true"/>
-  </documentManagement>
-</p:properties>
-</file>
-
 <file path=customXml/item3.xml><?xml version="1.0" encoding="utf-8"?>
 <?mso-contentType ?>
 <FormTemplates xmlns="http://schemas.microsoft.com/sharepoint/v3/contenttype/forms">
@@ -20847,6 +23767,22 @@
 </file>
 
 <file path=customXml/itemProps1.xml><?xml version="1.0" encoding="utf-8"?>
+<ds:datastoreItem xmlns:ds="http://schemas.openxmlformats.org/officeDocument/2006/customXml" ds:itemID="{2C2A40F2-5398-4DE1-A8FC-C0BA56DCE4EA}">
+  <ds:schemaRefs>
+    <ds:schemaRef ds:uri="bf1a47b5-10f0-4178-af4a-bbe7cc4004c3"/>
+    <ds:schemaRef ds:uri="http://purl.org/dc/terms/"/>
+    <ds:schemaRef ds:uri="http://schemas.microsoft.com/office/infopath/2007/PartnerControls"/>
+    <ds:schemaRef ds:uri="http://schemas.openxmlformats.org/package/2006/metadata/core-properties"/>
+    <ds:schemaRef ds:uri="http://purl.org/dc/elements/1.1/"/>
+    <ds:schemaRef ds:uri="http://schemas.microsoft.com/office/2006/documentManagement/types"/>
+    <ds:schemaRef ds:uri="http://www.w3.org/XML/1998/namespace"/>
+    <ds:schemaRef ds:uri="http://purl.org/dc/dcmitype/"/>
+    <ds:schemaRef ds:uri="http://schemas.microsoft.com/office/2006/metadata/properties"/>
+  </ds:schemaRefs>
+</ds:datastoreItem>
+</file>
+
+<file path=customXml/itemProps2.xml><?xml version="1.0" encoding="utf-8"?>
 <ds:datastoreItem xmlns:ds="http://schemas.openxmlformats.org/officeDocument/2006/customXml" ds:itemID="{68909959-C625-4C65-88C3-A1F8ACE56D22}">
   <ds:schemaRefs>
     <ds:schemaRef ds:uri="http://schemas.microsoft.com/office/2006/metadata/contentType"/>
@@ -20864,22 +23800,6 @@
 </ds:datastoreItem>
 </file>
 
-<file path=customXml/itemProps2.xml><?xml version="1.0" encoding="utf-8"?>
-<ds:datastoreItem xmlns:ds="http://schemas.openxmlformats.org/officeDocument/2006/customXml" ds:itemID="{2C2A40F2-5398-4DE1-A8FC-C0BA56DCE4EA}">
-  <ds:schemaRefs>
-    <ds:schemaRef ds:uri="bf1a47b5-10f0-4178-af4a-bbe7cc4004c3"/>
-    <ds:schemaRef ds:uri="http://purl.org/dc/terms/"/>
-    <ds:schemaRef ds:uri="http://schemas.microsoft.com/office/infopath/2007/PartnerControls"/>
-    <ds:schemaRef ds:uri="http://schemas.openxmlformats.org/package/2006/metadata/core-properties"/>
-    <ds:schemaRef ds:uri="http://purl.org/dc/elements/1.1/"/>
-    <ds:schemaRef ds:uri="http://schemas.microsoft.com/office/2006/documentManagement/types"/>
-    <ds:schemaRef ds:uri="http://www.w3.org/XML/1998/namespace"/>
-    <ds:schemaRef ds:uri="http://purl.org/dc/dcmitype/"/>
-    <ds:schemaRef ds:uri="http://schemas.microsoft.com/office/2006/metadata/properties"/>
-  </ds:schemaRefs>
-</ds:datastoreItem>
-</file>
-
 <file path=customXml/itemProps3.xml><?xml version="1.0" encoding="utf-8"?>
 <ds:datastoreItem xmlns:ds="http://schemas.openxmlformats.org/officeDocument/2006/customXml" ds:itemID="{D12945CB-A677-4013-820C-0AEFE2C4DC48}">
   <ds:schemaRefs>

</xml_diff>

<commit_message>
Slight changes for final programs, slight changes for final presentation
</commit_message>
<xml_diff>
--- a/report/Präsentation_final.pptx
+++ b/report/Präsentation_final.pptx
@@ -6835,6 +6835,103 @@
           <a:bodyPr/>
           <a:lstStyle/>
           <a:p>
+            <a:r>
+              <a:rPr lang="en-US" dirty="0"/>
+              <a:t>The second, more advanced part of the project involved connecting to an </a:t>
+            </a:r>
+            <a:r>
+              <a:rPr lang="en-US" b="1" dirty="0"/>
+              <a:t>MQTT broker</a:t>
+            </a:r>
+            <a:r>
+              <a:rPr lang="en-US" dirty="0"/>
+              <a:t> to publish the detected </a:t>
+            </a:r>
+            <a:r>
+              <a:rPr lang="en-US" b="1" dirty="0"/>
+              <a:t>punch types</a:t>
+            </a:r>
+            <a:r>
+              <a:rPr lang="en-US" dirty="0"/>
+              <a:t>.</a:t>
+            </a:r>
+          </a:p>
+          <a:p>
+            <a:endParaRPr lang="en-US" dirty="0"/>
+          </a:p>
+          <a:p>
+            <a:r>
+              <a:rPr lang="en-US" dirty="0"/>
+              <a:t>We used </a:t>
+            </a:r>
+            <a:r>
+              <a:rPr lang="en-US" b="1" dirty="0" err="1"/>
+              <a:t>Ubidots</a:t>
+            </a:r>
+            <a:r>
+              <a:rPr lang="en-US" dirty="0"/>
+              <a:t> as our web dashboard to provide a clear and organized </a:t>
+            </a:r>
+            <a:r>
+              <a:rPr lang="en-US" b="1" dirty="0"/>
+              <a:t>content table</a:t>
+            </a:r>
+            <a:r>
+              <a:rPr lang="en-US" dirty="0"/>
+              <a:t> for the data.</a:t>
+            </a:r>
+          </a:p>
+          <a:p>
+            <a:endParaRPr lang="en-US" dirty="0"/>
+          </a:p>
+          <a:p>
+            <a:r>
+              <a:rPr lang="en-US" dirty="0"/>
+              <a:t>The dashboard includes a </a:t>
+            </a:r>
+            <a:r>
+              <a:rPr lang="en-US" b="1" dirty="0"/>
+              <a:t>Session Control</a:t>
+            </a:r>
+            <a:r>
+              <a:rPr lang="en-US" dirty="0"/>
+              <a:t> column with custom </a:t>
+            </a:r>
+            <a:r>
+              <a:rPr lang="en-US" b="1" dirty="0"/>
+              <a:t>session names</a:t>
+            </a:r>
+            <a:r>
+              <a:rPr lang="en-US" dirty="0"/>
+              <a:t>, allowing users to track their progress and achievements for each individual training.</a:t>
+            </a:r>
+          </a:p>
+          <a:p>
+            <a:endParaRPr lang="en-US" dirty="0"/>
+          </a:p>
+          <a:p>
+            <a:r>
+              <a:rPr lang="en-US" dirty="0"/>
+              <a:t>A </a:t>
+            </a:r>
+            <a:r>
+              <a:rPr lang="en-US" b="1" dirty="0"/>
+              <a:t>new session</a:t>
+            </a:r>
+            <a:r>
+              <a:rPr lang="en-US" dirty="0"/>
+              <a:t> can be triggered easily by pressing the </a:t>
+            </a:r>
+            <a:r>
+              <a:rPr lang="en-US" b="1" dirty="0"/>
+              <a:t>user button</a:t>
+            </a:r>
+            <a:r>
+              <a:rPr lang="en-US" dirty="0"/>
+              <a:t> directly on the board.</a:t>
+            </a:r>
+          </a:p>
+          <a:p>
             <a:endParaRPr lang="de-AT" dirty="0"/>
           </a:p>
         </p:txBody>
@@ -14262,6 +14359,130 @@
         <p:txBody>
           <a:bodyPr/>
           <a:lstStyle/>
+          <a:p>
+            <a:r>
+              <a:rPr lang="en-US" sz="2000" b="1" dirty="0" err="1"/>
+              <a:t>MicroPython</a:t>
+            </a:r>
+            <a:r>
+              <a:rPr lang="en-US" sz="2000" b="1" dirty="0"/>
+              <a:t> Implementation:</a:t>
+            </a:r>
+            <a:r>
+              <a:rPr lang="en-US" sz="2000" dirty="0"/>
+              <a:t> The final phase of the project focused on the </a:t>
+            </a:r>
+            <a:r>
+              <a:rPr lang="en-US" sz="2000" b="1" dirty="0" err="1"/>
+              <a:t>MicroPython</a:t>
+            </a:r>
+            <a:r>
+              <a:rPr lang="en-US" sz="2000" b="1" dirty="0"/>
+              <a:t> code</a:t>
+            </a:r>
+            <a:r>
+              <a:rPr lang="en-US" sz="2000" dirty="0"/>
+              <a:t> development.</a:t>
+            </a:r>
+          </a:p>
+          <a:p>
+            <a:endParaRPr lang="en-US" sz="2000" dirty="0"/>
+          </a:p>
+          <a:p>
+            <a:r>
+              <a:rPr lang="en-US" sz="2000" b="1" dirty="0"/>
+              <a:t>Model Conversion:</a:t>
+            </a:r>
+            <a:r>
+              <a:rPr lang="en-US" sz="2000" dirty="0"/>
+              <a:t> We selected the model with the </a:t>
+            </a:r>
+            <a:r>
+              <a:rPr lang="en-US" sz="2000" b="1" dirty="0"/>
+              <a:t>best statistical performance</a:t>
+            </a:r>
+            <a:r>
+              <a:rPr lang="en-US" sz="2000" dirty="0"/>
+              <a:t>, generated the corresponding </a:t>
+            </a:r>
+            <a:r>
+              <a:rPr lang="en-US" sz="2000" b="1" dirty="0"/>
+              <a:t>C code</a:t>
+            </a:r>
+            <a:r>
+              <a:rPr lang="en-US" sz="2000" dirty="0"/>
+              <a:t>, and converted it into </a:t>
+            </a:r>
+            <a:r>
+              <a:rPr lang="en-US" sz="2000" b="1" dirty="0"/>
+              <a:t>functional </a:t>
+            </a:r>
+            <a:r>
+              <a:rPr lang="en-US" sz="2000" b="1" dirty="0" err="1"/>
+              <a:t>MicroPython</a:t>
+            </a:r>
+            <a:r>
+              <a:rPr lang="en-US" sz="2000" b="1" dirty="0"/>
+              <a:t> code</a:t>
+            </a:r>
+            <a:r>
+              <a:rPr lang="en-US" sz="2000" dirty="0"/>
+              <a:t>.</a:t>
+            </a:r>
+          </a:p>
+          <a:p>
+            <a:endParaRPr lang="en-US" sz="2000" dirty="0"/>
+          </a:p>
+          <a:p>
+            <a:r>
+              <a:rPr lang="en-US" sz="2000" b="1" dirty="0"/>
+              <a:t>Integration:</a:t>
+            </a:r>
+            <a:r>
+              <a:rPr lang="en-US" sz="2000" dirty="0"/>
+              <a:t> This model was integrated into </a:t>
+            </a:r>
+            <a:r>
+              <a:rPr lang="en-US" sz="2000" b="1" dirty="0"/>
+              <a:t>two separate programs</a:t>
+            </a:r>
+            <a:r>
+              <a:rPr lang="en-US" sz="2000" dirty="0"/>
+              <a:t>, which will be demonstrated later in the presentation.</a:t>
+            </a:r>
+          </a:p>
+          <a:p>
+            <a:endParaRPr lang="en-US" sz="2000" dirty="0"/>
+          </a:p>
+          <a:p>
+            <a:r>
+              <a:rPr lang="en-US" sz="2000" b="1" dirty="0"/>
+              <a:t>Accuracy Testing:</a:t>
+            </a:r>
+            <a:r>
+              <a:rPr lang="en-US" sz="2000" dirty="0"/>
+              <a:t> For the final stage, we evaluated the </a:t>
+            </a:r>
+            <a:r>
+              <a:rPr lang="en-US" sz="2000" b="1" dirty="0"/>
+              <a:t>reliability and precision</a:t>
+            </a:r>
+            <a:r>
+              <a:rPr lang="en-US" sz="2000" dirty="0"/>
+              <a:t> of the </a:t>
+            </a:r>
+            <a:r>
+              <a:rPr lang="en-US" sz="2000" b="1" dirty="0"/>
+              <a:t>punch detection</a:t>
+            </a:r>
+            <a:r>
+              <a:rPr lang="en-US" sz="2000" dirty="0"/>
+              <a:t> system.</a:t>
+            </a:r>
+          </a:p>
+          <a:p>
+            <a:endParaRPr lang="de-AT" dirty="0"/>
+          </a:p>
           <a:p>
             <a:endParaRPr lang="de-AT" dirty="0"/>
           </a:p>
@@ -14413,6 +14634,423 @@
         <p:txBody>
           <a:bodyPr/>
           <a:lstStyle/>
+          <a:p>
+            <a:r>
+              <a:rPr lang="de-AT" dirty="0" err="1"/>
+              <a:t>For</a:t>
+            </a:r>
+            <a:r>
+              <a:rPr lang="de-AT" dirty="0"/>
+              <a:t> </a:t>
+            </a:r>
+            <a:r>
+              <a:rPr lang="de-AT" dirty="0" err="1"/>
+              <a:t>the</a:t>
+            </a:r>
+            <a:r>
+              <a:rPr lang="de-AT" dirty="0"/>
+              <a:t> </a:t>
+            </a:r>
+            <a:r>
+              <a:rPr lang="de-AT" dirty="0" err="1"/>
+              <a:t>first</a:t>
+            </a:r>
+            <a:r>
+              <a:rPr lang="de-AT" dirty="0"/>
+              <a:t> </a:t>
+            </a:r>
+            <a:r>
+              <a:rPr lang="de-AT" dirty="0" err="1"/>
+              <a:t>program</a:t>
+            </a:r>
+            <a:r>
+              <a:rPr lang="de-AT" dirty="0"/>
+              <a:t> </a:t>
+            </a:r>
+            <a:r>
+              <a:rPr lang="de-AT" dirty="0" err="1"/>
+              <a:t>we</a:t>
+            </a:r>
+            <a:r>
+              <a:rPr lang="de-AT" dirty="0"/>
+              <a:t> </a:t>
+            </a:r>
+            <a:r>
+              <a:rPr lang="de-AT" dirty="0" err="1"/>
+              <a:t>implemented</a:t>
+            </a:r>
+            <a:r>
+              <a:rPr lang="de-AT" dirty="0"/>
+              <a:t> </a:t>
+            </a:r>
+            <a:r>
+              <a:rPr lang="de-AT" dirty="0" err="1"/>
+              <a:t>the</a:t>
+            </a:r>
+            <a:r>
+              <a:rPr lang="de-AT" dirty="0"/>
+              <a:t> </a:t>
+            </a:r>
+            <a:r>
+              <a:rPr lang="de-AT" dirty="0" err="1"/>
+              <a:t>most</a:t>
+            </a:r>
+            <a:r>
+              <a:rPr lang="de-AT" dirty="0"/>
+              <a:t> </a:t>
+            </a:r>
+            <a:r>
+              <a:rPr lang="de-AT" dirty="0" err="1"/>
+              <a:t>rudimentary</a:t>
+            </a:r>
+            <a:r>
+              <a:rPr lang="de-AT" dirty="0"/>
+              <a:t> </a:t>
+            </a:r>
+            <a:r>
+              <a:rPr lang="de-AT" dirty="0" err="1"/>
+              <a:t>functions</a:t>
+            </a:r>
+            <a:r>
+              <a:rPr lang="de-AT" dirty="0"/>
+              <a:t> </a:t>
+            </a:r>
+            <a:r>
+              <a:rPr lang="de-AT" dirty="0" err="1"/>
+              <a:t>which</a:t>
+            </a:r>
+            <a:r>
+              <a:rPr lang="de-AT" dirty="0"/>
+              <a:t> </a:t>
+            </a:r>
+            <a:r>
+              <a:rPr lang="de-AT" dirty="0" err="1"/>
+              <a:t>were</a:t>
+            </a:r>
+            <a:r>
+              <a:rPr lang="de-AT" dirty="0"/>
+              <a:t> </a:t>
+            </a:r>
+            <a:r>
+              <a:rPr lang="de-AT" dirty="0" err="1"/>
+              <a:t>detection</a:t>
+            </a:r>
+            <a:r>
+              <a:rPr lang="de-AT" dirty="0"/>
+              <a:t> and </a:t>
+            </a:r>
+            <a:r>
+              <a:rPr lang="de-AT" dirty="0" err="1"/>
+              <a:t>data</a:t>
+            </a:r>
+            <a:r>
+              <a:rPr lang="de-AT" dirty="0"/>
+              <a:t> </a:t>
+            </a:r>
+            <a:r>
+              <a:rPr lang="de-AT" dirty="0" err="1"/>
+              <a:t>transmission</a:t>
+            </a:r>
+            <a:r>
+              <a:rPr lang="de-AT" dirty="0"/>
+              <a:t> </a:t>
+            </a:r>
+            <a:r>
+              <a:rPr lang="de-AT" dirty="0" err="1"/>
+              <a:t>to</a:t>
+            </a:r>
+            <a:r>
+              <a:rPr lang="de-AT" dirty="0"/>
+              <a:t> a </a:t>
+            </a:r>
+            <a:r>
+              <a:rPr lang="de-AT" dirty="0" err="1"/>
+              <a:t>client</a:t>
+            </a:r>
+            <a:r>
+              <a:rPr lang="de-AT" dirty="0"/>
+              <a:t> via WiFi.</a:t>
+            </a:r>
+          </a:p>
+          <a:p>
+            <a:endParaRPr lang="de-AT" dirty="0"/>
+          </a:p>
+          <a:p>
+            <a:r>
+              <a:rPr lang="de-AT" dirty="0"/>
+              <a:t>Quick </a:t>
+            </a:r>
+            <a:r>
+              <a:rPr lang="de-AT" dirty="0" err="1"/>
+              <a:t>overview</a:t>
+            </a:r>
+            <a:r>
+              <a:rPr lang="de-AT" dirty="0"/>
+              <a:t> </a:t>
+            </a:r>
+            <a:r>
+              <a:rPr lang="de-AT" dirty="0" err="1"/>
+              <a:t>of</a:t>
+            </a:r>
+            <a:r>
+              <a:rPr lang="de-AT" dirty="0"/>
+              <a:t> </a:t>
+            </a:r>
+            <a:r>
+              <a:rPr lang="de-AT" dirty="0" err="1"/>
+              <a:t>the</a:t>
+            </a:r>
+            <a:r>
+              <a:rPr lang="de-AT" dirty="0"/>
+              <a:t> </a:t>
+            </a:r>
+            <a:r>
+              <a:rPr lang="de-AT" dirty="0" err="1"/>
+              <a:t>mode</a:t>
+            </a:r>
+            <a:r>
+              <a:rPr lang="de-AT" dirty="0"/>
+              <a:t> </a:t>
+            </a:r>
+            <a:r>
+              <a:rPr lang="de-AT" dirty="0" err="1"/>
+              <a:t>of</a:t>
+            </a:r>
+            <a:r>
+              <a:rPr lang="de-AT" dirty="0"/>
+              <a:t> </a:t>
+            </a:r>
+            <a:r>
+              <a:rPr lang="de-AT" dirty="0" err="1"/>
+              <a:t>operation</a:t>
+            </a:r>
+            <a:r>
+              <a:rPr lang="de-AT" dirty="0"/>
+              <a:t>.</a:t>
+            </a:r>
+          </a:p>
+          <a:p>
+            <a:pPr marL="171450" indent="-171450">
+              <a:buFont typeface="Arial" panose="020B0604020202020204" pitchFamily="34" charset="0"/>
+              <a:buChar char="•"/>
+            </a:pPr>
+            <a:r>
+              <a:rPr lang="de-AT" dirty="0"/>
+              <a:t>Read IMU</a:t>
+            </a:r>
+          </a:p>
+          <a:p>
+            <a:pPr marL="171450" indent="-171450">
+              <a:buFont typeface="Arial" panose="020B0604020202020204" pitchFamily="34" charset="0"/>
+              <a:buChar char="•"/>
+            </a:pPr>
+            <a:r>
+              <a:rPr lang="de-AT" dirty="0"/>
+              <a:t>Hand </a:t>
+            </a:r>
+            <a:r>
+              <a:rPr lang="de-AT" dirty="0" err="1"/>
+              <a:t>over</a:t>
+            </a:r>
+            <a:r>
+              <a:rPr lang="de-AT" dirty="0"/>
+              <a:t> </a:t>
+            </a:r>
+            <a:r>
+              <a:rPr lang="de-AT" dirty="0" err="1"/>
+              <a:t>to</a:t>
+            </a:r>
+            <a:r>
+              <a:rPr lang="de-AT" dirty="0"/>
+              <a:t> </a:t>
+            </a:r>
+            <a:r>
+              <a:rPr lang="de-AT" dirty="0" err="1"/>
+              <a:t>the</a:t>
+            </a:r>
+            <a:r>
+              <a:rPr lang="de-AT" dirty="0"/>
+              <a:t> </a:t>
+            </a:r>
+            <a:r>
+              <a:rPr lang="de-AT" dirty="0" err="1"/>
+              <a:t>model</a:t>
+            </a:r>
+            <a:endParaRPr lang="de-AT" dirty="0"/>
+          </a:p>
+          <a:p>
+            <a:pPr marL="171450" indent="-171450">
+              <a:buFont typeface="Arial" panose="020B0604020202020204" pitchFamily="34" charset="0"/>
+              <a:buChar char="•"/>
+            </a:pPr>
+            <a:r>
+              <a:rPr lang="de-AT" dirty="0" err="1"/>
+              <a:t>Decision</a:t>
+            </a:r>
+            <a:r>
+              <a:rPr lang="de-AT" dirty="0"/>
+              <a:t> </a:t>
+            </a:r>
+            <a:r>
+              <a:rPr lang="de-AT" dirty="0" err="1"/>
+              <a:t>logic</a:t>
+            </a:r>
+            <a:r>
+              <a:rPr lang="de-AT" dirty="0"/>
+              <a:t> </a:t>
+            </a:r>
+            <a:r>
+              <a:rPr lang="de-AT" dirty="0" err="1"/>
+              <a:t>probability</a:t>
+            </a:r>
+            <a:r>
+              <a:rPr lang="de-AT" dirty="0"/>
+              <a:t> </a:t>
+            </a:r>
+            <a:r>
+              <a:rPr lang="de-AT" dirty="0" err="1"/>
+              <a:t>had</a:t>
+            </a:r>
+            <a:r>
+              <a:rPr lang="de-AT" dirty="0"/>
+              <a:t> </a:t>
+            </a:r>
+            <a:r>
+              <a:rPr lang="de-AT" dirty="0" err="1"/>
+              <a:t>to</a:t>
+            </a:r>
+            <a:r>
+              <a:rPr lang="de-AT" dirty="0"/>
+              <a:t> </a:t>
+            </a:r>
+            <a:r>
+              <a:rPr lang="de-AT" dirty="0" err="1"/>
+              <a:t>surpass</a:t>
+            </a:r>
+            <a:r>
+              <a:rPr lang="de-AT" dirty="0"/>
+              <a:t> </a:t>
+            </a:r>
+            <a:r>
+              <a:rPr lang="de-AT" dirty="0" err="1"/>
+              <a:t>threshhold</a:t>
+            </a:r>
+            <a:r>
+              <a:rPr lang="de-AT" dirty="0"/>
+              <a:t> </a:t>
+            </a:r>
+            <a:r>
+              <a:rPr lang="de-AT" dirty="0" err="1"/>
+              <a:t>of</a:t>
+            </a:r>
+            <a:r>
+              <a:rPr lang="de-AT" dirty="0"/>
+              <a:t> 60% </a:t>
+            </a:r>
+            <a:r>
+              <a:rPr lang="de-AT" dirty="0" err="1"/>
+              <a:t>to</a:t>
+            </a:r>
+            <a:r>
+              <a:rPr lang="de-AT" dirty="0"/>
+              <a:t> </a:t>
+            </a:r>
+            <a:r>
+              <a:rPr lang="de-AT" dirty="0" err="1"/>
+              <a:t>be</a:t>
+            </a:r>
+            <a:r>
+              <a:rPr lang="de-AT" dirty="0"/>
+              <a:t> </a:t>
+            </a:r>
+            <a:r>
+              <a:rPr lang="de-AT" dirty="0" err="1"/>
+              <a:t>counted</a:t>
+            </a:r>
+            <a:r>
+              <a:rPr lang="de-AT" dirty="0"/>
+              <a:t> </a:t>
+            </a:r>
+            <a:r>
+              <a:rPr lang="de-AT" dirty="0" err="1"/>
+              <a:t>as</a:t>
+            </a:r>
+            <a:r>
+              <a:rPr lang="de-AT" dirty="0"/>
+              <a:t> a </a:t>
+            </a:r>
+            <a:r>
+              <a:rPr lang="de-AT" dirty="0" err="1"/>
+              <a:t>punch</a:t>
+            </a:r>
+            <a:endParaRPr lang="de-AT" dirty="0"/>
+          </a:p>
+          <a:p>
+            <a:pPr marL="171450" indent="-171450">
+              <a:buFont typeface="Arial" panose="020B0604020202020204" pitchFamily="34" charset="0"/>
+              <a:buChar char="•"/>
+            </a:pPr>
+            <a:r>
+              <a:rPr lang="de-AT" dirty="0"/>
+              <a:t>Last but not least </a:t>
+            </a:r>
+            <a:r>
+              <a:rPr lang="de-AT" dirty="0" err="1"/>
+              <a:t>transmission</a:t>
+            </a:r>
+            <a:r>
+              <a:rPr lang="de-AT" dirty="0"/>
+              <a:t> </a:t>
+            </a:r>
+            <a:r>
+              <a:rPr lang="de-AT" dirty="0" err="1"/>
+              <a:t>of</a:t>
+            </a:r>
+            <a:r>
+              <a:rPr lang="de-AT" dirty="0"/>
+              <a:t> </a:t>
+            </a:r>
+            <a:r>
+              <a:rPr lang="de-AT" dirty="0" err="1"/>
+              <a:t>result</a:t>
+            </a:r>
+            <a:r>
+              <a:rPr lang="de-AT" dirty="0"/>
+              <a:t> </a:t>
+            </a:r>
+            <a:r>
+              <a:rPr lang="de-AT" dirty="0" err="1"/>
+              <a:t>to</a:t>
+            </a:r>
+            <a:r>
+              <a:rPr lang="de-AT" dirty="0"/>
+              <a:t> </a:t>
+            </a:r>
+            <a:r>
+              <a:rPr lang="de-AT" dirty="0" err="1"/>
+              <a:t>client</a:t>
+            </a:r>
+            <a:r>
+              <a:rPr lang="de-AT" dirty="0"/>
+              <a:t> (</a:t>
+            </a:r>
+            <a:r>
+              <a:rPr lang="de-AT" dirty="0" err="1"/>
+              <a:t>Tera</a:t>
+            </a:r>
+            <a:r>
+              <a:rPr lang="de-AT" dirty="0"/>
+              <a:t> Term) Connection </a:t>
+            </a:r>
+            <a:r>
+              <a:rPr lang="de-AT" dirty="0" err="1"/>
+              <a:t>with</a:t>
+            </a:r>
+            <a:r>
+              <a:rPr lang="de-AT" dirty="0"/>
+              <a:t> TCP/IP</a:t>
+            </a:r>
+          </a:p>
           <a:p>
             <a:endParaRPr lang="de-AT" dirty="0"/>
           </a:p>
@@ -23562,11 +24200,12 @@
 </file>
 
 <file path=customXml/item1.xml><?xml version="1.0" encoding="utf-8"?>
-<p:properties xmlns:p="http://schemas.microsoft.com/office/2006/metadata/properties" xmlns:xsi="http://www.w3.org/2001/XMLSchema-instance" xmlns:pc="http://schemas.microsoft.com/office/infopath/2007/PartnerControls">
-  <documentManagement>
-    <_activity xmlns="bf1a47b5-10f0-4178-af4a-bbe7cc4004c3" xsi:nil="true"/>
-  </documentManagement>
-</p:properties>
+<?mso-contentType ?>
+<FormTemplates xmlns="http://schemas.microsoft.com/sharepoint/v3/contenttype/forms">
+  <Display>DocumentLibraryForm</Display>
+  <Edit>DocumentLibraryForm</Edit>
+  <New>DocumentLibraryForm</New>
+</FormTemplates>
 </file>
 
 <file path=customXml/item2.xml><?xml version="1.0" encoding="utf-8"?>
@@ -23758,26 +24397,17 @@
 </file>
 
 <file path=customXml/item3.xml><?xml version="1.0" encoding="utf-8"?>
-<?mso-contentType ?>
-<FormTemplates xmlns="http://schemas.microsoft.com/sharepoint/v3/contenttype/forms">
-  <Display>DocumentLibraryForm</Display>
-  <Edit>DocumentLibraryForm</Edit>
-  <New>DocumentLibraryForm</New>
-</FormTemplates>
+<p:properties xmlns:p="http://schemas.microsoft.com/office/2006/metadata/properties" xmlns:xsi="http://www.w3.org/2001/XMLSchema-instance" xmlns:pc="http://schemas.microsoft.com/office/infopath/2007/PartnerControls">
+  <documentManagement>
+    <_activity xmlns="bf1a47b5-10f0-4178-af4a-bbe7cc4004c3" xsi:nil="true"/>
+  </documentManagement>
+</p:properties>
 </file>
 
 <file path=customXml/itemProps1.xml><?xml version="1.0" encoding="utf-8"?>
-<ds:datastoreItem xmlns:ds="http://schemas.openxmlformats.org/officeDocument/2006/customXml" ds:itemID="{2C2A40F2-5398-4DE1-A8FC-C0BA56DCE4EA}">
+<ds:datastoreItem xmlns:ds="http://schemas.openxmlformats.org/officeDocument/2006/customXml" ds:itemID="{D12945CB-A677-4013-820C-0AEFE2C4DC48}">
   <ds:schemaRefs>
-    <ds:schemaRef ds:uri="bf1a47b5-10f0-4178-af4a-bbe7cc4004c3"/>
-    <ds:schemaRef ds:uri="http://purl.org/dc/terms/"/>
-    <ds:schemaRef ds:uri="http://schemas.microsoft.com/office/infopath/2007/PartnerControls"/>
-    <ds:schemaRef ds:uri="http://schemas.openxmlformats.org/package/2006/metadata/core-properties"/>
-    <ds:schemaRef ds:uri="http://purl.org/dc/elements/1.1/"/>
-    <ds:schemaRef ds:uri="http://schemas.microsoft.com/office/2006/documentManagement/types"/>
-    <ds:schemaRef ds:uri="http://www.w3.org/XML/1998/namespace"/>
-    <ds:schemaRef ds:uri="http://purl.org/dc/dcmitype/"/>
-    <ds:schemaRef ds:uri="http://schemas.microsoft.com/office/2006/metadata/properties"/>
+    <ds:schemaRef ds:uri="http://schemas.microsoft.com/sharepoint/v3/contenttype/forms"/>
   </ds:schemaRefs>
 </ds:datastoreItem>
 </file>
@@ -23801,9 +24431,17 @@
 </file>
 
 <file path=customXml/itemProps3.xml><?xml version="1.0" encoding="utf-8"?>
-<ds:datastoreItem xmlns:ds="http://schemas.openxmlformats.org/officeDocument/2006/customXml" ds:itemID="{D12945CB-A677-4013-820C-0AEFE2C4DC48}">
+<ds:datastoreItem xmlns:ds="http://schemas.openxmlformats.org/officeDocument/2006/customXml" ds:itemID="{2C2A40F2-5398-4DE1-A8FC-C0BA56DCE4EA}">
   <ds:schemaRefs>
-    <ds:schemaRef ds:uri="http://schemas.microsoft.com/sharepoint/v3/contenttype/forms"/>
+    <ds:schemaRef ds:uri="bf1a47b5-10f0-4178-af4a-bbe7cc4004c3"/>
+    <ds:schemaRef ds:uri="http://purl.org/dc/terms/"/>
+    <ds:schemaRef ds:uri="http://schemas.microsoft.com/office/infopath/2007/PartnerControls"/>
+    <ds:schemaRef ds:uri="http://schemas.openxmlformats.org/package/2006/metadata/core-properties"/>
+    <ds:schemaRef ds:uri="http://purl.org/dc/elements/1.1/"/>
+    <ds:schemaRef ds:uri="http://schemas.microsoft.com/office/2006/documentManagement/types"/>
+    <ds:schemaRef ds:uri="http://www.w3.org/XML/1998/namespace"/>
+    <ds:schemaRef ds:uri="http://purl.org/dc/dcmitype/"/>
+    <ds:schemaRef ds:uri="http://schemas.microsoft.com/office/2006/metadata/properties"/>
   </ds:schemaRefs>
 </ds:datastoreItem>
 </file>
</xml_diff>